<commit_message>
Other Viz and slide updates
</commit_message>
<xml_diff>
--- a/slides/R_Data_Wrangling_and_Visualization.pptx
+++ b/slides/R_Data_Wrangling_and_Visualization.pptx
@@ -6,29 +6,25 @@
     <p:sldMasterId id="2147483661" r:id="rId2"/>
   </p:sldMasterIdLst>
   <p:notesMasterIdLst>
-    <p:notesMasterId r:id="rId23"/>
+    <p:notesMasterId r:id="rId19"/>
   </p:notesMasterIdLst>
   <p:sldIdLst>
     <p:sldId id="299" r:id="rId3"/>
     <p:sldId id="376" r:id="rId4"/>
     <p:sldId id="272" r:id="rId5"/>
     <p:sldId id="374" r:id="rId6"/>
-    <p:sldId id="273" r:id="rId7"/>
-    <p:sldId id="271" r:id="rId8"/>
-    <p:sldId id="375" r:id="rId9"/>
-    <p:sldId id="377" r:id="rId10"/>
-    <p:sldId id="378" r:id="rId11"/>
-    <p:sldId id="321" r:id="rId12"/>
-    <p:sldId id="379" r:id="rId13"/>
-    <p:sldId id="322" r:id="rId14"/>
-    <p:sldId id="266" r:id="rId15"/>
-    <p:sldId id="300" r:id="rId16"/>
-    <p:sldId id="296" r:id="rId17"/>
-    <p:sldId id="373" r:id="rId18"/>
-    <p:sldId id="372" r:id="rId19"/>
-    <p:sldId id="262" r:id="rId20"/>
-    <p:sldId id="325" r:id="rId21"/>
-    <p:sldId id="368" r:id="rId22"/>
+    <p:sldId id="271" r:id="rId7"/>
+    <p:sldId id="375" r:id="rId8"/>
+    <p:sldId id="377" r:id="rId9"/>
+    <p:sldId id="378" r:id="rId10"/>
+    <p:sldId id="321" r:id="rId11"/>
+    <p:sldId id="372" r:id="rId12"/>
+    <p:sldId id="273" r:id="rId13"/>
+    <p:sldId id="296" r:id="rId14"/>
+    <p:sldId id="373" r:id="rId15"/>
+    <p:sldId id="262" r:id="rId16"/>
+    <p:sldId id="325" r:id="rId17"/>
+    <p:sldId id="368" r:id="rId18"/>
   </p:sldIdLst>
   <p:sldSz cx="12192000" cy="6858000"/>
   <p:notesSz cx="6858000" cy="9144000"/>
@@ -144,7 +140,7 @@
 <file path=ppt/revisionInfo.xml><?xml version="1.0" encoding="utf-8"?>
 <p1510:revInfo xmlns:a="http://schemas.openxmlformats.org/drawingml/2006/main" xmlns:r="http://schemas.openxmlformats.org/officeDocument/2006/relationships" xmlns:p1510="http://schemas.microsoft.com/office/powerpoint/2015/10/main">
   <p1510:revLst>
-    <p1510:client id="{F35A9B08-6B64-4261-AD91-5F59BA8C75C2}" v="938" dt="2026-03-17T18:12:15.488"/>
+    <p1510:client id="{F35A9B08-6B64-4261-AD91-5F59BA8C75C2}" v="1387" dt="2026-03-17T18:35:30.164"/>
   </p1510:revLst>
 </p1510:revInfo>
 </file>
@@ -154,7 +150,7 @@
   <pc:docChgLst>
     <pc:chgData name="Katie Owers Bonner" userId="031be739-2ca3-49bb-9134-32c5274b029d" providerId="ADAL" clId="{A2AFF3C0-B35D-4D35-896C-645D8DA4EEB0}"/>
     <pc:docChg chg="undo custSel addSld delSld modSld sldOrd">
-      <pc:chgData name="Katie Owers Bonner" userId="031be739-2ca3-49bb-9134-32c5274b029d" providerId="ADAL" clId="{A2AFF3C0-B35D-4D35-896C-645D8DA4EEB0}" dt="2026-03-17T18:17:09.056" v="1591"/>
+      <pc:chgData name="Katie Owers Bonner" userId="031be739-2ca3-49bb-9134-32c5274b029d" providerId="ADAL" clId="{A2AFF3C0-B35D-4D35-896C-645D8DA4EEB0}" dt="2026-03-17T18:35:30.164" v="2053" actId="313"/>
       <pc:docMkLst>
         <pc:docMk/>
       </pc:docMkLst>
@@ -173,14 +169,21 @@
           </ac:picMkLst>
         </pc:picChg>
       </pc:sldChg>
+      <pc:sldChg chg="del">
+        <pc:chgData name="Katie Owers Bonner" userId="031be739-2ca3-49bb-9134-32c5274b029d" providerId="ADAL" clId="{A2AFF3C0-B35D-4D35-896C-645D8DA4EEB0}" dt="2026-03-17T18:29:14.382" v="1602" actId="47"/>
+        <pc:sldMkLst>
+          <pc:docMk/>
+          <pc:sldMk cId="2372691659" sldId="266"/>
+        </pc:sldMkLst>
+      </pc:sldChg>
       <pc:sldChg chg="modSp mod">
-        <pc:chgData name="Katie Owers Bonner" userId="031be739-2ca3-49bb-9134-32c5274b029d" providerId="ADAL" clId="{A2AFF3C0-B35D-4D35-896C-645D8DA4EEB0}" dt="2026-03-17T14:55:24.276" v="423" actId="20577"/>
+        <pc:chgData name="Katie Owers Bonner" userId="031be739-2ca3-49bb-9134-32c5274b029d" providerId="ADAL" clId="{A2AFF3C0-B35D-4D35-896C-645D8DA4EEB0}" dt="2026-03-17T18:35:17.488" v="2052" actId="13926"/>
         <pc:sldMkLst>
           <pc:docMk/>
           <pc:sldMk cId="1346459711" sldId="271"/>
         </pc:sldMkLst>
         <pc:spChg chg="mod">
-          <ac:chgData name="Katie Owers Bonner" userId="031be739-2ca3-49bb-9134-32c5274b029d" providerId="ADAL" clId="{A2AFF3C0-B35D-4D35-896C-645D8DA4EEB0}" dt="2026-03-17T14:55:24.276" v="423" actId="20577"/>
+          <ac:chgData name="Katie Owers Bonner" userId="031be739-2ca3-49bb-9134-32c5274b029d" providerId="ADAL" clId="{A2AFF3C0-B35D-4D35-896C-645D8DA4EEB0}" dt="2026-03-17T18:35:17.488" v="2052" actId="13926"/>
           <ac:spMkLst>
             <pc:docMk/>
             <pc:sldMk cId="1346459711" sldId="271"/>
@@ -211,8 +214,15 @@
           </ac:spMkLst>
         </pc:spChg>
       </pc:sldChg>
-      <pc:sldChg chg="modSp mod ord">
-        <pc:chgData name="Katie Owers Bonner" userId="031be739-2ca3-49bb-9134-32c5274b029d" providerId="ADAL" clId="{A2AFF3C0-B35D-4D35-896C-645D8DA4EEB0}" dt="2026-03-17T18:17:09.056" v="1591"/>
+      <pc:sldChg chg="add">
+        <pc:chgData name="Katie Owers Bonner" userId="031be739-2ca3-49bb-9134-32c5274b029d" providerId="ADAL" clId="{A2AFF3C0-B35D-4D35-896C-645D8DA4EEB0}" dt="2026-03-17T18:29:29.514" v="1604"/>
+        <pc:sldMkLst>
+          <pc:docMk/>
+          <pc:sldMk cId="713113970" sldId="273"/>
+        </pc:sldMkLst>
+      </pc:sldChg>
+      <pc:sldChg chg="modSp del mod ord">
+        <pc:chgData name="Katie Owers Bonner" userId="031be739-2ca3-49bb-9134-32c5274b029d" providerId="ADAL" clId="{A2AFF3C0-B35D-4D35-896C-645D8DA4EEB0}" dt="2026-03-17T18:29:25.328" v="1603" actId="2696"/>
         <pc:sldMkLst>
           <pc:docMk/>
           <pc:sldMk cId="1227487870" sldId="273"/>
@@ -225,6 +235,13 @@
             <ac:spMk id="142" creationId="{9B72596A-D557-1CA0-4098-0B9E3210C40F}"/>
           </ac:spMkLst>
         </pc:spChg>
+      </pc:sldChg>
+      <pc:sldChg chg="ord">
+        <pc:chgData name="Katie Owers Bonner" userId="031be739-2ca3-49bb-9134-32c5274b029d" providerId="ADAL" clId="{A2AFF3C0-B35D-4D35-896C-645D8DA4EEB0}" dt="2026-03-17T18:29:10.728" v="1601"/>
+        <pc:sldMkLst>
+          <pc:docMk/>
+          <pc:sldMk cId="536404643" sldId="296"/>
+        </pc:sldMkLst>
       </pc:sldChg>
       <pc:sldChg chg="addSp delSp modSp mod">
         <pc:chgData name="Katie Owers Bonner" userId="031be739-2ca3-49bb-9134-32c5274b029d" providerId="ADAL" clId="{A2AFF3C0-B35D-4D35-896C-645D8DA4EEB0}" dt="2026-03-17T18:16:18.611" v="1585" actId="403"/>
@@ -265,6 +282,13 @@
           </ac:spMkLst>
         </pc:spChg>
       </pc:sldChg>
+      <pc:sldChg chg="del">
+        <pc:chgData name="Katie Owers Bonner" userId="031be739-2ca3-49bb-9134-32c5274b029d" providerId="ADAL" clId="{A2AFF3C0-B35D-4D35-896C-645D8DA4EEB0}" dt="2026-03-17T18:29:14.382" v="1602" actId="47"/>
+        <pc:sldMkLst>
+          <pc:docMk/>
+          <pc:sldMk cId="3594546687" sldId="300"/>
+        </pc:sldMkLst>
+      </pc:sldChg>
       <pc:sldChg chg="addSp modSp mod modNotesTx">
         <pc:chgData name="Katie Owers Bonner" userId="031be739-2ca3-49bb-9134-32c5274b029d" providerId="ADAL" clId="{A2AFF3C0-B35D-4D35-896C-645D8DA4EEB0}" dt="2026-03-17T18:12:46.612" v="1583" actId="20577"/>
         <pc:sldMkLst>
@@ -288,6 +312,28 @@
           </ac:spMkLst>
         </pc:spChg>
       </pc:sldChg>
+      <pc:sldChg chg="del">
+        <pc:chgData name="Katie Owers Bonner" userId="031be739-2ca3-49bb-9134-32c5274b029d" providerId="ADAL" clId="{A2AFF3C0-B35D-4D35-896C-645D8DA4EEB0}" dt="2026-03-17T18:29:14.382" v="1602" actId="47"/>
+        <pc:sldMkLst>
+          <pc:docMk/>
+          <pc:sldMk cId="2972185394" sldId="322"/>
+        </pc:sldMkLst>
+      </pc:sldChg>
+      <pc:sldChg chg="modSp mod ord">
+        <pc:chgData name="Katie Owers Bonner" userId="031be739-2ca3-49bb-9134-32c5274b029d" providerId="ADAL" clId="{A2AFF3C0-B35D-4D35-896C-645D8DA4EEB0}" dt="2026-03-17T18:28:59.296" v="1599" actId="20577"/>
+        <pc:sldMkLst>
+          <pc:docMk/>
+          <pc:sldMk cId="825263348" sldId="372"/>
+        </pc:sldMkLst>
+        <pc:spChg chg="mod">
+          <ac:chgData name="Katie Owers Bonner" userId="031be739-2ca3-49bb-9134-32c5274b029d" providerId="ADAL" clId="{A2AFF3C0-B35D-4D35-896C-645D8DA4EEB0}" dt="2026-03-17T18:28:59.296" v="1599" actId="20577"/>
+          <ac:spMkLst>
+            <pc:docMk/>
+            <pc:sldMk cId="825263348" sldId="372"/>
+            <ac:spMk id="134" creationId="{64477353-763A-15A6-FAA3-7320FC3B4337}"/>
+          </ac:spMkLst>
+        </pc:spChg>
+      </pc:sldChg>
       <pc:sldChg chg="modSp mod">
         <pc:chgData name="Katie Owers Bonner" userId="031be739-2ca3-49bb-9134-32c5274b029d" providerId="ADAL" clId="{A2AFF3C0-B35D-4D35-896C-645D8DA4EEB0}" dt="2026-03-17T14:53:19.348" v="371" actId="6549"/>
         <pc:sldMkLst>
@@ -303,8 +349,8 @@
           </ac:spMkLst>
         </pc:spChg>
       </pc:sldChg>
-      <pc:sldChg chg="modSp add mod ord">
-        <pc:chgData name="Katie Owers Bonner" userId="031be739-2ca3-49bb-9134-32c5274b029d" providerId="ADAL" clId="{A2AFF3C0-B35D-4D35-896C-645D8DA4EEB0}" dt="2026-03-17T18:17:06.677" v="1589"/>
+      <pc:sldChg chg="modSp add mod ord modAnim">
+        <pc:chgData name="Katie Owers Bonner" userId="031be739-2ca3-49bb-9134-32c5274b029d" providerId="ADAL" clId="{A2AFF3C0-B35D-4D35-896C-645D8DA4EEB0}" dt="2026-03-17T18:35:02.394" v="2051" actId="6549"/>
         <pc:sldMkLst>
           <pc:docMk/>
           <pc:sldMk cId="2108451283" sldId="374"/>
@@ -318,7 +364,7 @@
           </ac:spMkLst>
         </pc:spChg>
         <pc:spChg chg="mod">
-          <ac:chgData name="Katie Owers Bonner" userId="031be739-2ca3-49bb-9134-32c5274b029d" providerId="ADAL" clId="{A2AFF3C0-B35D-4D35-896C-645D8DA4EEB0}" dt="2026-03-17T14:55:08.770" v="398"/>
+          <ac:chgData name="Katie Owers Bonner" userId="031be739-2ca3-49bb-9134-32c5274b029d" providerId="ADAL" clId="{A2AFF3C0-B35D-4D35-896C-645D8DA4EEB0}" dt="2026-03-17T18:35:02.394" v="2051" actId="6549"/>
           <ac:spMkLst>
             <pc:docMk/>
             <pc:sldMk cId="2108451283" sldId="374"/>
@@ -380,7 +426,7 @@
         </pc:spChg>
       </pc:sldChg>
       <pc:sldChg chg="modSp add mod modAnim">
-        <pc:chgData name="Katie Owers Bonner" userId="031be739-2ca3-49bb-9134-32c5274b029d" providerId="ADAL" clId="{A2AFF3C0-B35D-4D35-896C-645D8DA4EEB0}" dt="2026-03-17T18:03:39.622" v="1451" actId="13926"/>
+        <pc:chgData name="Katie Owers Bonner" userId="031be739-2ca3-49bb-9134-32c5274b029d" providerId="ADAL" clId="{A2AFF3C0-B35D-4D35-896C-645D8DA4EEB0}" dt="2026-03-17T18:35:30.164" v="2053" actId="313"/>
         <pc:sldMkLst>
           <pc:docMk/>
           <pc:sldMk cId="1945847000" sldId="377"/>
@@ -394,7 +440,7 @@
           </ac:spMkLst>
         </pc:spChg>
         <pc:spChg chg="mod">
-          <ac:chgData name="Katie Owers Bonner" userId="031be739-2ca3-49bb-9134-32c5274b029d" providerId="ADAL" clId="{A2AFF3C0-B35D-4D35-896C-645D8DA4EEB0}" dt="2026-03-17T18:03:39.622" v="1451" actId="13926"/>
+          <ac:chgData name="Katie Owers Bonner" userId="031be739-2ca3-49bb-9134-32c5274b029d" providerId="ADAL" clId="{A2AFF3C0-B35D-4D35-896C-645D8DA4EEB0}" dt="2026-03-17T18:35:30.164" v="2053" actId="313"/>
           <ac:spMkLst>
             <pc:docMk/>
             <pc:sldMk cId="1945847000" sldId="377"/>
@@ -425,8 +471,8 @@
           </ac:spMkLst>
         </pc:spChg>
       </pc:sldChg>
-      <pc:sldChg chg="add">
-        <pc:chgData name="Katie Owers Bonner" userId="031be739-2ca3-49bb-9134-32c5274b029d" providerId="ADAL" clId="{A2AFF3C0-B35D-4D35-896C-645D8DA4EEB0}" dt="2026-03-17T18:11:56.274" v="1525"/>
+      <pc:sldChg chg="add del">
+        <pc:chgData name="Katie Owers Bonner" userId="031be739-2ca3-49bb-9134-32c5274b029d" providerId="ADAL" clId="{A2AFF3C0-B35D-4D35-896C-645D8DA4EEB0}" dt="2026-03-17T18:29:14.382" v="1602" actId="47"/>
         <pc:sldMkLst>
           <pc:docMk/>
           <pc:sldMk cId="3264595192" sldId="379"/>
@@ -926,268 +972,10 @@
   <p:cSld>
     <p:spTree>
       <p:nvGrpSpPr>
-        <p:cNvPr id="1" name="Shape 154">
-          <a:extLst>
-            <a:ext uri="{FF2B5EF4-FFF2-40B4-BE49-F238E27FC236}">
-              <a16:creationId xmlns:a16="http://schemas.microsoft.com/office/drawing/2014/main" id="{2BA011E6-134D-151C-AD28-4AA22971D43C}"/>
-            </a:ext>
-          </a:extLst>
-        </p:cNvPr>
-        <p:cNvGrpSpPr/>
-        <p:nvPr/>
-      </p:nvGrpSpPr>
-      <p:grpSpPr>
-        <a:xfrm>
-          <a:off x="0" y="0"/>
-          <a:ext cx="0" cy="0"/>
-          <a:chOff x="0" y="0"/>
-          <a:chExt cx="0" cy="0"/>
-        </a:xfrm>
-      </p:grpSpPr>
-      <p:sp>
-        <p:nvSpPr>
-          <p:cNvPr id="155" name="Google Shape;155;p3:notes">
-            <a:extLst>
-              <a:ext uri="{FF2B5EF4-FFF2-40B4-BE49-F238E27FC236}">
-                <a16:creationId xmlns:a16="http://schemas.microsoft.com/office/drawing/2014/main" id="{4EFC36F4-02D7-B6FE-07B6-86360A78807D}"/>
-              </a:ext>
-            </a:extLst>
-          </p:cNvPr>
-          <p:cNvSpPr txBox="1">
-            <a:spLocks noGrp="1"/>
-          </p:cNvSpPr>
-          <p:nvPr>
-            <p:ph type="body" idx="1"/>
-          </p:nvPr>
-        </p:nvSpPr>
-        <p:spPr>
-          <a:xfrm>
-            <a:off x="685800" y="4400550"/>
-            <a:ext cx="5486400" cy="3600450"/>
-          </a:xfrm>
-          <a:prstGeom prst="rect">
-            <a:avLst/>
-          </a:prstGeom>
-        </p:spPr>
-        <p:txBody>
-          <a:bodyPr spcFirstLastPara="1" wrap="square" lIns="91425" tIns="45700" rIns="91425" bIns="45700" anchor="t" anchorCtr="0">
-            <a:noAutofit/>
-          </a:bodyPr>
-          <a:lstStyle/>
-          <a:p>
-            <a:pPr marL="0" lvl="0" indent="0" algn="l" rtl="0">
-              <a:spcBef>
-                <a:spcPts val="0"/>
-              </a:spcBef>
-              <a:spcAft>
-                <a:spcPts val="0"/>
-              </a:spcAft>
-              <a:buNone/>
-            </a:pPr>
-            <a:endParaRPr dirty="0"/>
-          </a:p>
-        </p:txBody>
-      </p:sp>
-      <p:sp>
-        <p:nvSpPr>
-          <p:cNvPr id="156" name="Google Shape;156;p3:notes">
-            <a:extLst>
-              <a:ext uri="{FF2B5EF4-FFF2-40B4-BE49-F238E27FC236}">
-                <a16:creationId xmlns:a16="http://schemas.microsoft.com/office/drawing/2014/main" id="{236D2ACB-930C-5EAA-9C08-7FC1B2632362}"/>
-              </a:ext>
-            </a:extLst>
-          </p:cNvPr>
-          <p:cNvSpPr>
-            <a:spLocks noGrp="1" noRot="1" noChangeAspect="1"/>
-          </p:cNvSpPr>
-          <p:nvPr>
-            <p:ph type="sldImg" idx="2"/>
-          </p:nvPr>
-        </p:nvSpPr>
-        <p:spPr>
-          <a:xfrm>
-            <a:off x="685800" y="1143000"/>
-            <a:ext cx="5486400" cy="3086100"/>
-          </a:xfrm>
-          <a:custGeom>
-            <a:avLst/>
-            <a:gdLst/>
-            <a:ahLst/>
-            <a:cxnLst/>
-            <a:rect l="l" t="t" r="r" b="b"/>
-            <a:pathLst>
-              <a:path w="120000" h="120000" extrusionOk="0">
-                <a:moveTo>
-                  <a:pt x="0" y="0"/>
-                </a:moveTo>
-                <a:lnTo>
-                  <a:pt x="120000" y="0"/>
-                </a:lnTo>
-                <a:lnTo>
-                  <a:pt x="120000" y="120000"/>
-                </a:lnTo>
-                <a:lnTo>
-                  <a:pt x="0" y="120000"/>
-                </a:lnTo>
-                <a:close/>
-              </a:path>
-            </a:pathLst>
-          </a:custGeom>
-        </p:spPr>
-      </p:sp>
-    </p:spTree>
-    <p:extLst>
-      <p:ext uri="{BB962C8B-B14F-4D97-AF65-F5344CB8AC3E}">
-        <p14:creationId xmlns:p14="http://schemas.microsoft.com/office/powerpoint/2010/main" val="1740453337"/>
-      </p:ext>
-    </p:extLst>
-  </p:cSld>
-  <p:clrMapOvr>
-    <a:masterClrMapping/>
-  </p:clrMapOvr>
-</p:notes>
-</file>
-
-<file path=ppt/notesSlides/notesSlide11.xml><?xml version="1.0" encoding="utf-8"?>
-<p:notes xmlns:a="http://schemas.openxmlformats.org/drawingml/2006/main" xmlns:r="http://schemas.openxmlformats.org/officeDocument/2006/relationships" xmlns:p="http://schemas.openxmlformats.org/presentationml/2006/main" showMasterSp="0" showMasterPhAnim="0">
-  <p:cSld>
-    <p:spTree>
-      <p:nvGrpSpPr>
-        <p:cNvPr id="1" name="Shape 154">
-          <a:extLst>
-            <a:ext uri="{FF2B5EF4-FFF2-40B4-BE49-F238E27FC236}">
-              <a16:creationId xmlns:a16="http://schemas.microsoft.com/office/drawing/2014/main" id="{14B41C86-D38C-94DC-516B-25940883E4C4}"/>
-            </a:ext>
-          </a:extLst>
-        </p:cNvPr>
-        <p:cNvGrpSpPr/>
-        <p:nvPr/>
-      </p:nvGrpSpPr>
-      <p:grpSpPr>
-        <a:xfrm>
-          <a:off x="0" y="0"/>
-          <a:ext cx="0" cy="0"/>
-          <a:chOff x="0" y="0"/>
-          <a:chExt cx="0" cy="0"/>
-        </a:xfrm>
-      </p:grpSpPr>
-      <p:sp>
-        <p:nvSpPr>
-          <p:cNvPr id="155" name="Google Shape;155;p3:notes">
-            <a:extLst>
-              <a:ext uri="{FF2B5EF4-FFF2-40B4-BE49-F238E27FC236}">
-                <a16:creationId xmlns:a16="http://schemas.microsoft.com/office/drawing/2014/main" id="{78AC0E3F-C516-2FFA-520F-A918410D516F}"/>
-              </a:ext>
-            </a:extLst>
-          </p:cNvPr>
-          <p:cNvSpPr txBox="1">
-            <a:spLocks noGrp="1"/>
-          </p:cNvSpPr>
-          <p:nvPr>
-            <p:ph type="body" idx="1"/>
-          </p:nvPr>
-        </p:nvSpPr>
-        <p:spPr>
-          <a:xfrm>
-            <a:off x="685800" y="4400550"/>
-            <a:ext cx="5486400" cy="3600450"/>
-          </a:xfrm>
-          <a:prstGeom prst="rect">
-            <a:avLst/>
-          </a:prstGeom>
-        </p:spPr>
-        <p:txBody>
-          <a:bodyPr spcFirstLastPara="1" wrap="square" lIns="91425" tIns="45700" rIns="91425" bIns="45700" anchor="t" anchorCtr="0">
-            <a:noAutofit/>
-          </a:bodyPr>
-          <a:lstStyle/>
-          <a:p>
-            <a:pPr marL="0" lvl="0" indent="0" algn="l" rtl="0">
-              <a:spcBef>
-                <a:spcPts val="0"/>
-              </a:spcBef>
-              <a:spcAft>
-                <a:spcPts val="0"/>
-              </a:spcAft>
-              <a:buNone/>
-            </a:pPr>
-            <a:r>
-              <a:rPr lang="en-US" dirty="0"/>
-              <a:t>Launch zoom poll asking participants what exploratory data analysis means to them</a:t>
-            </a:r>
-            <a:endParaRPr dirty="0"/>
-          </a:p>
-        </p:txBody>
-      </p:sp>
-      <p:sp>
-        <p:nvSpPr>
-          <p:cNvPr id="156" name="Google Shape;156;p3:notes">
-            <a:extLst>
-              <a:ext uri="{FF2B5EF4-FFF2-40B4-BE49-F238E27FC236}">
-                <a16:creationId xmlns:a16="http://schemas.microsoft.com/office/drawing/2014/main" id="{6035978B-19D1-6889-79F9-A5ABE899B6FA}"/>
-              </a:ext>
-            </a:extLst>
-          </p:cNvPr>
-          <p:cNvSpPr>
-            <a:spLocks noGrp="1" noRot="1" noChangeAspect="1"/>
-          </p:cNvSpPr>
-          <p:nvPr>
-            <p:ph type="sldImg" idx="2"/>
-          </p:nvPr>
-        </p:nvSpPr>
-        <p:spPr>
-          <a:xfrm>
-            <a:off x="685800" y="1143000"/>
-            <a:ext cx="5486400" cy="3086100"/>
-          </a:xfrm>
-          <a:custGeom>
-            <a:avLst/>
-            <a:gdLst/>
-            <a:ahLst/>
-            <a:cxnLst/>
-            <a:rect l="l" t="t" r="r" b="b"/>
-            <a:pathLst>
-              <a:path w="120000" h="120000" extrusionOk="0">
-                <a:moveTo>
-                  <a:pt x="0" y="0"/>
-                </a:moveTo>
-                <a:lnTo>
-                  <a:pt x="120000" y="0"/>
-                </a:lnTo>
-                <a:lnTo>
-                  <a:pt x="120000" y="120000"/>
-                </a:lnTo>
-                <a:lnTo>
-                  <a:pt x="0" y="120000"/>
-                </a:lnTo>
-                <a:close/>
-              </a:path>
-            </a:pathLst>
-          </a:custGeom>
-        </p:spPr>
-      </p:sp>
-    </p:spTree>
-    <p:extLst>
-      <p:ext uri="{BB962C8B-B14F-4D97-AF65-F5344CB8AC3E}">
-        <p14:creationId xmlns:p14="http://schemas.microsoft.com/office/powerpoint/2010/main" val="2227097333"/>
-      </p:ext>
-    </p:extLst>
-  </p:cSld>
-  <p:clrMapOvr>
-    <a:masterClrMapping/>
-  </p:clrMapOvr>
-</p:notes>
-</file>
-
-<file path=ppt/notesSlides/notesSlide12.xml><?xml version="1.0" encoding="utf-8"?>
-<p:notes xmlns:a="http://schemas.openxmlformats.org/drawingml/2006/main" xmlns:r="http://schemas.openxmlformats.org/officeDocument/2006/relationships" xmlns:p="http://schemas.openxmlformats.org/presentationml/2006/main" showMasterSp="0" showMasterPhAnim="0">
-  <p:cSld>
-    <p:spTree>
-      <p:nvGrpSpPr>
         <p:cNvPr id="1" name="Shape 130">
           <a:extLst>
             <a:ext uri="{FF2B5EF4-FFF2-40B4-BE49-F238E27FC236}">
-              <a16:creationId xmlns:a16="http://schemas.microsoft.com/office/drawing/2014/main" id="{69BC706B-0588-BCA5-7FA1-99C780C996CB}"/>
+              <a16:creationId xmlns:a16="http://schemas.microsoft.com/office/drawing/2014/main" id="{673AE1B5-6C76-778B-B2CE-6FE7542F2EF8}"/>
             </a:ext>
           </a:extLst>
         </p:cNvPr>
@@ -1207,7 +995,7 @@
           <p:cNvPr id="131" name="Google Shape;131;p4:notes">
             <a:extLst>
               <a:ext uri="{FF2B5EF4-FFF2-40B4-BE49-F238E27FC236}">
-                <a16:creationId xmlns:a16="http://schemas.microsoft.com/office/drawing/2014/main" id="{07E39956-98A3-7608-6816-7F2D3C8084D7}"/>
+                <a16:creationId xmlns:a16="http://schemas.microsoft.com/office/drawing/2014/main" id="{450FC169-3522-9425-2494-DD6853700616}"/>
               </a:ext>
             </a:extLst>
           </p:cNvPr>
@@ -1251,7 +1039,7 @@
           <p:cNvPr id="132" name="Google Shape;132;p4:notes">
             <a:extLst>
               <a:ext uri="{FF2B5EF4-FFF2-40B4-BE49-F238E27FC236}">
-                <a16:creationId xmlns:a16="http://schemas.microsoft.com/office/drawing/2014/main" id="{2D6B694C-2E47-EB98-08A7-8D2760A74AE3}"/>
+                <a16:creationId xmlns:a16="http://schemas.microsoft.com/office/drawing/2014/main" id="{DC25B693-6CA7-57E4-D62F-C555B6186A32}"/>
               </a:ext>
             </a:extLst>
           </p:cNvPr>
@@ -1296,7 +1084,7 @@
     </p:spTree>
     <p:extLst>
       <p:ext uri="{BB962C8B-B14F-4D97-AF65-F5344CB8AC3E}">
-        <p14:creationId xmlns:p14="http://schemas.microsoft.com/office/powerpoint/2010/main" val="1490194714"/>
+        <p14:creationId xmlns:p14="http://schemas.microsoft.com/office/powerpoint/2010/main" val="1382916428"/>
       </p:ext>
     </p:extLst>
   </p:cSld>
@@ -1306,15 +1094,15 @@
 </p:notes>
 </file>
 
-<file path=ppt/notesSlides/notesSlide13.xml><?xml version="1.0" encoding="utf-8"?>
+<file path=ppt/notesSlides/notesSlide11.xml><?xml version="1.0" encoding="utf-8"?>
 <p:notes xmlns:a="http://schemas.openxmlformats.org/drawingml/2006/main" xmlns:r="http://schemas.openxmlformats.org/officeDocument/2006/relationships" xmlns:p="http://schemas.openxmlformats.org/presentationml/2006/main" showMasterSp="0" showMasterPhAnim="0">
   <p:cSld>
     <p:spTree>
       <p:nvGrpSpPr>
-        <p:cNvPr id="1" name="Shape 130">
+        <p:cNvPr id="1" name="Shape 136">
           <a:extLst>
             <a:ext uri="{FF2B5EF4-FFF2-40B4-BE49-F238E27FC236}">
-              <a16:creationId xmlns:a16="http://schemas.microsoft.com/office/drawing/2014/main" id="{496111B2-86A8-BBA5-42BA-585ECCC6B373}"/>
+              <a16:creationId xmlns:a16="http://schemas.microsoft.com/office/drawing/2014/main" id="{C0BD02D6-750D-D3FC-2CBB-D9FB5367F205}"/>
             </a:ext>
           </a:extLst>
         </p:cNvPr>
@@ -1331,10 +1119,10 @@
       </p:grpSpPr>
       <p:sp>
         <p:nvSpPr>
-          <p:cNvPr id="131" name="Google Shape;131;p4:notes">
+          <p:cNvPr id="137" name="Google Shape;137;p5:notes">
             <a:extLst>
               <a:ext uri="{FF2B5EF4-FFF2-40B4-BE49-F238E27FC236}">
-                <a16:creationId xmlns:a16="http://schemas.microsoft.com/office/drawing/2014/main" id="{B24ADCD6-0EB4-322B-A391-7C9779FDA3DA}"/>
+                <a16:creationId xmlns:a16="http://schemas.microsoft.com/office/drawing/2014/main" id="{3D008D43-143C-3D5B-9AB3-4DBB414A230F}"/>
               </a:ext>
             </a:extLst>
           </p:cNvPr>
@@ -1375,10 +1163,10 @@
       </p:sp>
       <p:sp>
         <p:nvSpPr>
-          <p:cNvPr id="132" name="Google Shape;132;p4:notes">
+          <p:cNvPr id="138" name="Google Shape;138;p5:notes">
             <a:extLst>
               <a:ext uri="{FF2B5EF4-FFF2-40B4-BE49-F238E27FC236}">
-                <a16:creationId xmlns:a16="http://schemas.microsoft.com/office/drawing/2014/main" id="{23C8E68D-3369-08A9-8DBB-DF09FC4ACC78}"/>
+                <a16:creationId xmlns:a16="http://schemas.microsoft.com/office/drawing/2014/main" id="{15FCE76D-A8AD-5554-87B8-6EF1C53AE443}"/>
               </a:ext>
             </a:extLst>
           </p:cNvPr>
@@ -1423,7 +1211,7 @@
     </p:spTree>
     <p:extLst>
       <p:ext uri="{BB962C8B-B14F-4D97-AF65-F5344CB8AC3E}">
-        <p14:creationId xmlns:p14="http://schemas.microsoft.com/office/powerpoint/2010/main" val="1757390138"/>
+        <p14:creationId xmlns:p14="http://schemas.microsoft.com/office/powerpoint/2010/main" val="1489175486"/>
       </p:ext>
     </p:extLst>
   </p:cSld>
@@ -1433,134 +1221,7 @@
 </p:notes>
 </file>
 
-<file path=ppt/notesSlides/notesSlide14.xml><?xml version="1.0" encoding="utf-8"?>
-<p:notes xmlns:a="http://schemas.openxmlformats.org/drawingml/2006/main" xmlns:r="http://schemas.openxmlformats.org/officeDocument/2006/relationships" xmlns:p="http://schemas.openxmlformats.org/presentationml/2006/main" showMasterSp="0" showMasterPhAnim="0">
-  <p:cSld>
-    <p:spTree>
-      <p:nvGrpSpPr>
-        <p:cNvPr id="1" name="Shape 136">
-          <a:extLst>
-            <a:ext uri="{FF2B5EF4-FFF2-40B4-BE49-F238E27FC236}">
-              <a16:creationId xmlns:a16="http://schemas.microsoft.com/office/drawing/2014/main" id="{630D9D44-15EA-9856-047B-24CF9CF1D632}"/>
-            </a:ext>
-          </a:extLst>
-        </p:cNvPr>
-        <p:cNvGrpSpPr/>
-        <p:nvPr/>
-      </p:nvGrpSpPr>
-      <p:grpSpPr>
-        <a:xfrm>
-          <a:off x="0" y="0"/>
-          <a:ext cx="0" cy="0"/>
-          <a:chOff x="0" y="0"/>
-          <a:chExt cx="0" cy="0"/>
-        </a:xfrm>
-      </p:grpSpPr>
-      <p:sp>
-        <p:nvSpPr>
-          <p:cNvPr id="137" name="Google Shape;137;p5:notes">
-            <a:extLst>
-              <a:ext uri="{FF2B5EF4-FFF2-40B4-BE49-F238E27FC236}">
-                <a16:creationId xmlns:a16="http://schemas.microsoft.com/office/drawing/2014/main" id="{36C89CF9-CD24-455E-0E29-C1311D8D1FB5}"/>
-              </a:ext>
-            </a:extLst>
-          </p:cNvPr>
-          <p:cNvSpPr txBox="1">
-            <a:spLocks noGrp="1"/>
-          </p:cNvSpPr>
-          <p:nvPr>
-            <p:ph type="body" idx="1"/>
-          </p:nvPr>
-        </p:nvSpPr>
-        <p:spPr>
-          <a:xfrm>
-            <a:off x="685800" y="4343400"/>
-            <a:ext cx="5486400" cy="4114800"/>
-          </a:xfrm>
-          <a:prstGeom prst="rect">
-            <a:avLst/>
-          </a:prstGeom>
-        </p:spPr>
-        <p:txBody>
-          <a:bodyPr spcFirstLastPara="1" wrap="square" lIns="91425" tIns="91425" rIns="91425" bIns="91425" anchor="t" anchorCtr="0">
-            <a:noAutofit/>
-          </a:bodyPr>
-          <a:lstStyle/>
-          <a:p>
-            <a:pPr marL="0" lvl="0" indent="0" algn="l" rtl="0">
-              <a:spcBef>
-                <a:spcPts val="0"/>
-              </a:spcBef>
-              <a:spcAft>
-                <a:spcPts val="0"/>
-              </a:spcAft>
-              <a:buNone/>
-            </a:pPr>
-            <a:endParaRPr dirty="0"/>
-          </a:p>
-        </p:txBody>
-      </p:sp>
-      <p:sp>
-        <p:nvSpPr>
-          <p:cNvPr id="138" name="Google Shape;138;p5:notes">
-            <a:extLst>
-              <a:ext uri="{FF2B5EF4-FFF2-40B4-BE49-F238E27FC236}">
-                <a16:creationId xmlns:a16="http://schemas.microsoft.com/office/drawing/2014/main" id="{13B6F075-54AC-59A4-DF80-1AF4AB81E110}"/>
-              </a:ext>
-            </a:extLst>
-          </p:cNvPr>
-          <p:cNvSpPr>
-            <a:spLocks noGrp="1" noRot="1" noChangeAspect="1"/>
-          </p:cNvSpPr>
-          <p:nvPr>
-            <p:ph type="sldImg" idx="2"/>
-          </p:nvPr>
-        </p:nvSpPr>
-        <p:spPr>
-          <a:xfrm>
-            <a:off x="381000" y="685800"/>
-            <a:ext cx="6096000" cy="3429000"/>
-          </a:xfrm>
-          <a:custGeom>
-            <a:avLst/>
-            <a:gdLst/>
-            <a:ahLst/>
-            <a:cxnLst/>
-            <a:rect l="l" t="t" r="r" b="b"/>
-            <a:pathLst>
-              <a:path w="120000" h="120000" extrusionOk="0">
-                <a:moveTo>
-                  <a:pt x="0" y="0"/>
-                </a:moveTo>
-                <a:lnTo>
-                  <a:pt x="120000" y="0"/>
-                </a:lnTo>
-                <a:lnTo>
-                  <a:pt x="120000" y="120000"/>
-                </a:lnTo>
-                <a:lnTo>
-                  <a:pt x="0" y="120000"/>
-                </a:lnTo>
-                <a:close/>
-              </a:path>
-            </a:pathLst>
-          </a:custGeom>
-        </p:spPr>
-      </p:sp>
-    </p:spTree>
-    <p:extLst>
-      <p:ext uri="{BB962C8B-B14F-4D97-AF65-F5344CB8AC3E}">
-        <p14:creationId xmlns:p14="http://schemas.microsoft.com/office/powerpoint/2010/main" val="1202162411"/>
-      </p:ext>
-    </p:extLst>
-  </p:cSld>
-  <p:clrMapOvr>
-    <a:masterClrMapping/>
-  </p:clrMapOvr>
-</p:notes>
-</file>
-
-<file path=ppt/notesSlides/notesSlide15.xml><?xml version="1.0" encoding="utf-8"?>
+<file path=ppt/notesSlides/notesSlide12.xml><?xml version="1.0" encoding="utf-8"?>
 <p:notes xmlns:a="http://schemas.openxmlformats.org/drawingml/2006/main" xmlns:r="http://schemas.openxmlformats.org/officeDocument/2006/relationships" xmlns:p="http://schemas.openxmlformats.org/presentationml/2006/main" showMasterSp="0" showMasterPhAnim="0">
   <p:cSld>
     <p:spTree>
@@ -1687,7 +1348,7 @@
 </p:notes>
 </file>
 
-<file path=ppt/notesSlides/notesSlide16.xml><?xml version="1.0" encoding="utf-8"?>
+<file path=ppt/notesSlides/notesSlide13.xml><?xml version="1.0" encoding="utf-8"?>
 <p:notes xmlns:a="http://schemas.openxmlformats.org/drawingml/2006/main" xmlns:r="http://schemas.openxmlformats.org/officeDocument/2006/relationships" xmlns:p="http://schemas.openxmlformats.org/presentationml/2006/main" showMasterSp="0" showMasterPhAnim="0">
   <p:cSld>
     <p:spTree>
@@ -1814,134 +1475,7 @@
 </p:notes>
 </file>
 
-<file path=ppt/notesSlides/notesSlide17.xml><?xml version="1.0" encoding="utf-8"?>
-<p:notes xmlns:a="http://schemas.openxmlformats.org/drawingml/2006/main" xmlns:r="http://schemas.openxmlformats.org/officeDocument/2006/relationships" xmlns:p="http://schemas.openxmlformats.org/presentationml/2006/main" showMasterSp="0" showMasterPhAnim="0">
-  <p:cSld>
-    <p:spTree>
-      <p:nvGrpSpPr>
-        <p:cNvPr id="1" name="Shape 130">
-          <a:extLst>
-            <a:ext uri="{FF2B5EF4-FFF2-40B4-BE49-F238E27FC236}">
-              <a16:creationId xmlns:a16="http://schemas.microsoft.com/office/drawing/2014/main" id="{673AE1B5-6C76-778B-B2CE-6FE7542F2EF8}"/>
-            </a:ext>
-          </a:extLst>
-        </p:cNvPr>
-        <p:cNvGrpSpPr/>
-        <p:nvPr/>
-      </p:nvGrpSpPr>
-      <p:grpSpPr>
-        <a:xfrm>
-          <a:off x="0" y="0"/>
-          <a:ext cx="0" cy="0"/>
-          <a:chOff x="0" y="0"/>
-          <a:chExt cx="0" cy="0"/>
-        </a:xfrm>
-      </p:grpSpPr>
-      <p:sp>
-        <p:nvSpPr>
-          <p:cNvPr id="131" name="Google Shape;131;p4:notes">
-            <a:extLst>
-              <a:ext uri="{FF2B5EF4-FFF2-40B4-BE49-F238E27FC236}">
-                <a16:creationId xmlns:a16="http://schemas.microsoft.com/office/drawing/2014/main" id="{450FC169-3522-9425-2494-DD6853700616}"/>
-              </a:ext>
-            </a:extLst>
-          </p:cNvPr>
-          <p:cNvSpPr txBox="1">
-            <a:spLocks noGrp="1"/>
-          </p:cNvSpPr>
-          <p:nvPr>
-            <p:ph type="body" idx="1"/>
-          </p:nvPr>
-        </p:nvSpPr>
-        <p:spPr>
-          <a:xfrm>
-            <a:off x="685800" y="4343400"/>
-            <a:ext cx="5486400" cy="4114800"/>
-          </a:xfrm>
-          <a:prstGeom prst="rect">
-            <a:avLst/>
-          </a:prstGeom>
-        </p:spPr>
-        <p:txBody>
-          <a:bodyPr spcFirstLastPara="1" wrap="square" lIns="91425" tIns="91425" rIns="91425" bIns="91425" anchor="t" anchorCtr="0">
-            <a:noAutofit/>
-          </a:bodyPr>
-          <a:lstStyle/>
-          <a:p>
-            <a:pPr marL="0" lvl="0" indent="0" algn="l" rtl="0">
-              <a:spcBef>
-                <a:spcPts val="0"/>
-              </a:spcBef>
-              <a:spcAft>
-                <a:spcPts val="0"/>
-              </a:spcAft>
-              <a:buNone/>
-            </a:pPr>
-            <a:endParaRPr/>
-          </a:p>
-        </p:txBody>
-      </p:sp>
-      <p:sp>
-        <p:nvSpPr>
-          <p:cNvPr id="132" name="Google Shape;132;p4:notes">
-            <a:extLst>
-              <a:ext uri="{FF2B5EF4-FFF2-40B4-BE49-F238E27FC236}">
-                <a16:creationId xmlns:a16="http://schemas.microsoft.com/office/drawing/2014/main" id="{DC25B693-6CA7-57E4-D62F-C555B6186A32}"/>
-              </a:ext>
-            </a:extLst>
-          </p:cNvPr>
-          <p:cNvSpPr>
-            <a:spLocks noGrp="1" noRot="1" noChangeAspect="1"/>
-          </p:cNvSpPr>
-          <p:nvPr>
-            <p:ph type="sldImg" idx="2"/>
-          </p:nvPr>
-        </p:nvSpPr>
-        <p:spPr>
-          <a:xfrm>
-            <a:off x="381000" y="685800"/>
-            <a:ext cx="6096000" cy="3429000"/>
-          </a:xfrm>
-          <a:custGeom>
-            <a:avLst/>
-            <a:gdLst/>
-            <a:ahLst/>
-            <a:cxnLst/>
-            <a:rect l="l" t="t" r="r" b="b"/>
-            <a:pathLst>
-              <a:path w="120000" h="120000" extrusionOk="0">
-                <a:moveTo>
-                  <a:pt x="0" y="0"/>
-                </a:moveTo>
-                <a:lnTo>
-                  <a:pt x="120000" y="0"/>
-                </a:lnTo>
-                <a:lnTo>
-                  <a:pt x="120000" y="120000"/>
-                </a:lnTo>
-                <a:lnTo>
-                  <a:pt x="0" y="120000"/>
-                </a:lnTo>
-                <a:close/>
-              </a:path>
-            </a:pathLst>
-          </a:custGeom>
-        </p:spPr>
-      </p:sp>
-    </p:spTree>
-    <p:extLst>
-      <p:ext uri="{BB962C8B-B14F-4D97-AF65-F5344CB8AC3E}">
-        <p14:creationId xmlns:p14="http://schemas.microsoft.com/office/powerpoint/2010/main" val="1382916428"/>
-      </p:ext>
-    </p:extLst>
-  </p:cSld>
-  <p:clrMapOvr>
-    <a:masterClrMapping/>
-  </p:clrMapOvr>
-</p:notes>
-</file>
-
-<file path=ppt/notesSlides/notesSlide18.xml><?xml version="1.0" encoding="utf-8"?>
+<file path=ppt/notesSlides/notesSlide14.xml><?xml version="1.0" encoding="utf-8"?>
 <p:notes xmlns:a="http://schemas.openxmlformats.org/drawingml/2006/main" xmlns:r="http://schemas.openxmlformats.org/officeDocument/2006/relationships" xmlns:p="http://schemas.openxmlformats.org/presentationml/2006/main" showMasterSp="0" showMasterPhAnim="0">
   <p:cSld>
     <p:spTree>
@@ -2045,7 +1579,7 @@
 </p:notes>
 </file>
 
-<file path=ppt/notesSlides/notesSlide19.xml><?xml version="1.0" encoding="utf-8"?>
+<file path=ppt/notesSlides/notesSlide15.xml><?xml version="1.0" encoding="utf-8"?>
 <p:notes xmlns:a="http://schemas.openxmlformats.org/drawingml/2006/main" xmlns:r="http://schemas.openxmlformats.org/officeDocument/2006/relationships" xmlns:p="http://schemas.openxmlformats.org/presentationml/2006/main" showMasterSp="0" showMasterPhAnim="0">
   <p:cSld>
     <p:spTree>
@@ -2167,6 +1701,137 @@
     <p:extLst>
       <p:ext uri="{BB962C8B-B14F-4D97-AF65-F5344CB8AC3E}">
         <p14:creationId xmlns:p14="http://schemas.microsoft.com/office/powerpoint/2010/main" val="3717950828"/>
+      </p:ext>
+    </p:extLst>
+  </p:cSld>
+  <p:clrMapOvr>
+    <a:masterClrMapping/>
+  </p:clrMapOvr>
+</p:notes>
+</file>
+
+<file path=ppt/notesSlides/notesSlide16.xml><?xml version="1.0" encoding="utf-8"?>
+<p:notes xmlns:a="http://schemas.openxmlformats.org/drawingml/2006/main" xmlns:r="http://schemas.openxmlformats.org/officeDocument/2006/relationships" xmlns:p="http://schemas.openxmlformats.org/presentationml/2006/main" showMasterSp="0" showMasterPhAnim="0">
+  <p:cSld>
+    <p:spTree>
+      <p:nvGrpSpPr>
+        <p:cNvPr id="1" name="Shape 136">
+          <a:extLst>
+            <a:ext uri="{FF2B5EF4-FFF2-40B4-BE49-F238E27FC236}">
+              <a16:creationId xmlns:a16="http://schemas.microsoft.com/office/drawing/2014/main" id="{5511F11B-19A8-0589-8EAC-0A2BDC6BCEB7}"/>
+            </a:ext>
+          </a:extLst>
+        </p:cNvPr>
+        <p:cNvGrpSpPr/>
+        <p:nvPr/>
+      </p:nvGrpSpPr>
+      <p:grpSpPr>
+        <a:xfrm>
+          <a:off x="0" y="0"/>
+          <a:ext cx="0" cy="0"/>
+          <a:chOff x="0" y="0"/>
+          <a:chExt cx="0" cy="0"/>
+        </a:xfrm>
+      </p:grpSpPr>
+      <p:sp>
+        <p:nvSpPr>
+          <p:cNvPr id="137" name="Google Shape;137;p5:notes">
+            <a:extLst>
+              <a:ext uri="{FF2B5EF4-FFF2-40B4-BE49-F238E27FC236}">
+                <a16:creationId xmlns:a16="http://schemas.microsoft.com/office/drawing/2014/main" id="{9ACCE4B3-B38E-7360-8B94-D60DD49D74B3}"/>
+              </a:ext>
+            </a:extLst>
+          </p:cNvPr>
+          <p:cNvSpPr txBox="1">
+            <a:spLocks noGrp="1"/>
+          </p:cNvSpPr>
+          <p:nvPr>
+            <p:ph type="body" idx="1"/>
+          </p:nvPr>
+        </p:nvSpPr>
+        <p:spPr>
+          <a:xfrm>
+            <a:off x="685800" y="4343400"/>
+            <a:ext cx="5486400" cy="4114800"/>
+          </a:xfrm>
+          <a:prstGeom prst="rect">
+            <a:avLst/>
+          </a:prstGeom>
+        </p:spPr>
+        <p:txBody>
+          <a:bodyPr spcFirstLastPara="1" wrap="square" lIns="91425" tIns="91425" rIns="91425" bIns="91425" anchor="t" anchorCtr="0">
+            <a:noAutofit/>
+          </a:bodyPr>
+          <a:lstStyle/>
+          <a:p>
+            <a:pPr marL="0" lvl="0" indent="0" algn="l" rtl="0">
+              <a:spcBef>
+                <a:spcPts val="0"/>
+              </a:spcBef>
+              <a:spcAft>
+                <a:spcPts val="0"/>
+              </a:spcAft>
+              <a:buNone/>
+            </a:pPr>
+            <a:r>
+              <a:rPr lang="en-US" dirty="0"/>
+              <a:t>Note this flow is specific to the data aspects of a project and does not include critical steps like literature review and hypothesis formulation.</a:t>
+            </a:r>
+            <a:endParaRPr dirty="0"/>
+          </a:p>
+        </p:txBody>
+      </p:sp>
+      <p:sp>
+        <p:nvSpPr>
+          <p:cNvPr id="138" name="Google Shape;138;p5:notes">
+            <a:extLst>
+              <a:ext uri="{FF2B5EF4-FFF2-40B4-BE49-F238E27FC236}">
+                <a16:creationId xmlns:a16="http://schemas.microsoft.com/office/drawing/2014/main" id="{662FD663-B329-75E2-5F62-59BA65C25855}"/>
+              </a:ext>
+            </a:extLst>
+          </p:cNvPr>
+          <p:cNvSpPr>
+            <a:spLocks noGrp="1" noRot="1" noChangeAspect="1"/>
+          </p:cNvSpPr>
+          <p:nvPr>
+            <p:ph type="sldImg" idx="2"/>
+          </p:nvPr>
+        </p:nvSpPr>
+        <p:spPr>
+          <a:xfrm>
+            <a:off x="381000" y="685800"/>
+            <a:ext cx="6096000" cy="3429000"/>
+          </a:xfrm>
+          <a:custGeom>
+            <a:avLst/>
+            <a:gdLst/>
+            <a:ahLst/>
+            <a:cxnLst/>
+            <a:rect l="l" t="t" r="r" b="b"/>
+            <a:pathLst>
+              <a:path w="120000" h="120000" extrusionOk="0">
+                <a:moveTo>
+                  <a:pt x="0" y="0"/>
+                </a:moveTo>
+                <a:lnTo>
+                  <a:pt x="120000" y="0"/>
+                </a:lnTo>
+                <a:lnTo>
+                  <a:pt x="120000" y="120000"/>
+                </a:lnTo>
+                <a:lnTo>
+                  <a:pt x="0" y="120000"/>
+                </a:lnTo>
+                <a:close/>
+              </a:path>
+            </a:pathLst>
+          </a:custGeom>
+        </p:spPr>
+      </p:sp>
+    </p:spTree>
+    <p:extLst>
+      <p:ext uri="{BB962C8B-B14F-4D97-AF65-F5344CB8AC3E}">
+        <p14:creationId xmlns:p14="http://schemas.microsoft.com/office/powerpoint/2010/main" val="567471064"/>
       </p:ext>
     </p:extLst>
   </p:cSld>
@@ -2294,137 +1959,6 @@
     <p:extLst>
       <p:ext uri="{BB962C8B-B14F-4D97-AF65-F5344CB8AC3E}">
         <p14:creationId xmlns:p14="http://schemas.microsoft.com/office/powerpoint/2010/main" val="2703362923"/>
-      </p:ext>
-    </p:extLst>
-  </p:cSld>
-  <p:clrMapOvr>
-    <a:masterClrMapping/>
-  </p:clrMapOvr>
-</p:notes>
-</file>
-
-<file path=ppt/notesSlides/notesSlide20.xml><?xml version="1.0" encoding="utf-8"?>
-<p:notes xmlns:a="http://schemas.openxmlformats.org/drawingml/2006/main" xmlns:r="http://schemas.openxmlformats.org/officeDocument/2006/relationships" xmlns:p="http://schemas.openxmlformats.org/presentationml/2006/main" showMasterSp="0" showMasterPhAnim="0">
-  <p:cSld>
-    <p:spTree>
-      <p:nvGrpSpPr>
-        <p:cNvPr id="1" name="Shape 136">
-          <a:extLst>
-            <a:ext uri="{FF2B5EF4-FFF2-40B4-BE49-F238E27FC236}">
-              <a16:creationId xmlns:a16="http://schemas.microsoft.com/office/drawing/2014/main" id="{5511F11B-19A8-0589-8EAC-0A2BDC6BCEB7}"/>
-            </a:ext>
-          </a:extLst>
-        </p:cNvPr>
-        <p:cNvGrpSpPr/>
-        <p:nvPr/>
-      </p:nvGrpSpPr>
-      <p:grpSpPr>
-        <a:xfrm>
-          <a:off x="0" y="0"/>
-          <a:ext cx="0" cy="0"/>
-          <a:chOff x="0" y="0"/>
-          <a:chExt cx="0" cy="0"/>
-        </a:xfrm>
-      </p:grpSpPr>
-      <p:sp>
-        <p:nvSpPr>
-          <p:cNvPr id="137" name="Google Shape;137;p5:notes">
-            <a:extLst>
-              <a:ext uri="{FF2B5EF4-FFF2-40B4-BE49-F238E27FC236}">
-                <a16:creationId xmlns:a16="http://schemas.microsoft.com/office/drawing/2014/main" id="{9ACCE4B3-B38E-7360-8B94-D60DD49D74B3}"/>
-              </a:ext>
-            </a:extLst>
-          </p:cNvPr>
-          <p:cNvSpPr txBox="1">
-            <a:spLocks noGrp="1"/>
-          </p:cNvSpPr>
-          <p:nvPr>
-            <p:ph type="body" idx="1"/>
-          </p:nvPr>
-        </p:nvSpPr>
-        <p:spPr>
-          <a:xfrm>
-            <a:off x="685800" y="4343400"/>
-            <a:ext cx="5486400" cy="4114800"/>
-          </a:xfrm>
-          <a:prstGeom prst="rect">
-            <a:avLst/>
-          </a:prstGeom>
-        </p:spPr>
-        <p:txBody>
-          <a:bodyPr spcFirstLastPara="1" wrap="square" lIns="91425" tIns="91425" rIns="91425" bIns="91425" anchor="t" anchorCtr="0">
-            <a:noAutofit/>
-          </a:bodyPr>
-          <a:lstStyle/>
-          <a:p>
-            <a:pPr marL="0" lvl="0" indent="0" algn="l" rtl="0">
-              <a:spcBef>
-                <a:spcPts val="0"/>
-              </a:spcBef>
-              <a:spcAft>
-                <a:spcPts val="0"/>
-              </a:spcAft>
-              <a:buNone/>
-            </a:pPr>
-            <a:r>
-              <a:rPr lang="en-US" dirty="0"/>
-              <a:t>Note this flow is specific to the data aspects of a project and does not include critical steps like literature review and hypothesis formulation.</a:t>
-            </a:r>
-            <a:endParaRPr dirty="0"/>
-          </a:p>
-        </p:txBody>
-      </p:sp>
-      <p:sp>
-        <p:nvSpPr>
-          <p:cNvPr id="138" name="Google Shape;138;p5:notes">
-            <a:extLst>
-              <a:ext uri="{FF2B5EF4-FFF2-40B4-BE49-F238E27FC236}">
-                <a16:creationId xmlns:a16="http://schemas.microsoft.com/office/drawing/2014/main" id="{662FD663-B329-75E2-5F62-59BA65C25855}"/>
-              </a:ext>
-            </a:extLst>
-          </p:cNvPr>
-          <p:cNvSpPr>
-            <a:spLocks noGrp="1" noRot="1" noChangeAspect="1"/>
-          </p:cNvSpPr>
-          <p:nvPr>
-            <p:ph type="sldImg" idx="2"/>
-          </p:nvPr>
-        </p:nvSpPr>
-        <p:spPr>
-          <a:xfrm>
-            <a:off x="381000" y="685800"/>
-            <a:ext cx="6096000" cy="3429000"/>
-          </a:xfrm>
-          <a:custGeom>
-            <a:avLst/>
-            <a:gdLst/>
-            <a:ahLst/>
-            <a:cxnLst/>
-            <a:rect l="l" t="t" r="r" b="b"/>
-            <a:pathLst>
-              <a:path w="120000" h="120000" extrusionOk="0">
-                <a:moveTo>
-                  <a:pt x="0" y="0"/>
-                </a:moveTo>
-                <a:lnTo>
-                  <a:pt x="120000" y="0"/>
-                </a:lnTo>
-                <a:lnTo>
-                  <a:pt x="120000" y="120000"/>
-                </a:lnTo>
-                <a:lnTo>
-                  <a:pt x="0" y="120000"/>
-                </a:lnTo>
-                <a:close/>
-              </a:path>
-            </a:pathLst>
-          </a:custGeom>
-        </p:spPr>
-      </p:sp>
-    </p:spTree>
-    <p:extLst>
-      <p:ext uri="{BB962C8B-B14F-4D97-AF65-F5344CB8AC3E}">
-        <p14:creationId xmlns:p14="http://schemas.microsoft.com/office/powerpoint/2010/main" val="567471064"/>
       </p:ext>
     </p:extLst>
   </p:cSld>
@@ -2696,133 +2230,6 @@
         <p:cNvPr id="1" name="Shape 136">
           <a:extLst>
             <a:ext uri="{FF2B5EF4-FFF2-40B4-BE49-F238E27FC236}">
-              <a16:creationId xmlns:a16="http://schemas.microsoft.com/office/drawing/2014/main" id="{C0BD02D6-750D-D3FC-2CBB-D9FB5367F205}"/>
-            </a:ext>
-          </a:extLst>
-        </p:cNvPr>
-        <p:cNvGrpSpPr/>
-        <p:nvPr/>
-      </p:nvGrpSpPr>
-      <p:grpSpPr>
-        <a:xfrm>
-          <a:off x="0" y="0"/>
-          <a:ext cx="0" cy="0"/>
-          <a:chOff x="0" y="0"/>
-          <a:chExt cx="0" cy="0"/>
-        </a:xfrm>
-      </p:grpSpPr>
-      <p:sp>
-        <p:nvSpPr>
-          <p:cNvPr id="137" name="Google Shape;137;p5:notes">
-            <a:extLst>
-              <a:ext uri="{FF2B5EF4-FFF2-40B4-BE49-F238E27FC236}">
-                <a16:creationId xmlns:a16="http://schemas.microsoft.com/office/drawing/2014/main" id="{3D008D43-143C-3D5B-9AB3-4DBB414A230F}"/>
-              </a:ext>
-            </a:extLst>
-          </p:cNvPr>
-          <p:cNvSpPr txBox="1">
-            <a:spLocks noGrp="1"/>
-          </p:cNvSpPr>
-          <p:nvPr>
-            <p:ph type="body" idx="1"/>
-          </p:nvPr>
-        </p:nvSpPr>
-        <p:spPr>
-          <a:xfrm>
-            <a:off x="685800" y="4343400"/>
-            <a:ext cx="5486400" cy="4114800"/>
-          </a:xfrm>
-          <a:prstGeom prst="rect">
-            <a:avLst/>
-          </a:prstGeom>
-        </p:spPr>
-        <p:txBody>
-          <a:bodyPr spcFirstLastPara="1" wrap="square" lIns="91425" tIns="91425" rIns="91425" bIns="91425" anchor="t" anchorCtr="0">
-            <a:noAutofit/>
-          </a:bodyPr>
-          <a:lstStyle/>
-          <a:p>
-            <a:pPr marL="0" lvl="0" indent="0" algn="l" rtl="0">
-              <a:spcBef>
-                <a:spcPts val="0"/>
-              </a:spcBef>
-              <a:spcAft>
-                <a:spcPts val="0"/>
-              </a:spcAft>
-              <a:buNone/>
-            </a:pPr>
-            <a:endParaRPr/>
-          </a:p>
-        </p:txBody>
-      </p:sp>
-      <p:sp>
-        <p:nvSpPr>
-          <p:cNvPr id="138" name="Google Shape;138;p5:notes">
-            <a:extLst>
-              <a:ext uri="{FF2B5EF4-FFF2-40B4-BE49-F238E27FC236}">
-                <a16:creationId xmlns:a16="http://schemas.microsoft.com/office/drawing/2014/main" id="{15FCE76D-A8AD-5554-87B8-6EF1C53AE443}"/>
-              </a:ext>
-            </a:extLst>
-          </p:cNvPr>
-          <p:cNvSpPr>
-            <a:spLocks noGrp="1" noRot="1" noChangeAspect="1"/>
-          </p:cNvSpPr>
-          <p:nvPr>
-            <p:ph type="sldImg" idx="2"/>
-          </p:nvPr>
-        </p:nvSpPr>
-        <p:spPr>
-          <a:xfrm>
-            <a:off x="381000" y="685800"/>
-            <a:ext cx="6096000" cy="3429000"/>
-          </a:xfrm>
-          <a:custGeom>
-            <a:avLst/>
-            <a:gdLst/>
-            <a:ahLst/>
-            <a:cxnLst/>
-            <a:rect l="l" t="t" r="r" b="b"/>
-            <a:pathLst>
-              <a:path w="120000" h="120000" extrusionOk="0">
-                <a:moveTo>
-                  <a:pt x="0" y="0"/>
-                </a:moveTo>
-                <a:lnTo>
-                  <a:pt x="120000" y="0"/>
-                </a:lnTo>
-                <a:lnTo>
-                  <a:pt x="120000" y="120000"/>
-                </a:lnTo>
-                <a:lnTo>
-                  <a:pt x="0" y="120000"/>
-                </a:lnTo>
-                <a:close/>
-              </a:path>
-            </a:pathLst>
-          </a:custGeom>
-        </p:spPr>
-      </p:sp>
-    </p:spTree>
-    <p:extLst>
-      <p:ext uri="{BB962C8B-B14F-4D97-AF65-F5344CB8AC3E}">
-        <p14:creationId xmlns:p14="http://schemas.microsoft.com/office/powerpoint/2010/main" val="3782734666"/>
-      </p:ext>
-    </p:extLst>
-  </p:cSld>
-  <p:clrMapOvr>
-    <a:masterClrMapping/>
-  </p:clrMapOvr>
-</p:notes>
-</file>
-
-<file path=ppt/notesSlides/notesSlide6.xml><?xml version="1.0" encoding="utf-8"?>
-<p:notes xmlns:a="http://schemas.openxmlformats.org/drawingml/2006/main" xmlns:r="http://schemas.openxmlformats.org/officeDocument/2006/relationships" xmlns:p="http://schemas.openxmlformats.org/presentationml/2006/main" showMasterSp="0" showMasterPhAnim="0">
-  <p:cSld>
-    <p:spTree>
-      <p:nvGrpSpPr>
-        <p:cNvPr id="1" name="Shape 136">
-          <a:extLst>
-            <a:ext uri="{FF2B5EF4-FFF2-40B4-BE49-F238E27FC236}">
               <a16:creationId xmlns:a16="http://schemas.microsoft.com/office/drawing/2014/main" id="{665FF49C-22CA-561F-4B1C-B554BD230355}"/>
             </a:ext>
           </a:extLst>
@@ -2942,7 +2349,7 @@
 </p:notes>
 </file>
 
-<file path=ppt/notesSlides/notesSlide7.xml><?xml version="1.0" encoding="utf-8"?>
+<file path=ppt/notesSlides/notesSlide6.xml><?xml version="1.0" encoding="utf-8"?>
 <p:notes xmlns:a="http://schemas.openxmlformats.org/drawingml/2006/main" xmlns:r="http://schemas.openxmlformats.org/officeDocument/2006/relationships" xmlns:p="http://schemas.openxmlformats.org/presentationml/2006/main" showMasterSp="0" showMasterPhAnim="0">
   <p:cSld>
     <p:spTree>
@@ -3069,7 +2476,7 @@
 </p:notes>
 </file>
 
-<file path=ppt/notesSlides/notesSlide8.xml><?xml version="1.0" encoding="utf-8"?>
+<file path=ppt/notesSlides/notesSlide7.xml><?xml version="1.0" encoding="utf-8"?>
 <p:notes xmlns:a="http://schemas.openxmlformats.org/drawingml/2006/main" xmlns:r="http://schemas.openxmlformats.org/officeDocument/2006/relationships" xmlns:p="http://schemas.openxmlformats.org/presentationml/2006/main" showMasterSp="0" showMasterPhAnim="0">
   <p:cSld>
     <p:spTree>
@@ -3196,7 +2603,7 @@
 </p:notes>
 </file>
 
-<file path=ppt/notesSlides/notesSlide9.xml><?xml version="1.0" encoding="utf-8"?>
+<file path=ppt/notesSlides/notesSlide8.xml><?xml version="1.0" encoding="utf-8"?>
 <p:notes xmlns:a="http://schemas.openxmlformats.org/drawingml/2006/main" xmlns:r="http://schemas.openxmlformats.org/officeDocument/2006/relationships" xmlns:p="http://schemas.openxmlformats.org/presentationml/2006/main" showMasterSp="0" showMasterPhAnim="0">
   <p:cSld>
     <p:spTree>
@@ -3314,6 +2721,133 @@
     <p:extLst>
       <p:ext uri="{BB962C8B-B14F-4D97-AF65-F5344CB8AC3E}">
         <p14:creationId xmlns:p14="http://schemas.microsoft.com/office/powerpoint/2010/main" val="884275554"/>
+      </p:ext>
+    </p:extLst>
+  </p:cSld>
+  <p:clrMapOvr>
+    <a:masterClrMapping/>
+  </p:clrMapOvr>
+</p:notes>
+</file>
+
+<file path=ppt/notesSlides/notesSlide9.xml><?xml version="1.0" encoding="utf-8"?>
+<p:notes xmlns:a="http://schemas.openxmlformats.org/drawingml/2006/main" xmlns:r="http://schemas.openxmlformats.org/officeDocument/2006/relationships" xmlns:p="http://schemas.openxmlformats.org/presentationml/2006/main" showMasterSp="0" showMasterPhAnim="0">
+  <p:cSld>
+    <p:spTree>
+      <p:nvGrpSpPr>
+        <p:cNvPr id="1" name="Shape 154">
+          <a:extLst>
+            <a:ext uri="{FF2B5EF4-FFF2-40B4-BE49-F238E27FC236}">
+              <a16:creationId xmlns:a16="http://schemas.microsoft.com/office/drawing/2014/main" id="{2BA011E6-134D-151C-AD28-4AA22971D43C}"/>
+            </a:ext>
+          </a:extLst>
+        </p:cNvPr>
+        <p:cNvGrpSpPr/>
+        <p:nvPr/>
+      </p:nvGrpSpPr>
+      <p:grpSpPr>
+        <a:xfrm>
+          <a:off x="0" y="0"/>
+          <a:ext cx="0" cy="0"/>
+          <a:chOff x="0" y="0"/>
+          <a:chExt cx="0" cy="0"/>
+        </a:xfrm>
+      </p:grpSpPr>
+      <p:sp>
+        <p:nvSpPr>
+          <p:cNvPr id="155" name="Google Shape;155;p3:notes">
+            <a:extLst>
+              <a:ext uri="{FF2B5EF4-FFF2-40B4-BE49-F238E27FC236}">
+                <a16:creationId xmlns:a16="http://schemas.microsoft.com/office/drawing/2014/main" id="{4EFC36F4-02D7-B6FE-07B6-86360A78807D}"/>
+              </a:ext>
+            </a:extLst>
+          </p:cNvPr>
+          <p:cNvSpPr txBox="1">
+            <a:spLocks noGrp="1"/>
+          </p:cNvSpPr>
+          <p:nvPr>
+            <p:ph type="body" idx="1"/>
+          </p:nvPr>
+        </p:nvSpPr>
+        <p:spPr>
+          <a:xfrm>
+            <a:off x="685800" y="4400550"/>
+            <a:ext cx="5486400" cy="3600450"/>
+          </a:xfrm>
+          <a:prstGeom prst="rect">
+            <a:avLst/>
+          </a:prstGeom>
+        </p:spPr>
+        <p:txBody>
+          <a:bodyPr spcFirstLastPara="1" wrap="square" lIns="91425" tIns="45700" rIns="91425" bIns="45700" anchor="t" anchorCtr="0">
+            <a:noAutofit/>
+          </a:bodyPr>
+          <a:lstStyle/>
+          <a:p>
+            <a:pPr marL="0" lvl="0" indent="0" algn="l" rtl="0">
+              <a:spcBef>
+                <a:spcPts val="0"/>
+              </a:spcBef>
+              <a:spcAft>
+                <a:spcPts val="0"/>
+              </a:spcAft>
+              <a:buNone/>
+            </a:pPr>
+            <a:endParaRPr dirty="0"/>
+          </a:p>
+        </p:txBody>
+      </p:sp>
+      <p:sp>
+        <p:nvSpPr>
+          <p:cNvPr id="156" name="Google Shape;156;p3:notes">
+            <a:extLst>
+              <a:ext uri="{FF2B5EF4-FFF2-40B4-BE49-F238E27FC236}">
+                <a16:creationId xmlns:a16="http://schemas.microsoft.com/office/drawing/2014/main" id="{236D2ACB-930C-5EAA-9C08-7FC1B2632362}"/>
+              </a:ext>
+            </a:extLst>
+          </p:cNvPr>
+          <p:cNvSpPr>
+            <a:spLocks noGrp="1" noRot="1" noChangeAspect="1"/>
+          </p:cNvSpPr>
+          <p:nvPr>
+            <p:ph type="sldImg" idx="2"/>
+          </p:nvPr>
+        </p:nvSpPr>
+        <p:spPr>
+          <a:xfrm>
+            <a:off x="685800" y="1143000"/>
+            <a:ext cx="5486400" cy="3086100"/>
+          </a:xfrm>
+          <a:custGeom>
+            <a:avLst/>
+            <a:gdLst/>
+            <a:ahLst/>
+            <a:cxnLst/>
+            <a:rect l="l" t="t" r="r" b="b"/>
+            <a:pathLst>
+              <a:path w="120000" h="120000" extrusionOk="0">
+                <a:moveTo>
+                  <a:pt x="0" y="0"/>
+                </a:moveTo>
+                <a:lnTo>
+                  <a:pt x="120000" y="0"/>
+                </a:lnTo>
+                <a:lnTo>
+                  <a:pt x="120000" y="120000"/>
+                </a:lnTo>
+                <a:lnTo>
+                  <a:pt x="0" y="120000"/>
+                </a:lnTo>
+                <a:close/>
+              </a:path>
+            </a:pathLst>
+          </a:custGeom>
+        </p:spPr>
+      </p:sp>
+    </p:spTree>
+    <p:extLst>
+      <p:ext uri="{BB962C8B-B14F-4D97-AF65-F5344CB8AC3E}">
+        <p14:creationId xmlns:p14="http://schemas.microsoft.com/office/powerpoint/2010/main" val="1740453337"/>
       </p:ext>
     </p:extLst>
   </p:cSld>
@@ -16115,253 +15649,10 @@
   <p:cSld>
     <p:spTree>
       <p:nvGrpSpPr>
-        <p:cNvPr id="1" name="Shape 157">
-          <a:extLst>
-            <a:ext uri="{FF2B5EF4-FFF2-40B4-BE49-F238E27FC236}">
-              <a16:creationId xmlns:a16="http://schemas.microsoft.com/office/drawing/2014/main" id="{085F6405-7F4A-13C9-ADC6-785C80561D89}"/>
-            </a:ext>
-          </a:extLst>
-        </p:cNvPr>
-        <p:cNvGrpSpPr/>
-        <p:nvPr/>
-      </p:nvGrpSpPr>
-      <p:grpSpPr>
-        <a:xfrm>
-          <a:off x="0" y="0"/>
-          <a:ext cx="0" cy="0"/>
-          <a:chOff x="0" y="0"/>
-          <a:chExt cx="0" cy="0"/>
-        </a:xfrm>
-      </p:grpSpPr>
-      <p:sp>
-        <p:nvSpPr>
-          <p:cNvPr id="158" name="Google Shape;158;p19">
-            <a:extLst>
-              <a:ext uri="{FF2B5EF4-FFF2-40B4-BE49-F238E27FC236}">
-                <a16:creationId xmlns:a16="http://schemas.microsoft.com/office/drawing/2014/main" id="{F0B4E771-CF6F-C6B2-8CF5-60A162B78732}"/>
-              </a:ext>
-            </a:extLst>
-          </p:cNvPr>
-          <p:cNvSpPr txBox="1">
-            <a:spLocks noGrp="1"/>
-          </p:cNvSpPr>
-          <p:nvPr>
-            <p:ph type="title"/>
-          </p:nvPr>
-        </p:nvSpPr>
-        <p:spPr>
-          <a:xfrm>
-            <a:off x="2329800" y="1709750"/>
-            <a:ext cx="9017400" cy="2852700"/>
-          </a:xfrm>
-          <a:prstGeom prst="rect">
-            <a:avLst/>
-          </a:prstGeom>
-          <a:noFill/>
-          <a:ln>
-            <a:noFill/>
-          </a:ln>
-        </p:spPr>
-        <p:txBody>
-          <a:bodyPr spcFirstLastPara="1" wrap="square" lIns="91425" tIns="45700" rIns="91425" bIns="45700" anchor="b" anchorCtr="0">
-            <a:noAutofit/>
-          </a:bodyPr>
-          <a:lstStyle/>
-          <a:p>
-            <a:pPr marL="0" lvl="0" indent="0" algn="l" rtl="0">
-              <a:lnSpc>
-                <a:spcPct val="90000"/>
-              </a:lnSpc>
-              <a:spcBef>
-                <a:spcPts val="0"/>
-              </a:spcBef>
-              <a:spcAft>
-                <a:spcPts val="0"/>
-              </a:spcAft>
-              <a:buClr>
-                <a:schemeClr val="dk1"/>
-              </a:buClr>
-              <a:buSzPts val="6000"/>
-              <a:buFont typeface="Arial"/>
-              <a:buNone/>
-            </a:pPr>
-            <a:r>
-              <a:rPr lang="en-US" b="0" dirty="0"/>
-              <a:t>Let’s get started!</a:t>
-            </a:r>
-            <a:endParaRPr b="0" dirty="0"/>
-          </a:p>
-        </p:txBody>
-      </p:sp>
-      <p:sp>
-        <p:nvSpPr>
-          <p:cNvPr id="2" name="TextBox 1">
-            <a:extLst>
-              <a:ext uri="{FF2B5EF4-FFF2-40B4-BE49-F238E27FC236}">
-                <a16:creationId xmlns:a16="http://schemas.microsoft.com/office/drawing/2014/main" id="{C666E518-A04F-6DE0-C306-91FE81E92306}"/>
-              </a:ext>
-            </a:extLst>
-          </p:cNvPr>
-          <p:cNvSpPr txBox="1"/>
-          <p:nvPr/>
-        </p:nvSpPr>
-        <p:spPr>
-          <a:xfrm>
-            <a:off x="3315767" y="5078064"/>
-            <a:ext cx="4242987" cy="369332"/>
-          </a:xfrm>
-          <a:prstGeom prst="rect">
-            <a:avLst/>
-          </a:prstGeom>
-          <a:noFill/>
-        </p:spPr>
-        <p:txBody>
-          <a:bodyPr wrap="square" rtlCol="0">
-            <a:spAutoFit/>
-          </a:bodyPr>
-          <a:lstStyle/>
-          <a:p>
-            <a:r>
-              <a:rPr lang="en-US" dirty="0"/>
-              <a:t>Download the data from: </a:t>
-            </a:r>
-            <a:r>
-              <a:rPr lang="en-US" dirty="0" err="1">
-                <a:highlight>
-                  <a:srgbClr val="FFFF00"/>
-                </a:highlight>
-              </a:rPr>
-              <a:t>dartgo</a:t>
-            </a:r>
-            <a:r>
-              <a:rPr lang="en-US" dirty="0">
-                <a:highlight>
-                  <a:srgbClr val="FFFF00"/>
-                </a:highlight>
-              </a:rPr>
-              <a:t> link</a:t>
-            </a:r>
-          </a:p>
-        </p:txBody>
-      </p:sp>
-    </p:spTree>
-    <p:extLst>
-      <p:ext uri="{BB962C8B-B14F-4D97-AF65-F5344CB8AC3E}">
-        <p14:creationId xmlns:p14="http://schemas.microsoft.com/office/powerpoint/2010/main" val="3846199407"/>
-      </p:ext>
-    </p:extLst>
-  </p:cSld>
-  <p:clrMapOvr>
-    <a:masterClrMapping/>
-  </p:clrMapOvr>
-</p:sld>
-</file>
-
-<file path=ppt/slides/slide11.xml><?xml version="1.0" encoding="utf-8"?>
-<p:sld xmlns:a="http://schemas.openxmlformats.org/drawingml/2006/main" xmlns:r="http://schemas.openxmlformats.org/officeDocument/2006/relationships" xmlns:p="http://schemas.openxmlformats.org/presentationml/2006/main">
-  <p:cSld>
-    <p:spTree>
-      <p:nvGrpSpPr>
-        <p:cNvPr id="1" name="Shape 157">
-          <a:extLst>
-            <a:ext uri="{FF2B5EF4-FFF2-40B4-BE49-F238E27FC236}">
-              <a16:creationId xmlns:a16="http://schemas.microsoft.com/office/drawing/2014/main" id="{547496E7-A833-33DE-2654-5CBB7BB3E932}"/>
-            </a:ext>
-          </a:extLst>
-        </p:cNvPr>
-        <p:cNvGrpSpPr/>
-        <p:nvPr/>
-      </p:nvGrpSpPr>
-      <p:grpSpPr>
-        <a:xfrm>
-          <a:off x="0" y="0"/>
-          <a:ext cx="0" cy="0"/>
-          <a:chOff x="0" y="0"/>
-          <a:chExt cx="0" cy="0"/>
-        </a:xfrm>
-      </p:grpSpPr>
-      <p:sp>
-        <p:nvSpPr>
-          <p:cNvPr id="158" name="Google Shape;158;p19">
-            <a:extLst>
-              <a:ext uri="{FF2B5EF4-FFF2-40B4-BE49-F238E27FC236}">
-                <a16:creationId xmlns:a16="http://schemas.microsoft.com/office/drawing/2014/main" id="{E6D073DF-C2AB-0BC0-505B-E995E8317EBC}"/>
-              </a:ext>
-            </a:extLst>
-          </p:cNvPr>
-          <p:cNvSpPr txBox="1">
-            <a:spLocks noGrp="1"/>
-          </p:cNvSpPr>
-          <p:nvPr>
-            <p:ph type="title"/>
-          </p:nvPr>
-        </p:nvSpPr>
-        <p:spPr>
-          <a:xfrm>
-            <a:off x="2329800" y="1709750"/>
-            <a:ext cx="9017400" cy="2852700"/>
-          </a:xfrm>
-          <a:prstGeom prst="rect">
-            <a:avLst/>
-          </a:prstGeom>
-          <a:noFill/>
-          <a:ln>
-            <a:noFill/>
-          </a:ln>
-        </p:spPr>
-        <p:txBody>
-          <a:bodyPr spcFirstLastPara="1" wrap="square" lIns="91425" tIns="45700" rIns="91425" bIns="45700" anchor="b" anchorCtr="0">
-            <a:noAutofit/>
-          </a:bodyPr>
-          <a:lstStyle/>
-          <a:p>
-            <a:pPr marL="0" lvl="0" indent="0" algn="l" rtl="0">
-              <a:lnSpc>
-                <a:spcPct val="90000"/>
-              </a:lnSpc>
-              <a:spcBef>
-                <a:spcPts val="0"/>
-              </a:spcBef>
-              <a:spcAft>
-                <a:spcPts val="0"/>
-              </a:spcAft>
-              <a:buClr>
-                <a:schemeClr val="dk1"/>
-              </a:buClr>
-              <a:buSzPts val="6000"/>
-              <a:buFont typeface="Arial"/>
-              <a:buNone/>
-            </a:pPr>
-            <a:r>
-              <a:rPr lang="en-US" b="0" dirty="0"/>
-              <a:t>Emphasis template</a:t>
-            </a:r>
-            <a:endParaRPr b="0" dirty="0"/>
-          </a:p>
-        </p:txBody>
-      </p:sp>
-    </p:spTree>
-    <p:extLst>
-      <p:ext uri="{BB962C8B-B14F-4D97-AF65-F5344CB8AC3E}">
-        <p14:creationId xmlns:p14="http://schemas.microsoft.com/office/powerpoint/2010/main" val="3264595192"/>
-      </p:ext>
-    </p:extLst>
-  </p:cSld>
-  <p:clrMapOvr>
-    <a:masterClrMapping/>
-  </p:clrMapOvr>
-</p:sld>
-</file>
-
-<file path=ppt/slides/slide12.xml><?xml version="1.0" encoding="utf-8"?>
-<p:sld xmlns:a="http://schemas.openxmlformats.org/drawingml/2006/main" xmlns:r="http://schemas.openxmlformats.org/officeDocument/2006/relationships" xmlns:p="http://schemas.openxmlformats.org/presentationml/2006/main">
-  <p:cSld>
-    <p:spTree>
-      <p:nvGrpSpPr>
         <p:cNvPr id="1" name="Shape 133">
           <a:extLst>
             <a:ext uri="{FF2B5EF4-FFF2-40B4-BE49-F238E27FC236}">
-              <a16:creationId xmlns:a16="http://schemas.microsoft.com/office/drawing/2014/main" id="{3E414038-5369-B37B-4312-59566BAC0C2D}"/>
+              <a16:creationId xmlns:a16="http://schemas.microsoft.com/office/drawing/2014/main" id="{2B114DF9-97CA-2B66-BD58-02EF311F8256}"/>
             </a:ext>
           </a:extLst>
         </p:cNvPr>
@@ -16381,7 +15672,7 @@
           <p:cNvPr id="134" name="Google Shape;134;p25">
             <a:extLst>
               <a:ext uri="{FF2B5EF4-FFF2-40B4-BE49-F238E27FC236}">
-                <a16:creationId xmlns:a16="http://schemas.microsoft.com/office/drawing/2014/main" id="{AEFC1B03-EB6E-7013-558E-E1A5E260A541}"/>
+                <a16:creationId xmlns:a16="http://schemas.microsoft.com/office/drawing/2014/main" id="{64477353-763A-15A6-FAA3-7320FC3B4337}"/>
               </a:ext>
             </a:extLst>
           </p:cNvPr>
@@ -16422,7 +15713,7 @@
                 <a:cs typeface="Anton"/>
                 <a:sym typeface="Anton"/>
               </a:rPr>
-              <a:t>Template section break</a:t>
+              <a:t>Day 2 </a:t>
             </a:r>
             <a:endParaRPr sz="100" kern="0" dirty="0">
               <a:solidFill>
@@ -16441,7 +15732,7 @@
           <p:cNvPr id="135" name="Google Shape;135;p25">
             <a:extLst>
               <a:ext uri="{FF2B5EF4-FFF2-40B4-BE49-F238E27FC236}">
-                <a16:creationId xmlns:a16="http://schemas.microsoft.com/office/drawing/2014/main" id="{27C37B2B-A165-ED87-47C5-9789B934C931}"/>
+                <a16:creationId xmlns:a16="http://schemas.microsoft.com/office/drawing/2014/main" id="{1CBE9B77-AEC0-E2BF-6DD1-05D68D82A90C}"/>
               </a:ext>
             </a:extLst>
           </p:cNvPr>
@@ -16450,8 +15741,8 @@
         </p:nvSpPr>
         <p:spPr>
           <a:xfrm>
-            <a:off x="836403" y="3038803"/>
-            <a:ext cx="7990097" cy="780393"/>
+            <a:off x="1065004" y="2844069"/>
+            <a:ext cx="3947264" cy="780393"/>
           </a:xfrm>
           <a:custGeom>
             <a:avLst/>
@@ -16515,7 +15806,7 @@
     </p:spTree>
     <p:extLst>
       <p:ext uri="{BB962C8B-B14F-4D97-AF65-F5344CB8AC3E}">
-        <p14:creationId xmlns:p14="http://schemas.microsoft.com/office/powerpoint/2010/main" val="2972185394"/>
+        <p14:creationId xmlns:p14="http://schemas.microsoft.com/office/powerpoint/2010/main" val="825263348"/>
       </p:ext>
     </p:extLst>
   </p:cSld>
@@ -16525,248 +15816,7 @@
 </p:sld>
 </file>
 
-<file path=ppt/slides/slide13.xml><?xml version="1.0" encoding="utf-8"?>
-<p:sld xmlns:a="http://schemas.openxmlformats.org/drawingml/2006/main" xmlns:r="http://schemas.openxmlformats.org/officeDocument/2006/relationships" xmlns:p="http://schemas.openxmlformats.org/presentationml/2006/main">
-  <p:cSld>
-    <p:spTree>
-      <p:nvGrpSpPr>
-        <p:cNvPr id="1" name="Shape 133">
-          <a:extLst>
-            <a:ext uri="{FF2B5EF4-FFF2-40B4-BE49-F238E27FC236}">
-              <a16:creationId xmlns:a16="http://schemas.microsoft.com/office/drawing/2014/main" id="{D452EFA7-99F5-AC17-FD94-47424FD19699}"/>
-            </a:ext>
-          </a:extLst>
-        </p:cNvPr>
-        <p:cNvGrpSpPr/>
-        <p:nvPr/>
-      </p:nvGrpSpPr>
-      <p:grpSpPr>
-        <a:xfrm>
-          <a:off x="0" y="0"/>
-          <a:ext cx="0" cy="0"/>
-          <a:chOff x="0" y="0"/>
-          <a:chExt cx="0" cy="0"/>
-        </a:xfrm>
-      </p:grpSpPr>
-      <p:sp>
-        <p:nvSpPr>
-          <p:cNvPr id="134" name="Google Shape;134;p25">
-            <a:extLst>
-              <a:ext uri="{FF2B5EF4-FFF2-40B4-BE49-F238E27FC236}">
-                <a16:creationId xmlns:a16="http://schemas.microsoft.com/office/drawing/2014/main" id="{F7A93097-A548-77F9-CE56-144378A0207C}"/>
-              </a:ext>
-            </a:extLst>
-          </p:cNvPr>
-          <p:cNvSpPr txBox="1"/>
-          <p:nvPr/>
-        </p:nvSpPr>
-        <p:spPr>
-          <a:xfrm>
-            <a:off x="1785128" y="2286000"/>
-            <a:ext cx="7305000" cy="1034129"/>
-          </a:xfrm>
-          <a:prstGeom prst="rect">
-            <a:avLst/>
-          </a:prstGeom>
-          <a:noFill/>
-          <a:ln>
-            <a:noFill/>
-          </a:ln>
-        </p:spPr>
-        <p:txBody>
-          <a:bodyPr spcFirstLastPara="1" wrap="square" lIns="0" tIns="0" rIns="0" bIns="0" anchor="t" anchorCtr="0">
-            <a:spAutoFit/>
-          </a:bodyPr>
-          <a:lstStyle/>
-          <a:p>
-            <a:pPr defTabSz="609630">
-              <a:lnSpc>
-                <a:spcPct val="139996"/>
-              </a:lnSpc>
-              <a:buClr>
-                <a:srgbClr val="000000"/>
-              </a:buClr>
-            </a:pPr>
-            <a:r>
-              <a:rPr lang="en-US" sz="4800" kern="0" dirty="0">
-                <a:solidFill>
-                  <a:srgbClr val="A5D75F"/>
-                </a:solidFill>
-                <a:latin typeface="Anton"/>
-                <a:ea typeface="Anton"/>
-                <a:cs typeface="Anton"/>
-                <a:sym typeface="Anton"/>
-              </a:rPr>
-              <a:t>Section with </a:t>
-            </a:r>
-            <a:r>
-              <a:rPr lang="en-US" sz="4800" kern="0" dirty="0" err="1">
-                <a:solidFill>
-                  <a:srgbClr val="A5D75F"/>
-                </a:solidFill>
-                <a:latin typeface="Anton"/>
-                <a:ea typeface="Anton"/>
-                <a:cs typeface="Anton"/>
-                <a:sym typeface="Anton"/>
-              </a:rPr>
-              <a:t>subheader</a:t>
-            </a:r>
-            <a:endParaRPr lang="en-US" sz="4800" kern="0" dirty="0">
-              <a:solidFill>
-                <a:srgbClr val="A5D75F"/>
-              </a:solidFill>
-              <a:latin typeface="Anton"/>
-              <a:ea typeface="Anton"/>
-              <a:cs typeface="Anton"/>
-              <a:sym typeface="Anton"/>
-            </a:endParaRPr>
-          </a:p>
-        </p:txBody>
-      </p:sp>
-      <p:sp>
-        <p:nvSpPr>
-          <p:cNvPr id="135" name="Google Shape;135;p25">
-            <a:extLst>
-              <a:ext uri="{FF2B5EF4-FFF2-40B4-BE49-F238E27FC236}">
-                <a16:creationId xmlns:a16="http://schemas.microsoft.com/office/drawing/2014/main" id="{331D6F09-9458-526A-FF20-F267795F2555}"/>
-              </a:ext>
-            </a:extLst>
-          </p:cNvPr>
-          <p:cNvSpPr/>
-          <p:nvPr/>
-        </p:nvSpPr>
-        <p:spPr>
-          <a:xfrm>
-            <a:off x="1202207" y="3147675"/>
-            <a:ext cx="8470842" cy="780393"/>
-          </a:xfrm>
-          <a:custGeom>
-            <a:avLst/>
-            <a:gdLst/>
-            <a:ahLst/>
-            <a:cxnLst/>
-            <a:rect l="l" t="t" r="r" b="b"/>
-            <a:pathLst>
-              <a:path w="6287497" h="938348" extrusionOk="0">
-                <a:moveTo>
-                  <a:pt x="0" y="0"/>
-                </a:moveTo>
-                <a:lnTo>
-                  <a:pt x="6287496" y="0"/>
-                </a:lnTo>
-                <a:lnTo>
-                  <a:pt x="6287496" y="938349"/>
-                </a:lnTo>
-                <a:lnTo>
-                  <a:pt x="0" y="938349"/>
-                </a:lnTo>
-                <a:lnTo>
-                  <a:pt x="0" y="0"/>
-                </a:lnTo>
-                <a:close/>
-              </a:path>
-            </a:pathLst>
-          </a:custGeom>
-          <a:blipFill rotWithShape="1">
-            <a:blip r:embed="rId3">
-              <a:alphaModFix/>
-            </a:blip>
-            <a:stretch>
-              <a:fillRect/>
-            </a:stretch>
-          </a:blipFill>
-          <a:ln>
-            <a:noFill/>
-          </a:ln>
-        </p:spPr>
-        <p:txBody>
-          <a:bodyPr/>
-          <a:lstStyle/>
-          <a:p>
-            <a:pPr defTabSz="609630">
-              <a:buClr>
-                <a:srgbClr val="000000"/>
-              </a:buClr>
-            </a:pPr>
-            <a:endParaRPr lang="en-US" sz="933" kern="0">
-              <a:solidFill>
-                <a:srgbClr val="000000"/>
-              </a:solidFill>
-              <a:latin typeface="Arial"/>
-              <a:cs typeface="Arial"/>
-              <a:sym typeface="Arial"/>
-            </a:endParaRPr>
-          </a:p>
-        </p:txBody>
-      </p:sp>
-      <p:sp>
-        <p:nvSpPr>
-          <p:cNvPr id="2" name="Google Shape;134;p25">
-            <a:extLst>
-              <a:ext uri="{FF2B5EF4-FFF2-40B4-BE49-F238E27FC236}">
-                <a16:creationId xmlns:a16="http://schemas.microsoft.com/office/drawing/2014/main" id="{FD177E63-CF02-BE48-4279-6F903A246918}"/>
-              </a:ext>
-            </a:extLst>
-          </p:cNvPr>
-          <p:cNvSpPr txBox="1"/>
-          <p:nvPr/>
-        </p:nvSpPr>
-        <p:spPr>
-          <a:xfrm>
-            <a:off x="1853585" y="4633937"/>
-            <a:ext cx="7305000" cy="861774"/>
-          </a:xfrm>
-          <a:prstGeom prst="rect">
-            <a:avLst/>
-          </a:prstGeom>
-          <a:noFill/>
-          <a:ln>
-            <a:noFill/>
-          </a:ln>
-        </p:spPr>
-        <p:txBody>
-          <a:bodyPr spcFirstLastPara="1" wrap="square" lIns="0" tIns="0" rIns="0" bIns="0" anchor="t" anchorCtr="0">
-            <a:spAutoFit/>
-          </a:bodyPr>
-          <a:lstStyle/>
-          <a:p>
-            <a:pPr defTabSz="609630">
-              <a:lnSpc>
-                <a:spcPct val="139996"/>
-              </a:lnSpc>
-              <a:buClr>
-                <a:srgbClr val="000000"/>
-              </a:buClr>
-            </a:pPr>
-            <a:r>
-              <a:rPr lang="en-US" sz="4000" kern="0" dirty="0">
-                <a:solidFill>
-                  <a:schemeClr val="accent5"/>
-                </a:solidFill>
-                <a:latin typeface="Anton"/>
-                <a:ea typeface="Anton"/>
-                <a:cs typeface="Anton"/>
-                <a:sym typeface="Anton"/>
-              </a:rPr>
-              <a:t>Subheading</a:t>
-            </a:r>
-          </a:p>
-        </p:txBody>
-      </p:sp>
-    </p:spTree>
-    <p:extLst>
-      <p:ext uri="{BB962C8B-B14F-4D97-AF65-F5344CB8AC3E}">
-        <p14:creationId xmlns:p14="http://schemas.microsoft.com/office/powerpoint/2010/main" val="2372691659"/>
-      </p:ext>
-    </p:extLst>
-  </p:cSld>
-  <p:clrMapOvr>
-    <a:masterClrMapping/>
-  </p:clrMapOvr>
-</p:sld>
-</file>
-
-<file path=ppt/slides/slide14.xml><?xml version="1.0" encoding="utf-8"?>
+<file path=ppt/slides/slide11.xml><?xml version="1.0" encoding="utf-8"?>
 <p:sld xmlns:a="http://schemas.openxmlformats.org/drawingml/2006/main" xmlns:r="http://schemas.openxmlformats.org/officeDocument/2006/relationships" xmlns:p="http://schemas.openxmlformats.org/presentationml/2006/main">
   <p:cSld>
     <p:spTree>
@@ -16774,7 +15824,7 @@
         <p:cNvPr id="1" name="Shape 139">
           <a:extLst>
             <a:ext uri="{FF2B5EF4-FFF2-40B4-BE49-F238E27FC236}">
-              <a16:creationId xmlns:a16="http://schemas.microsoft.com/office/drawing/2014/main" id="{36A3A810-BE3F-FF9F-7C09-CC7A3E413F8B}"/>
+              <a16:creationId xmlns:a16="http://schemas.microsoft.com/office/drawing/2014/main" id="{492ED415-B6B2-270C-003F-176DCDAA9815}"/>
             </a:ext>
           </a:extLst>
         </p:cNvPr>
@@ -16794,7 +15844,7 @@
           <p:cNvPr id="141" name="Google Shape;141;p26">
             <a:extLst>
               <a:ext uri="{FF2B5EF4-FFF2-40B4-BE49-F238E27FC236}">
-                <a16:creationId xmlns:a16="http://schemas.microsoft.com/office/drawing/2014/main" id="{CFB73FC9-1CA6-89B0-A47E-4CD56BECF796}"/>
+                <a16:creationId xmlns:a16="http://schemas.microsoft.com/office/drawing/2014/main" id="{5EDFCD96-892A-B449-4839-26398579B5A5}"/>
               </a:ext>
             </a:extLst>
           </p:cNvPr>
@@ -16803,8 +15853,8 @@
         </p:nvSpPr>
         <p:spPr>
           <a:xfrm>
-            <a:off x="922202" y="1157695"/>
-            <a:ext cx="6097800" cy="742383"/>
+            <a:off x="922201" y="1157695"/>
+            <a:ext cx="8284715" cy="742383"/>
           </a:xfrm>
           <a:prstGeom prst="rect">
             <a:avLst/>
@@ -16838,7 +15888,7 @@
                 <a:cs typeface="Anton"/>
                 <a:sym typeface="Anton"/>
               </a:rPr>
-              <a:t>Slide with sub-bullets</a:t>
+              <a:t>Reproducible Research workshop series</a:t>
             </a:r>
             <a:endParaRPr sz="933" kern="0" dirty="0">
               <a:solidFill>
@@ -16857,7 +15907,7 @@
           <p:cNvPr id="142" name="Google Shape;142;p26">
             <a:extLst>
               <a:ext uri="{FF2B5EF4-FFF2-40B4-BE49-F238E27FC236}">
-                <a16:creationId xmlns:a16="http://schemas.microsoft.com/office/drawing/2014/main" id="{979C2E83-708D-E6AD-5F5E-877A1779EB5E}"/>
+                <a16:creationId xmlns:a16="http://schemas.microsoft.com/office/drawing/2014/main" id="{9B72596A-D557-1CA0-4098-0B9E3210C40F}"/>
               </a:ext>
             </a:extLst>
           </p:cNvPr>
@@ -16866,8 +15916,8 @@
         </p:nvSpPr>
         <p:spPr>
           <a:xfrm>
-            <a:off x="922202" y="1736904"/>
-            <a:ext cx="9776400" cy="3282437"/>
+            <a:off x="922201" y="1983519"/>
+            <a:ext cx="9776400" cy="3834896"/>
           </a:xfrm>
           <a:prstGeom prst="rect">
             <a:avLst/>
@@ -16894,13 +15944,89 @@
               <a:buFont typeface="Archivo Medium"/>
               <a:buChar char="•"/>
             </a:pPr>
-            <a:endParaRPr lang="en-US" sz="2006" kern="0" dirty="0">
-              <a:solidFill>
+            <a:r>
+              <a:rPr lang="en-US" dirty="0">
+                <a:solidFill>
+                  <a:srgbClr val="12312B"/>
+                </a:solidFill>
+                <a:latin typeface="Archivo Medium"/>
+                <a:cs typeface="Archivo Medium"/>
+                <a:sym typeface="Archivo Medium"/>
+              </a:rPr>
+              <a:t>T</a:t>
+            </a:r>
+            <a:r>
+              <a:rPr lang="en-US" dirty="0">
+                <a:solidFill>
+                  <a:srgbClr val="12312B"/>
+                </a:solidFill>
+                <a:latin typeface="Archivo Medium"/>
+                <a:ea typeface="Archivo Medium"/>
+                <a:cs typeface="Archivo Medium"/>
+                <a:sym typeface="Archivo Medium"/>
+              </a:rPr>
+              <a:t>he </a:t>
+            </a:r>
+            <a:r>
+              <a:rPr lang="en-US" b="1" dirty="0">
+                <a:solidFill>
+                  <a:srgbClr val="12312B"/>
+                </a:solidFill>
+                <a:latin typeface="Archivo Medium"/>
+                <a:ea typeface="Archivo"/>
+                <a:cs typeface="Archivo"/>
+                <a:sym typeface="Archivo"/>
+              </a:rPr>
+              <a:t>Reproducible Research Group</a:t>
+            </a:r>
+            <a:r>
+              <a:rPr lang="en-US" dirty="0">
+                <a:solidFill>
+                  <a:srgbClr val="12312B"/>
+                </a:solidFill>
+                <a:latin typeface="Archivo Medium"/>
+                <a:ea typeface="Archivo"/>
+                <a:cs typeface="Archivo"/>
+                <a:sym typeface="Archivo"/>
+              </a:rPr>
+              <a:t>—a</a:t>
+            </a:r>
+            <a:r>
+              <a:rPr lang="en-US" dirty="0">
+                <a:latin typeface="Archivo Medium"/>
+              </a:rPr>
+              <a:t> collaboration between Dartmouth Libraries and Research Computing / ITC—of</a:t>
+            </a:r>
+            <a:r>
+              <a:rPr lang="en-US" dirty="0">
+                <a:solidFill>
+                  <a:srgbClr val="12312B"/>
+                </a:solidFill>
+                <a:latin typeface="Archivo Medium"/>
+                <a:ea typeface="Archivo Medium"/>
+                <a:cs typeface="Archivo Medium"/>
+                <a:sym typeface="Archivo Medium"/>
+              </a:rPr>
+              <a:t>fers workshops on computational and reproducible research, data science, and related fields every term. </a:t>
+            </a:r>
+            <a:endParaRPr lang="en-US" dirty="0">
+              <a:latin typeface="Archivo Medium"/>
+            </a:endParaRPr>
+          </a:p>
+          <a:p>
+            <a:pPr marL="433260" lvl="1" indent="-216630" defTabSz="609630">
+              <a:lnSpc>
+                <a:spcPct val="140013"/>
+              </a:lnSpc>
+              <a:buClr>
                 <a:srgbClr val="12312B"/>
-              </a:solidFill>
+              </a:buClr>
+              <a:buSzPts val="3009"/>
+              <a:buFont typeface="Archivo Medium"/>
+              <a:buChar char="•"/>
+            </a:pPr>
+            <a:endParaRPr lang="en-US" dirty="0">
               <a:latin typeface="Archivo Medium"/>
-              <a:ea typeface="Archivo Medium"/>
-              <a:cs typeface="Archivo Medium"/>
               <a:sym typeface="Archivo Medium"/>
             </a:endParaRPr>
           </a:p>
@@ -16917,64 +16043,35 @@
               <a:buChar char="•"/>
             </a:pPr>
             <a:r>
-              <a:rPr lang="en-US" sz="2006" kern="0" dirty="0">
-                <a:solidFill>
-                  <a:srgbClr val="12312B"/>
-                </a:solidFill>
+              <a:rPr lang="en-US" dirty="0">
                 <a:latin typeface="Archivo Medium"/>
-                <a:ea typeface="Archivo Medium"/>
-                <a:cs typeface="Archivo Medium"/>
-                <a:sym typeface="Archivo Medium"/>
               </a:rPr>
-              <a:t>Point 1</a:t>
+              <a:t>The full list of upcoming workshops is available at </a:t>
             </a:r>
-          </a:p>
-          <a:p>
-            <a:pPr marL="433260" lvl="1" indent="-216630" defTabSz="609630">
-              <a:lnSpc>
-                <a:spcPct val="140013"/>
-              </a:lnSpc>
-              <a:buClr>
-                <a:srgbClr val="12312B"/>
-              </a:buClr>
-              <a:buSzPts val="3009"/>
-              <a:buFont typeface="Archivo Medium"/>
-              <a:buChar char="•"/>
-            </a:pPr>
-            <a:endParaRPr lang="en-US" sz="2006" kern="0" dirty="0">
-              <a:solidFill>
-                <a:srgbClr val="12312B"/>
-              </a:solidFill>
+            <a:r>
+              <a:rPr lang="en-US" dirty="0">
+                <a:latin typeface="Archivo Medium"/>
+                <a:hlinkClick r:id="rId3"/>
+              </a:rPr>
+              <a:t>dartgo.org/</a:t>
+            </a:r>
+            <a:r>
+              <a:rPr lang="en-US" dirty="0" err="1">
+                <a:latin typeface="Archivo Medium"/>
+                <a:hlinkClick r:id="rId3"/>
+              </a:rPr>
+              <a:t>RRADworkshops</a:t>
+            </a:r>
+            <a:r>
+              <a:rPr lang="en-US" dirty="0">
+                <a:latin typeface="Archivo Medium"/>
+                <a:hlinkClick r:id="rId3"/>
+              </a:rPr>
+              <a:t>  </a:t>
+            </a:r>
+            <a:endParaRPr lang="en-US" dirty="0">
               <a:latin typeface="Archivo Medium"/>
-              <a:ea typeface="Archivo Medium"/>
-              <a:cs typeface="Archivo Medium"/>
-              <a:sym typeface="Archivo Medium"/>
             </a:endParaRPr>
-          </a:p>
-          <a:p>
-            <a:pPr marL="433260" lvl="1" indent="-216630" defTabSz="609630">
-              <a:lnSpc>
-                <a:spcPct val="140013"/>
-              </a:lnSpc>
-              <a:buClr>
-                <a:srgbClr val="12312B"/>
-              </a:buClr>
-              <a:buSzPts val="3009"/>
-              <a:buFont typeface="Archivo Medium"/>
-              <a:buChar char="•"/>
-            </a:pPr>
-            <a:r>
-              <a:rPr lang="en-US" sz="2006" kern="0" dirty="0">
-                <a:solidFill>
-                  <a:srgbClr val="12312B"/>
-                </a:solidFill>
-                <a:latin typeface="Archivo Medium"/>
-                <a:ea typeface="Archivo Medium"/>
-                <a:cs typeface="Archivo Medium"/>
-                <a:sym typeface="Archivo Medium"/>
-              </a:rPr>
-              <a:t>Point 2</a:t>
-            </a:r>
           </a:p>
           <a:p>
             <a:pPr marL="866521" lvl="2" indent="-288840" defTabSz="609630">
@@ -16992,7 +16089,7 @@
               <a:rPr lang="en-US" sz="1600" dirty="0">
                 <a:sym typeface="Archivo Medium"/>
               </a:rPr>
-              <a:t>Subpoint 1</a:t>
+              <a:t>Most are online</a:t>
             </a:r>
           </a:p>
           <a:p>
@@ -17009,10 +16106,38 @@
             </a:pPr>
             <a:r>
               <a:rPr lang="en-US" sz="1600" dirty="0">
+                <a:highlight>
+                  <a:srgbClr val="FFFF00"/>
+                </a:highlight>
                 <a:sym typeface="Archivo Medium"/>
               </a:rPr>
-              <a:t>Subpoint 2</a:t>
+              <a:t>Upcoming workshops related to today’s are listed at the end of this presentation</a:t>
             </a:r>
+            <a:r>
+              <a:rPr lang="en-US" sz="1600" dirty="0">
+                <a:sym typeface="Archivo Medium"/>
+              </a:rPr>
+              <a:t>.</a:t>
+            </a:r>
+            <a:endParaRPr sz="1600" dirty="0">
+              <a:sym typeface="Archivo Medium"/>
+            </a:endParaRPr>
+          </a:p>
+          <a:p>
+            <a:pPr marL="866521" lvl="2" indent="-288840" defTabSz="609630">
+              <a:lnSpc>
+                <a:spcPct val="140013"/>
+              </a:lnSpc>
+              <a:buClr>
+                <a:srgbClr val="12312B"/>
+              </a:buClr>
+              <a:buSzPts val="3009"/>
+              <a:buFont typeface="Archivo Medium"/>
+              <a:buChar char="⚬"/>
+            </a:pPr>
+            <a:endParaRPr lang="en-US" sz="1600" dirty="0">
+              <a:latin typeface="Archivo Medium"/>
+            </a:endParaRPr>
           </a:p>
           <a:p>
             <a:pPr marL="433260" lvl="1" indent="-216630" defTabSz="609630">
@@ -17025,37 +16150,22 @@
               <a:buSzPts val="3009"/>
               <a:buFont typeface="Archivo Medium"/>
               <a:buChar char="•"/>
+              <a:defRPr/>
             </a:pPr>
-            <a:endParaRPr lang="en-US" sz="2006" kern="0" dirty="0">
+            <a:r>
+              <a:rPr lang="en-US" dirty="0">
+                <a:latin typeface="Archivo Medium"/>
+              </a:rPr>
+              <a:t>If you need help with something that isn’t the subject of a workshop or need it before we’re offering the relevant workshop, please reach out!</a:t>
+            </a:r>
+            <a:endParaRPr sz="2006" kern="0" dirty="0">
               <a:solidFill>
                 <a:srgbClr val="12312B"/>
               </a:solidFill>
               <a:latin typeface="Archivo Medium"/>
-              <a:ea typeface="Archivo Medium"/>
-              <a:cs typeface="Archivo Medium"/>
-              <a:sym typeface="Archivo Medium"/>
-            </a:endParaRPr>
-          </a:p>
-          <a:p>
-            <a:pPr marL="433260" lvl="1" indent="-216630" defTabSz="609630">
-              <a:lnSpc>
-                <a:spcPct val="140013"/>
-              </a:lnSpc>
-              <a:buClr>
-                <a:srgbClr val="12312B"/>
-              </a:buClr>
-              <a:buSzPts val="3009"/>
-              <a:buFont typeface="Archivo Medium"/>
-              <a:buChar char="•"/>
-            </a:pPr>
-            <a:endParaRPr lang="en-US" sz="2006" kern="0" dirty="0">
-              <a:solidFill>
-                <a:srgbClr val="12312B"/>
-              </a:solidFill>
-              <a:latin typeface="Archivo Medium"/>
-              <a:ea typeface="Archivo Medium"/>
-              <a:cs typeface="Archivo Medium"/>
-              <a:sym typeface="Archivo Medium"/>
+              <a:ea typeface="Arial"/>
+              <a:cs typeface="Arial"/>
+              <a:sym typeface="Arial"/>
             </a:endParaRPr>
           </a:p>
         </p:txBody>
@@ -17063,127 +16173,17 @@
     </p:spTree>
     <p:extLst>
       <p:ext uri="{BB962C8B-B14F-4D97-AF65-F5344CB8AC3E}">
-        <p14:creationId xmlns:p14="http://schemas.microsoft.com/office/powerpoint/2010/main" val="3594546687"/>
+        <p14:creationId xmlns:p14="http://schemas.microsoft.com/office/powerpoint/2010/main" val="713113970"/>
       </p:ext>
     </p:extLst>
   </p:cSld>
   <p:clrMapOvr>
     <a:masterClrMapping/>
   </p:clrMapOvr>
-  <p:timing>
-    <p:tnLst>
-      <p:par>
-        <p:cTn id="1" dur="indefinite" restart="never" nodeType="tmRoot">
-          <p:childTnLst>
-            <p:seq concurrent="1" nextAc="seek">
-              <p:cTn id="2" dur="indefinite" nodeType="mainSeq">
-                <p:childTnLst>
-                  <p:par>
-                    <p:cTn id="3" fill="hold">
-                      <p:stCondLst>
-                        <p:cond delay="indefinite"/>
-                      </p:stCondLst>
-                      <p:childTnLst>
-                        <p:par>
-                          <p:cTn id="4" fill="hold">
-                            <p:stCondLst>
-                              <p:cond delay="0"/>
-                            </p:stCondLst>
-                            <p:childTnLst>
-                              <p:par>
-                                <p:cTn id="5" presetID="1" presetClass="entr" presetSubtype="0" fill="hold" nodeType="clickEffect">
-                                  <p:stCondLst>
-                                    <p:cond delay="0"/>
-                                  </p:stCondLst>
-                                  <p:childTnLst>
-                                    <p:set>
-                                      <p:cBhvr>
-                                        <p:cTn id="6" dur="1" fill="hold">
-                                          <p:stCondLst>
-                                            <p:cond delay="0"/>
-                                          </p:stCondLst>
-                                        </p:cTn>
-                                        <p:tgtEl>
-                                          <p:spTgt spid="142">
-                                            <p:txEl>
-                                              <p:pRg st="3" end="3"/>
-                                            </p:txEl>
-                                          </p:spTgt>
-                                        </p:tgtEl>
-                                        <p:attrNameLst>
-                                          <p:attrName>style.visibility</p:attrName>
-                                        </p:attrNameLst>
-                                      </p:cBhvr>
-                                      <p:to>
-                                        <p:strVal val="visible"/>
-                                      </p:to>
-                                    </p:set>
-                                  </p:childTnLst>
-                                </p:cTn>
-                              </p:par>
-                              <p:par>
-                                <p:cTn id="7" presetID="1" presetClass="entr" presetSubtype="0" fill="hold" nodeType="withEffect">
-                                  <p:stCondLst>
-                                    <p:cond delay="0"/>
-                                  </p:stCondLst>
-                                  <p:childTnLst>
-                                    <p:set>
-                                      <p:cBhvr>
-                                        <p:cTn id="8" dur="1" fill="hold">
-                                          <p:stCondLst>
-                                            <p:cond delay="0"/>
-                                          </p:stCondLst>
-                                        </p:cTn>
-                                        <p:tgtEl>
-                                          <p:spTgt spid="142">
-                                            <p:txEl>
-                                              <p:pRg st="4" end="4"/>
-                                            </p:txEl>
-                                          </p:spTgt>
-                                        </p:tgtEl>
-                                        <p:attrNameLst>
-                                          <p:attrName>style.visibility</p:attrName>
-                                        </p:attrNameLst>
-                                      </p:cBhvr>
-                                      <p:to>
-                                        <p:strVal val="visible"/>
-                                      </p:to>
-                                    </p:set>
-                                  </p:childTnLst>
-                                </p:cTn>
-                              </p:par>
-                            </p:childTnLst>
-                          </p:cTn>
-                        </p:par>
-                      </p:childTnLst>
-                    </p:cTn>
-                  </p:par>
-                </p:childTnLst>
-              </p:cTn>
-              <p:prevCondLst>
-                <p:cond evt="onPrev" delay="0">
-                  <p:tgtEl>
-                    <p:sldTgt/>
-                  </p:tgtEl>
-                </p:cond>
-              </p:prevCondLst>
-              <p:nextCondLst>
-                <p:cond evt="onNext" delay="0">
-                  <p:tgtEl>
-                    <p:sldTgt/>
-                  </p:tgtEl>
-                </p:cond>
-              </p:nextCondLst>
-            </p:seq>
-          </p:childTnLst>
-        </p:cTn>
-      </p:par>
-    </p:tnLst>
-  </p:timing>
 </p:sld>
 </file>
 
-<file path=ppt/slides/slide15.xml><?xml version="1.0" encoding="utf-8"?>
+<file path=ppt/slides/slide12.xml><?xml version="1.0" encoding="utf-8"?>
 <p:sld xmlns:a="http://schemas.openxmlformats.org/drawingml/2006/main" xmlns:r="http://schemas.openxmlformats.org/officeDocument/2006/relationships" xmlns:p="http://schemas.openxmlformats.org/presentationml/2006/main">
   <p:cSld>
     <p:spTree>
@@ -17591,7 +16591,7 @@
 </p:sld>
 </file>
 
-<file path=ppt/slides/slide16.xml><?xml version="1.0" encoding="utf-8"?>
+<file path=ppt/slides/slide13.xml><?xml version="1.0" encoding="utf-8"?>
 <p:sld xmlns:a="http://schemas.openxmlformats.org/drawingml/2006/main" xmlns:r="http://schemas.openxmlformats.org/officeDocument/2006/relationships" xmlns:p="http://schemas.openxmlformats.org/presentationml/2006/main">
   <p:cSld>
     <p:spTree>
@@ -18005,179 +17005,7 @@
 </p:sld>
 </file>
 
-<file path=ppt/slides/slide17.xml><?xml version="1.0" encoding="utf-8"?>
-<p:sld xmlns:a="http://schemas.openxmlformats.org/drawingml/2006/main" xmlns:r="http://schemas.openxmlformats.org/officeDocument/2006/relationships" xmlns:p="http://schemas.openxmlformats.org/presentationml/2006/main">
-  <p:cSld>
-    <p:spTree>
-      <p:nvGrpSpPr>
-        <p:cNvPr id="1" name="Shape 133">
-          <a:extLst>
-            <a:ext uri="{FF2B5EF4-FFF2-40B4-BE49-F238E27FC236}">
-              <a16:creationId xmlns:a16="http://schemas.microsoft.com/office/drawing/2014/main" id="{2B114DF9-97CA-2B66-BD58-02EF311F8256}"/>
-            </a:ext>
-          </a:extLst>
-        </p:cNvPr>
-        <p:cNvGrpSpPr/>
-        <p:nvPr/>
-      </p:nvGrpSpPr>
-      <p:grpSpPr>
-        <a:xfrm>
-          <a:off x="0" y="0"/>
-          <a:ext cx="0" cy="0"/>
-          <a:chOff x="0" y="0"/>
-          <a:chExt cx="0" cy="0"/>
-        </a:xfrm>
-      </p:grpSpPr>
-      <p:sp>
-        <p:nvSpPr>
-          <p:cNvPr id="134" name="Google Shape;134;p25">
-            <a:extLst>
-              <a:ext uri="{FF2B5EF4-FFF2-40B4-BE49-F238E27FC236}">
-                <a16:creationId xmlns:a16="http://schemas.microsoft.com/office/drawing/2014/main" id="{64477353-763A-15A6-FAA3-7320FC3B4337}"/>
-              </a:ext>
-            </a:extLst>
-          </p:cNvPr>
-          <p:cNvSpPr txBox="1"/>
-          <p:nvPr/>
-        </p:nvSpPr>
-        <p:spPr>
-          <a:xfrm>
-            <a:off x="1417320" y="2148841"/>
-            <a:ext cx="9930384" cy="738664"/>
-          </a:xfrm>
-          <a:prstGeom prst="rect">
-            <a:avLst/>
-          </a:prstGeom>
-          <a:noFill/>
-          <a:ln>
-            <a:noFill/>
-          </a:ln>
-        </p:spPr>
-        <p:txBody>
-          <a:bodyPr spcFirstLastPara="1" wrap="square" lIns="0" tIns="0" rIns="0" bIns="0" anchor="t" anchorCtr="0">
-            <a:spAutoFit/>
-          </a:bodyPr>
-          <a:lstStyle/>
-          <a:p>
-            <a:pPr defTabSz="609630">
-              <a:buClr>
-                <a:srgbClr val="000000"/>
-              </a:buClr>
-            </a:pPr>
-            <a:r>
-              <a:rPr lang="en-US" sz="4800" kern="0" dirty="0">
-                <a:solidFill>
-                  <a:srgbClr val="A5D75F"/>
-                </a:solidFill>
-                <a:latin typeface="Anton"/>
-                <a:ea typeface="Anton"/>
-                <a:cs typeface="Anton"/>
-                <a:sym typeface="Anton"/>
-              </a:rPr>
-              <a:t>Questions?</a:t>
-            </a:r>
-            <a:endParaRPr sz="100" kern="0" dirty="0">
-              <a:solidFill>
-                <a:srgbClr val="A5D75F"/>
-              </a:solidFill>
-              <a:latin typeface="Anton"/>
-              <a:ea typeface="Anton"/>
-              <a:cs typeface="Anton"/>
-              <a:sym typeface="Anton"/>
-            </a:endParaRPr>
-          </a:p>
-        </p:txBody>
-      </p:sp>
-      <p:sp>
-        <p:nvSpPr>
-          <p:cNvPr id="135" name="Google Shape;135;p25">
-            <a:extLst>
-              <a:ext uri="{FF2B5EF4-FFF2-40B4-BE49-F238E27FC236}">
-                <a16:creationId xmlns:a16="http://schemas.microsoft.com/office/drawing/2014/main" id="{1CBE9B77-AEC0-E2BF-6DD1-05D68D82A90C}"/>
-              </a:ext>
-            </a:extLst>
-          </p:cNvPr>
-          <p:cNvSpPr/>
-          <p:nvPr/>
-        </p:nvSpPr>
-        <p:spPr>
-          <a:xfrm>
-            <a:off x="1065004" y="2844069"/>
-            <a:ext cx="3947264" cy="780393"/>
-          </a:xfrm>
-          <a:custGeom>
-            <a:avLst/>
-            <a:gdLst/>
-            <a:ahLst/>
-            <a:cxnLst/>
-            <a:rect l="l" t="t" r="r" b="b"/>
-            <a:pathLst>
-              <a:path w="6287497" h="938348" extrusionOk="0">
-                <a:moveTo>
-                  <a:pt x="0" y="0"/>
-                </a:moveTo>
-                <a:lnTo>
-                  <a:pt x="6287496" y="0"/>
-                </a:lnTo>
-                <a:lnTo>
-                  <a:pt x="6287496" y="938349"/>
-                </a:lnTo>
-                <a:lnTo>
-                  <a:pt x="0" y="938349"/>
-                </a:lnTo>
-                <a:lnTo>
-                  <a:pt x="0" y="0"/>
-                </a:lnTo>
-                <a:close/>
-              </a:path>
-            </a:pathLst>
-          </a:custGeom>
-          <a:blipFill rotWithShape="1">
-            <a:blip r:embed="rId3">
-              <a:alphaModFix/>
-            </a:blip>
-            <a:stretch>
-              <a:fillRect/>
-            </a:stretch>
-          </a:blipFill>
-          <a:ln>
-            <a:noFill/>
-          </a:ln>
-        </p:spPr>
-        <p:txBody>
-          <a:bodyPr/>
-          <a:lstStyle/>
-          <a:p>
-            <a:pPr defTabSz="609630">
-              <a:buClr>
-                <a:srgbClr val="000000"/>
-              </a:buClr>
-            </a:pPr>
-            <a:endParaRPr lang="en-US" sz="933" kern="0">
-              <a:solidFill>
-                <a:srgbClr val="000000"/>
-              </a:solidFill>
-              <a:latin typeface="Arial"/>
-              <a:cs typeface="Arial"/>
-              <a:sym typeface="Arial"/>
-            </a:endParaRPr>
-          </a:p>
-        </p:txBody>
-      </p:sp>
-    </p:spTree>
-    <p:extLst>
-      <p:ext uri="{BB962C8B-B14F-4D97-AF65-F5344CB8AC3E}">
-        <p14:creationId xmlns:p14="http://schemas.microsoft.com/office/powerpoint/2010/main" val="825263348"/>
-      </p:ext>
-    </p:extLst>
-  </p:cSld>
-  <p:clrMapOvr>
-    <a:masterClrMapping/>
-  </p:clrMapOvr>
-</p:sld>
-</file>
-
-<file path=ppt/slides/slide18.xml><?xml version="1.0" encoding="utf-8"?>
+<file path=ppt/slides/slide14.xml><?xml version="1.0" encoding="utf-8"?>
 <p:sld xmlns:a="http://schemas.openxmlformats.org/drawingml/2006/main" xmlns:r="http://schemas.openxmlformats.org/officeDocument/2006/relationships" xmlns:p="http://schemas.openxmlformats.org/presentationml/2006/main">
   <p:cSld>
     <p:spTree>
@@ -18505,7 +17333,7 @@
 </p:sld>
 </file>
 
-<file path=ppt/slides/slide19.xml><?xml version="1.0" encoding="utf-8"?>
+<file path=ppt/slides/slide15.xml><?xml version="1.0" encoding="utf-8"?>
 <p:sld xmlns:a="http://schemas.openxmlformats.org/drawingml/2006/main" xmlns:r="http://schemas.openxmlformats.org/officeDocument/2006/relationships" xmlns:p="http://schemas.openxmlformats.org/presentationml/2006/main">
   <p:cSld>
     <p:spTree>
@@ -20157,424 +18985,7 @@
 </p:sld>
 </file>
 
-<file path=ppt/slides/slide2.xml><?xml version="1.0" encoding="utf-8"?>
-<p:sld xmlns:a="http://schemas.openxmlformats.org/drawingml/2006/main" xmlns:r="http://schemas.openxmlformats.org/officeDocument/2006/relationships" xmlns:p="http://schemas.openxmlformats.org/presentationml/2006/main">
-  <p:cSld>
-    <p:spTree>
-      <p:nvGrpSpPr>
-        <p:cNvPr id="1" name="Shape 139">
-          <a:extLst>
-            <a:ext uri="{FF2B5EF4-FFF2-40B4-BE49-F238E27FC236}">
-              <a16:creationId xmlns:a16="http://schemas.microsoft.com/office/drawing/2014/main" id="{5F49B5EB-41A3-EB3B-9CEE-A97C8229E8B4}"/>
-            </a:ext>
-          </a:extLst>
-        </p:cNvPr>
-        <p:cNvGrpSpPr/>
-        <p:nvPr/>
-      </p:nvGrpSpPr>
-      <p:grpSpPr>
-        <a:xfrm>
-          <a:off x="0" y="0"/>
-          <a:ext cx="0" cy="0"/>
-          <a:chOff x="0" y="0"/>
-          <a:chExt cx="0" cy="0"/>
-        </a:xfrm>
-      </p:grpSpPr>
-      <p:sp>
-        <p:nvSpPr>
-          <p:cNvPr id="141" name="Google Shape;141;p26">
-            <a:extLst>
-              <a:ext uri="{FF2B5EF4-FFF2-40B4-BE49-F238E27FC236}">
-                <a16:creationId xmlns:a16="http://schemas.microsoft.com/office/drawing/2014/main" id="{F570BA1C-399F-EAD6-F0E9-8014736EF252}"/>
-              </a:ext>
-            </a:extLst>
-          </p:cNvPr>
-          <p:cNvSpPr txBox="1"/>
-          <p:nvPr/>
-        </p:nvSpPr>
-        <p:spPr>
-          <a:xfrm>
-            <a:off x="922202" y="1157695"/>
-            <a:ext cx="6097800" cy="1484765"/>
-          </a:xfrm>
-          <a:prstGeom prst="rect">
-            <a:avLst/>
-          </a:prstGeom>
-          <a:noFill/>
-          <a:ln>
-            <a:noFill/>
-          </a:ln>
-        </p:spPr>
-        <p:txBody>
-          <a:bodyPr spcFirstLastPara="1" wrap="square" lIns="0" tIns="0" rIns="0" bIns="0" anchor="t" anchorCtr="0">
-            <a:spAutoFit/>
-          </a:bodyPr>
-          <a:lstStyle/>
-          <a:p>
-            <a:pPr defTabSz="609630">
-              <a:lnSpc>
-                <a:spcPct val="140007"/>
-              </a:lnSpc>
-              <a:buClr>
-                <a:srgbClr val="000000"/>
-              </a:buClr>
-            </a:pPr>
-            <a:r>
-              <a:rPr lang="en-US" sz="3446" kern="0" dirty="0">
-                <a:solidFill>
-                  <a:srgbClr val="00693D"/>
-                </a:solidFill>
-                <a:latin typeface="Anton"/>
-                <a:ea typeface="Anton"/>
-                <a:cs typeface="Anton"/>
-                <a:sym typeface="Anton"/>
-              </a:rPr>
-              <a:t>Welcome, Introductions, Set Expectations – Jeremy?</a:t>
-            </a:r>
-            <a:endParaRPr sz="933" kern="0" dirty="0">
-              <a:solidFill>
-                <a:srgbClr val="000000"/>
-              </a:solidFill>
-              <a:latin typeface="Anton"/>
-              <a:ea typeface="Anton"/>
-              <a:cs typeface="Anton"/>
-              <a:sym typeface="Anton"/>
-            </a:endParaRPr>
-          </a:p>
-        </p:txBody>
-      </p:sp>
-      <p:sp>
-        <p:nvSpPr>
-          <p:cNvPr id="142" name="Google Shape;142;p26">
-            <a:extLst>
-              <a:ext uri="{FF2B5EF4-FFF2-40B4-BE49-F238E27FC236}">
-                <a16:creationId xmlns:a16="http://schemas.microsoft.com/office/drawing/2014/main" id="{CEF0492E-90EB-7879-1C58-587861C38DEC}"/>
-              </a:ext>
-            </a:extLst>
-          </p:cNvPr>
-          <p:cNvSpPr txBox="1"/>
-          <p:nvPr/>
-        </p:nvSpPr>
-        <p:spPr>
-          <a:xfrm>
-            <a:off x="858108" y="2719670"/>
-            <a:ext cx="9776400" cy="3282437"/>
-          </a:xfrm>
-          <a:prstGeom prst="rect">
-            <a:avLst/>
-          </a:prstGeom>
-          <a:noFill/>
-          <a:ln>
-            <a:noFill/>
-          </a:ln>
-        </p:spPr>
-        <p:txBody>
-          <a:bodyPr spcFirstLastPara="1" wrap="square" lIns="0" tIns="0" rIns="0" bIns="0" anchor="t" anchorCtr="0">
-            <a:spAutoFit/>
-          </a:bodyPr>
-          <a:lstStyle/>
-          <a:p>
-            <a:pPr marL="433260" lvl="1" indent="-216630" defTabSz="609630">
-              <a:lnSpc>
-                <a:spcPct val="140013"/>
-              </a:lnSpc>
-              <a:buClr>
-                <a:srgbClr val="12312B"/>
-              </a:buClr>
-              <a:buSzPts val="3009"/>
-              <a:buFont typeface="Archivo Medium"/>
-              <a:buChar char="•"/>
-            </a:pPr>
-            <a:endParaRPr lang="en-US" sz="2006" kern="0" dirty="0">
-              <a:solidFill>
-                <a:srgbClr val="12312B"/>
-              </a:solidFill>
-              <a:latin typeface="Archivo Medium"/>
-              <a:ea typeface="Archivo Medium"/>
-              <a:cs typeface="Archivo Medium"/>
-              <a:sym typeface="Archivo Medium"/>
-            </a:endParaRPr>
-          </a:p>
-          <a:p>
-            <a:pPr marL="433260" lvl="1" indent="-216630" defTabSz="609630">
-              <a:lnSpc>
-                <a:spcPct val="140013"/>
-              </a:lnSpc>
-              <a:buClr>
-                <a:srgbClr val="12312B"/>
-              </a:buClr>
-              <a:buSzPts val="3009"/>
-              <a:buFont typeface="Archivo Medium"/>
-              <a:buChar char="•"/>
-            </a:pPr>
-            <a:r>
-              <a:rPr lang="en-US" sz="2006" kern="0" dirty="0">
-                <a:solidFill>
-                  <a:srgbClr val="12312B"/>
-                </a:solidFill>
-                <a:latin typeface="Archivo Medium"/>
-                <a:ea typeface="Archivo Medium"/>
-                <a:cs typeface="Archivo Medium"/>
-                <a:sym typeface="Archivo Medium"/>
-              </a:rPr>
-              <a:t>Point 1</a:t>
-            </a:r>
-          </a:p>
-          <a:p>
-            <a:pPr marL="433260" lvl="1" indent="-216630" defTabSz="609630">
-              <a:lnSpc>
-                <a:spcPct val="140013"/>
-              </a:lnSpc>
-              <a:buClr>
-                <a:srgbClr val="12312B"/>
-              </a:buClr>
-              <a:buSzPts val="3009"/>
-              <a:buFont typeface="Archivo Medium"/>
-              <a:buChar char="•"/>
-            </a:pPr>
-            <a:endParaRPr lang="en-US" sz="2006" kern="0" dirty="0">
-              <a:solidFill>
-                <a:srgbClr val="12312B"/>
-              </a:solidFill>
-              <a:latin typeface="Archivo Medium"/>
-              <a:ea typeface="Archivo Medium"/>
-              <a:cs typeface="Archivo Medium"/>
-              <a:sym typeface="Archivo Medium"/>
-            </a:endParaRPr>
-          </a:p>
-          <a:p>
-            <a:pPr marL="433260" lvl="1" indent="-216630" defTabSz="609630">
-              <a:lnSpc>
-                <a:spcPct val="140013"/>
-              </a:lnSpc>
-              <a:buClr>
-                <a:srgbClr val="12312B"/>
-              </a:buClr>
-              <a:buSzPts val="3009"/>
-              <a:buFont typeface="Archivo Medium"/>
-              <a:buChar char="•"/>
-            </a:pPr>
-            <a:r>
-              <a:rPr lang="en-US" sz="2006" kern="0" dirty="0">
-                <a:solidFill>
-                  <a:srgbClr val="12312B"/>
-                </a:solidFill>
-                <a:latin typeface="Archivo Medium"/>
-                <a:ea typeface="Archivo Medium"/>
-                <a:cs typeface="Archivo Medium"/>
-                <a:sym typeface="Archivo Medium"/>
-              </a:rPr>
-              <a:t>Point 2</a:t>
-            </a:r>
-          </a:p>
-          <a:p>
-            <a:pPr marL="866521" lvl="2" indent="-288840" defTabSz="609630">
-              <a:lnSpc>
-                <a:spcPct val="140013"/>
-              </a:lnSpc>
-              <a:buClr>
-                <a:srgbClr val="12312B"/>
-              </a:buClr>
-              <a:buSzPts val="3009"/>
-              <a:buFont typeface="Archivo Medium"/>
-              <a:buChar char="⚬"/>
-            </a:pPr>
-            <a:r>
-              <a:rPr lang="en-US" sz="1600" dirty="0">
-                <a:sym typeface="Archivo Medium"/>
-              </a:rPr>
-              <a:t>Subpoint 1</a:t>
-            </a:r>
-          </a:p>
-          <a:p>
-            <a:pPr marL="866521" lvl="2" indent="-288840" defTabSz="609630">
-              <a:lnSpc>
-                <a:spcPct val="140013"/>
-              </a:lnSpc>
-              <a:buClr>
-                <a:srgbClr val="12312B"/>
-              </a:buClr>
-              <a:buSzPts val="3009"/>
-              <a:buFont typeface="Archivo Medium"/>
-              <a:buChar char="⚬"/>
-            </a:pPr>
-            <a:r>
-              <a:rPr lang="en-US" sz="1600" dirty="0">
-                <a:sym typeface="Archivo Medium"/>
-              </a:rPr>
-              <a:t>Subpoint 2</a:t>
-            </a:r>
-          </a:p>
-          <a:p>
-            <a:pPr marL="433260" lvl="1" indent="-216630" defTabSz="609630">
-              <a:lnSpc>
-                <a:spcPct val="140013"/>
-              </a:lnSpc>
-              <a:buClr>
-                <a:srgbClr val="12312B"/>
-              </a:buClr>
-              <a:buSzPts val="3009"/>
-              <a:buFont typeface="Archivo Medium"/>
-              <a:buChar char="•"/>
-            </a:pPr>
-            <a:endParaRPr lang="en-US" sz="2006" kern="0" dirty="0">
-              <a:solidFill>
-                <a:srgbClr val="12312B"/>
-              </a:solidFill>
-              <a:latin typeface="Archivo Medium"/>
-              <a:ea typeface="Archivo Medium"/>
-              <a:cs typeface="Archivo Medium"/>
-              <a:sym typeface="Archivo Medium"/>
-            </a:endParaRPr>
-          </a:p>
-          <a:p>
-            <a:pPr marL="433260" lvl="1" indent="-216630" defTabSz="609630">
-              <a:lnSpc>
-                <a:spcPct val="140013"/>
-              </a:lnSpc>
-              <a:buClr>
-                <a:srgbClr val="12312B"/>
-              </a:buClr>
-              <a:buSzPts val="3009"/>
-              <a:buFont typeface="Archivo Medium"/>
-              <a:buChar char="•"/>
-            </a:pPr>
-            <a:endParaRPr lang="en-US" sz="2006" kern="0" dirty="0">
-              <a:solidFill>
-                <a:srgbClr val="12312B"/>
-              </a:solidFill>
-              <a:latin typeface="Archivo Medium"/>
-              <a:ea typeface="Archivo Medium"/>
-              <a:cs typeface="Archivo Medium"/>
-              <a:sym typeface="Archivo Medium"/>
-            </a:endParaRPr>
-          </a:p>
-        </p:txBody>
-      </p:sp>
-    </p:spTree>
-    <p:extLst>
-      <p:ext uri="{BB962C8B-B14F-4D97-AF65-F5344CB8AC3E}">
-        <p14:creationId xmlns:p14="http://schemas.microsoft.com/office/powerpoint/2010/main" val="3691630995"/>
-      </p:ext>
-    </p:extLst>
-  </p:cSld>
-  <p:clrMapOvr>
-    <a:masterClrMapping/>
-  </p:clrMapOvr>
-  <p:timing>
-    <p:tnLst>
-      <p:par>
-        <p:cTn id="1" dur="indefinite" restart="never" nodeType="tmRoot">
-          <p:childTnLst>
-            <p:seq concurrent="1" nextAc="seek">
-              <p:cTn id="2" dur="indefinite" nodeType="mainSeq">
-                <p:childTnLst>
-                  <p:par>
-                    <p:cTn id="3" fill="hold">
-                      <p:stCondLst>
-                        <p:cond delay="indefinite"/>
-                      </p:stCondLst>
-                      <p:childTnLst>
-                        <p:par>
-                          <p:cTn id="4" fill="hold">
-                            <p:stCondLst>
-                              <p:cond delay="0"/>
-                            </p:stCondLst>
-                            <p:childTnLst>
-                              <p:par>
-                                <p:cTn id="5" presetID="1" presetClass="entr" presetSubtype="0" fill="hold" nodeType="clickEffect">
-                                  <p:stCondLst>
-                                    <p:cond delay="0"/>
-                                  </p:stCondLst>
-                                  <p:childTnLst>
-                                    <p:set>
-                                      <p:cBhvr>
-                                        <p:cTn id="6" dur="1" fill="hold">
-                                          <p:stCondLst>
-                                            <p:cond delay="0"/>
-                                          </p:stCondLst>
-                                        </p:cTn>
-                                        <p:tgtEl>
-                                          <p:spTgt spid="142">
-                                            <p:txEl>
-                                              <p:pRg st="3" end="3"/>
-                                            </p:txEl>
-                                          </p:spTgt>
-                                        </p:tgtEl>
-                                        <p:attrNameLst>
-                                          <p:attrName>style.visibility</p:attrName>
-                                        </p:attrNameLst>
-                                      </p:cBhvr>
-                                      <p:to>
-                                        <p:strVal val="visible"/>
-                                      </p:to>
-                                    </p:set>
-                                  </p:childTnLst>
-                                </p:cTn>
-                              </p:par>
-                              <p:par>
-                                <p:cTn id="7" presetID="1" presetClass="entr" presetSubtype="0" fill="hold" nodeType="withEffect">
-                                  <p:stCondLst>
-                                    <p:cond delay="0"/>
-                                  </p:stCondLst>
-                                  <p:childTnLst>
-                                    <p:set>
-                                      <p:cBhvr>
-                                        <p:cTn id="8" dur="1" fill="hold">
-                                          <p:stCondLst>
-                                            <p:cond delay="0"/>
-                                          </p:stCondLst>
-                                        </p:cTn>
-                                        <p:tgtEl>
-                                          <p:spTgt spid="142">
-                                            <p:txEl>
-                                              <p:pRg st="4" end="4"/>
-                                            </p:txEl>
-                                          </p:spTgt>
-                                        </p:tgtEl>
-                                        <p:attrNameLst>
-                                          <p:attrName>style.visibility</p:attrName>
-                                        </p:attrNameLst>
-                                      </p:cBhvr>
-                                      <p:to>
-                                        <p:strVal val="visible"/>
-                                      </p:to>
-                                    </p:set>
-                                  </p:childTnLst>
-                                </p:cTn>
-                              </p:par>
-                            </p:childTnLst>
-                          </p:cTn>
-                        </p:par>
-                      </p:childTnLst>
-                    </p:cTn>
-                  </p:par>
-                </p:childTnLst>
-              </p:cTn>
-              <p:prevCondLst>
-                <p:cond evt="onPrev" delay="0">
-                  <p:tgtEl>
-                    <p:sldTgt/>
-                  </p:tgtEl>
-                </p:cond>
-              </p:prevCondLst>
-              <p:nextCondLst>
-                <p:cond evt="onNext" delay="0">
-                  <p:tgtEl>
-                    <p:sldTgt/>
-                  </p:tgtEl>
-                </p:cond>
-              </p:nextCondLst>
-            </p:seq>
-          </p:childTnLst>
-        </p:cTn>
-      </p:par>
-    </p:tnLst>
-  </p:timing>
-</p:sld>
-</file>
-
-<file path=ppt/slides/slide20.xml><?xml version="1.0" encoding="utf-8"?>
+<file path=ppt/slides/slide16.xml><?xml version="1.0" encoding="utf-8"?>
 <p:sld xmlns:a="http://schemas.openxmlformats.org/drawingml/2006/main" xmlns:r="http://schemas.openxmlformats.org/officeDocument/2006/relationships" xmlns:p="http://schemas.openxmlformats.org/presentationml/2006/main">
   <p:cSld>
     <p:spTree>
@@ -21742,6 +20153,423 @@
 </p:sld>
 </file>
 
+<file path=ppt/slides/slide2.xml><?xml version="1.0" encoding="utf-8"?>
+<p:sld xmlns:a="http://schemas.openxmlformats.org/drawingml/2006/main" xmlns:r="http://schemas.openxmlformats.org/officeDocument/2006/relationships" xmlns:p="http://schemas.openxmlformats.org/presentationml/2006/main">
+  <p:cSld>
+    <p:spTree>
+      <p:nvGrpSpPr>
+        <p:cNvPr id="1" name="Shape 139">
+          <a:extLst>
+            <a:ext uri="{FF2B5EF4-FFF2-40B4-BE49-F238E27FC236}">
+              <a16:creationId xmlns:a16="http://schemas.microsoft.com/office/drawing/2014/main" id="{5F49B5EB-41A3-EB3B-9CEE-A97C8229E8B4}"/>
+            </a:ext>
+          </a:extLst>
+        </p:cNvPr>
+        <p:cNvGrpSpPr/>
+        <p:nvPr/>
+      </p:nvGrpSpPr>
+      <p:grpSpPr>
+        <a:xfrm>
+          <a:off x="0" y="0"/>
+          <a:ext cx="0" cy="0"/>
+          <a:chOff x="0" y="0"/>
+          <a:chExt cx="0" cy="0"/>
+        </a:xfrm>
+      </p:grpSpPr>
+      <p:sp>
+        <p:nvSpPr>
+          <p:cNvPr id="141" name="Google Shape;141;p26">
+            <a:extLst>
+              <a:ext uri="{FF2B5EF4-FFF2-40B4-BE49-F238E27FC236}">
+                <a16:creationId xmlns:a16="http://schemas.microsoft.com/office/drawing/2014/main" id="{F570BA1C-399F-EAD6-F0E9-8014736EF252}"/>
+              </a:ext>
+            </a:extLst>
+          </p:cNvPr>
+          <p:cNvSpPr txBox="1"/>
+          <p:nvPr/>
+        </p:nvSpPr>
+        <p:spPr>
+          <a:xfrm>
+            <a:off x="922202" y="1157695"/>
+            <a:ext cx="6097800" cy="1484765"/>
+          </a:xfrm>
+          <a:prstGeom prst="rect">
+            <a:avLst/>
+          </a:prstGeom>
+          <a:noFill/>
+          <a:ln>
+            <a:noFill/>
+          </a:ln>
+        </p:spPr>
+        <p:txBody>
+          <a:bodyPr spcFirstLastPara="1" wrap="square" lIns="0" tIns="0" rIns="0" bIns="0" anchor="t" anchorCtr="0">
+            <a:spAutoFit/>
+          </a:bodyPr>
+          <a:lstStyle/>
+          <a:p>
+            <a:pPr defTabSz="609630">
+              <a:lnSpc>
+                <a:spcPct val="140007"/>
+              </a:lnSpc>
+              <a:buClr>
+                <a:srgbClr val="000000"/>
+              </a:buClr>
+            </a:pPr>
+            <a:r>
+              <a:rPr lang="en-US" sz="3446" kern="0" dirty="0">
+                <a:solidFill>
+                  <a:srgbClr val="00693D"/>
+                </a:solidFill>
+                <a:latin typeface="Anton"/>
+                <a:ea typeface="Anton"/>
+                <a:cs typeface="Anton"/>
+                <a:sym typeface="Anton"/>
+              </a:rPr>
+              <a:t>Welcome, Introductions, Set Expectations – Jeremy?</a:t>
+            </a:r>
+            <a:endParaRPr sz="933" kern="0" dirty="0">
+              <a:solidFill>
+                <a:srgbClr val="000000"/>
+              </a:solidFill>
+              <a:latin typeface="Anton"/>
+              <a:ea typeface="Anton"/>
+              <a:cs typeface="Anton"/>
+              <a:sym typeface="Anton"/>
+            </a:endParaRPr>
+          </a:p>
+        </p:txBody>
+      </p:sp>
+      <p:sp>
+        <p:nvSpPr>
+          <p:cNvPr id="142" name="Google Shape;142;p26">
+            <a:extLst>
+              <a:ext uri="{FF2B5EF4-FFF2-40B4-BE49-F238E27FC236}">
+                <a16:creationId xmlns:a16="http://schemas.microsoft.com/office/drawing/2014/main" id="{CEF0492E-90EB-7879-1C58-587861C38DEC}"/>
+              </a:ext>
+            </a:extLst>
+          </p:cNvPr>
+          <p:cNvSpPr txBox="1"/>
+          <p:nvPr/>
+        </p:nvSpPr>
+        <p:spPr>
+          <a:xfrm>
+            <a:off x="858108" y="2719670"/>
+            <a:ext cx="9776400" cy="3282437"/>
+          </a:xfrm>
+          <a:prstGeom prst="rect">
+            <a:avLst/>
+          </a:prstGeom>
+          <a:noFill/>
+          <a:ln>
+            <a:noFill/>
+          </a:ln>
+        </p:spPr>
+        <p:txBody>
+          <a:bodyPr spcFirstLastPara="1" wrap="square" lIns="0" tIns="0" rIns="0" bIns="0" anchor="t" anchorCtr="0">
+            <a:spAutoFit/>
+          </a:bodyPr>
+          <a:lstStyle/>
+          <a:p>
+            <a:pPr marL="433260" lvl="1" indent="-216630" defTabSz="609630">
+              <a:lnSpc>
+                <a:spcPct val="140013"/>
+              </a:lnSpc>
+              <a:buClr>
+                <a:srgbClr val="12312B"/>
+              </a:buClr>
+              <a:buSzPts val="3009"/>
+              <a:buFont typeface="Archivo Medium"/>
+              <a:buChar char="•"/>
+            </a:pPr>
+            <a:endParaRPr lang="en-US" sz="2006" kern="0" dirty="0">
+              <a:solidFill>
+                <a:srgbClr val="12312B"/>
+              </a:solidFill>
+              <a:latin typeface="Archivo Medium"/>
+              <a:ea typeface="Archivo Medium"/>
+              <a:cs typeface="Archivo Medium"/>
+              <a:sym typeface="Archivo Medium"/>
+            </a:endParaRPr>
+          </a:p>
+          <a:p>
+            <a:pPr marL="433260" lvl="1" indent="-216630" defTabSz="609630">
+              <a:lnSpc>
+                <a:spcPct val="140013"/>
+              </a:lnSpc>
+              <a:buClr>
+                <a:srgbClr val="12312B"/>
+              </a:buClr>
+              <a:buSzPts val="3009"/>
+              <a:buFont typeface="Archivo Medium"/>
+              <a:buChar char="•"/>
+            </a:pPr>
+            <a:r>
+              <a:rPr lang="en-US" sz="2006" kern="0" dirty="0">
+                <a:solidFill>
+                  <a:srgbClr val="12312B"/>
+                </a:solidFill>
+                <a:latin typeface="Archivo Medium"/>
+                <a:ea typeface="Archivo Medium"/>
+                <a:cs typeface="Archivo Medium"/>
+                <a:sym typeface="Archivo Medium"/>
+              </a:rPr>
+              <a:t>Point 1</a:t>
+            </a:r>
+          </a:p>
+          <a:p>
+            <a:pPr marL="433260" lvl="1" indent="-216630" defTabSz="609630">
+              <a:lnSpc>
+                <a:spcPct val="140013"/>
+              </a:lnSpc>
+              <a:buClr>
+                <a:srgbClr val="12312B"/>
+              </a:buClr>
+              <a:buSzPts val="3009"/>
+              <a:buFont typeface="Archivo Medium"/>
+              <a:buChar char="•"/>
+            </a:pPr>
+            <a:endParaRPr lang="en-US" sz="2006" kern="0" dirty="0">
+              <a:solidFill>
+                <a:srgbClr val="12312B"/>
+              </a:solidFill>
+              <a:latin typeface="Archivo Medium"/>
+              <a:ea typeface="Archivo Medium"/>
+              <a:cs typeface="Archivo Medium"/>
+              <a:sym typeface="Archivo Medium"/>
+            </a:endParaRPr>
+          </a:p>
+          <a:p>
+            <a:pPr marL="433260" lvl="1" indent="-216630" defTabSz="609630">
+              <a:lnSpc>
+                <a:spcPct val="140013"/>
+              </a:lnSpc>
+              <a:buClr>
+                <a:srgbClr val="12312B"/>
+              </a:buClr>
+              <a:buSzPts val="3009"/>
+              <a:buFont typeface="Archivo Medium"/>
+              <a:buChar char="•"/>
+            </a:pPr>
+            <a:r>
+              <a:rPr lang="en-US" sz="2006" kern="0" dirty="0">
+                <a:solidFill>
+                  <a:srgbClr val="12312B"/>
+                </a:solidFill>
+                <a:latin typeface="Archivo Medium"/>
+                <a:ea typeface="Archivo Medium"/>
+                <a:cs typeface="Archivo Medium"/>
+                <a:sym typeface="Archivo Medium"/>
+              </a:rPr>
+              <a:t>Point 2</a:t>
+            </a:r>
+          </a:p>
+          <a:p>
+            <a:pPr marL="866521" lvl="2" indent="-288840" defTabSz="609630">
+              <a:lnSpc>
+                <a:spcPct val="140013"/>
+              </a:lnSpc>
+              <a:buClr>
+                <a:srgbClr val="12312B"/>
+              </a:buClr>
+              <a:buSzPts val="3009"/>
+              <a:buFont typeface="Archivo Medium"/>
+              <a:buChar char="⚬"/>
+            </a:pPr>
+            <a:r>
+              <a:rPr lang="en-US" sz="1600" dirty="0">
+                <a:sym typeface="Archivo Medium"/>
+              </a:rPr>
+              <a:t>Subpoint 1</a:t>
+            </a:r>
+          </a:p>
+          <a:p>
+            <a:pPr marL="866521" lvl="2" indent="-288840" defTabSz="609630">
+              <a:lnSpc>
+                <a:spcPct val="140013"/>
+              </a:lnSpc>
+              <a:buClr>
+                <a:srgbClr val="12312B"/>
+              </a:buClr>
+              <a:buSzPts val="3009"/>
+              <a:buFont typeface="Archivo Medium"/>
+              <a:buChar char="⚬"/>
+            </a:pPr>
+            <a:r>
+              <a:rPr lang="en-US" sz="1600" dirty="0">
+                <a:sym typeface="Archivo Medium"/>
+              </a:rPr>
+              <a:t>Subpoint 2</a:t>
+            </a:r>
+          </a:p>
+          <a:p>
+            <a:pPr marL="433260" lvl="1" indent="-216630" defTabSz="609630">
+              <a:lnSpc>
+                <a:spcPct val="140013"/>
+              </a:lnSpc>
+              <a:buClr>
+                <a:srgbClr val="12312B"/>
+              </a:buClr>
+              <a:buSzPts val="3009"/>
+              <a:buFont typeface="Archivo Medium"/>
+              <a:buChar char="•"/>
+            </a:pPr>
+            <a:endParaRPr lang="en-US" sz="2006" kern="0" dirty="0">
+              <a:solidFill>
+                <a:srgbClr val="12312B"/>
+              </a:solidFill>
+              <a:latin typeface="Archivo Medium"/>
+              <a:ea typeface="Archivo Medium"/>
+              <a:cs typeface="Archivo Medium"/>
+              <a:sym typeface="Archivo Medium"/>
+            </a:endParaRPr>
+          </a:p>
+          <a:p>
+            <a:pPr marL="433260" lvl="1" indent="-216630" defTabSz="609630">
+              <a:lnSpc>
+                <a:spcPct val="140013"/>
+              </a:lnSpc>
+              <a:buClr>
+                <a:srgbClr val="12312B"/>
+              </a:buClr>
+              <a:buSzPts val="3009"/>
+              <a:buFont typeface="Archivo Medium"/>
+              <a:buChar char="•"/>
+            </a:pPr>
+            <a:endParaRPr lang="en-US" sz="2006" kern="0" dirty="0">
+              <a:solidFill>
+                <a:srgbClr val="12312B"/>
+              </a:solidFill>
+              <a:latin typeface="Archivo Medium"/>
+              <a:ea typeface="Archivo Medium"/>
+              <a:cs typeface="Archivo Medium"/>
+              <a:sym typeface="Archivo Medium"/>
+            </a:endParaRPr>
+          </a:p>
+        </p:txBody>
+      </p:sp>
+    </p:spTree>
+    <p:extLst>
+      <p:ext uri="{BB962C8B-B14F-4D97-AF65-F5344CB8AC3E}">
+        <p14:creationId xmlns:p14="http://schemas.microsoft.com/office/powerpoint/2010/main" val="3691630995"/>
+      </p:ext>
+    </p:extLst>
+  </p:cSld>
+  <p:clrMapOvr>
+    <a:masterClrMapping/>
+  </p:clrMapOvr>
+  <p:timing>
+    <p:tnLst>
+      <p:par>
+        <p:cTn id="1" dur="indefinite" restart="never" nodeType="tmRoot">
+          <p:childTnLst>
+            <p:seq concurrent="1" nextAc="seek">
+              <p:cTn id="2" dur="indefinite" nodeType="mainSeq">
+                <p:childTnLst>
+                  <p:par>
+                    <p:cTn id="3" fill="hold">
+                      <p:stCondLst>
+                        <p:cond delay="indefinite"/>
+                      </p:stCondLst>
+                      <p:childTnLst>
+                        <p:par>
+                          <p:cTn id="4" fill="hold">
+                            <p:stCondLst>
+                              <p:cond delay="0"/>
+                            </p:stCondLst>
+                            <p:childTnLst>
+                              <p:par>
+                                <p:cTn id="5" presetID="1" presetClass="entr" presetSubtype="0" fill="hold" nodeType="clickEffect">
+                                  <p:stCondLst>
+                                    <p:cond delay="0"/>
+                                  </p:stCondLst>
+                                  <p:childTnLst>
+                                    <p:set>
+                                      <p:cBhvr>
+                                        <p:cTn id="6" dur="1" fill="hold">
+                                          <p:stCondLst>
+                                            <p:cond delay="0"/>
+                                          </p:stCondLst>
+                                        </p:cTn>
+                                        <p:tgtEl>
+                                          <p:spTgt spid="142">
+                                            <p:txEl>
+                                              <p:pRg st="3" end="3"/>
+                                            </p:txEl>
+                                          </p:spTgt>
+                                        </p:tgtEl>
+                                        <p:attrNameLst>
+                                          <p:attrName>style.visibility</p:attrName>
+                                        </p:attrNameLst>
+                                      </p:cBhvr>
+                                      <p:to>
+                                        <p:strVal val="visible"/>
+                                      </p:to>
+                                    </p:set>
+                                  </p:childTnLst>
+                                </p:cTn>
+                              </p:par>
+                              <p:par>
+                                <p:cTn id="7" presetID="1" presetClass="entr" presetSubtype="0" fill="hold" nodeType="withEffect">
+                                  <p:stCondLst>
+                                    <p:cond delay="0"/>
+                                  </p:stCondLst>
+                                  <p:childTnLst>
+                                    <p:set>
+                                      <p:cBhvr>
+                                        <p:cTn id="8" dur="1" fill="hold">
+                                          <p:stCondLst>
+                                            <p:cond delay="0"/>
+                                          </p:stCondLst>
+                                        </p:cTn>
+                                        <p:tgtEl>
+                                          <p:spTgt spid="142">
+                                            <p:txEl>
+                                              <p:pRg st="4" end="4"/>
+                                            </p:txEl>
+                                          </p:spTgt>
+                                        </p:tgtEl>
+                                        <p:attrNameLst>
+                                          <p:attrName>style.visibility</p:attrName>
+                                        </p:attrNameLst>
+                                      </p:cBhvr>
+                                      <p:to>
+                                        <p:strVal val="visible"/>
+                                      </p:to>
+                                    </p:set>
+                                  </p:childTnLst>
+                                </p:cTn>
+                              </p:par>
+                            </p:childTnLst>
+                          </p:cTn>
+                        </p:par>
+                      </p:childTnLst>
+                    </p:cTn>
+                  </p:par>
+                </p:childTnLst>
+              </p:cTn>
+              <p:prevCondLst>
+                <p:cond evt="onPrev" delay="0">
+                  <p:tgtEl>
+                    <p:sldTgt/>
+                  </p:tgtEl>
+                </p:cond>
+              </p:prevCondLst>
+              <p:nextCondLst>
+                <p:cond evt="onNext" delay="0">
+                  <p:tgtEl>
+                    <p:sldTgt/>
+                  </p:tgtEl>
+                </p:cond>
+              </p:nextCondLst>
+            </p:seq>
+          </p:childTnLst>
+        </p:cTn>
+      </p:par>
+    </p:tnLst>
+  </p:timing>
+</p:sld>
+</file>
+
 <file path=ppt/slides/slide3.xml><?xml version="1.0" encoding="utf-8"?>
 <p:sld xmlns:a="http://schemas.openxmlformats.org/drawingml/2006/main" xmlns:r="http://schemas.openxmlformats.org/officeDocument/2006/relationships" xmlns:p="http://schemas.openxmlformats.org/presentationml/2006/main">
   <p:cSld>
@@ -22213,7 +21041,7 @@
         <p:spPr>
           <a:xfrm>
             <a:off x="922202" y="1736904"/>
-            <a:ext cx="9776400" cy="3971857"/>
+            <a:ext cx="9776400" cy="5175776"/>
           </a:xfrm>
           <a:prstGeom prst="rect">
             <a:avLst/>
@@ -22228,28 +21056,6 @@
             <a:spAutoFit/>
           </a:bodyPr>
           <a:lstStyle/>
-          <a:p>
-            <a:pPr marL="433260" lvl="1" indent="-216630" defTabSz="609630">
-              <a:lnSpc>
-                <a:spcPct val="140013"/>
-              </a:lnSpc>
-              <a:buClr>
-                <a:srgbClr val="12312B"/>
-              </a:buClr>
-              <a:buSzPts val="3009"/>
-              <a:buFont typeface="Archivo Medium"/>
-              <a:buChar char="•"/>
-            </a:pPr>
-            <a:endParaRPr lang="en-US" sz="2006" kern="0" dirty="0">
-              <a:solidFill>
-                <a:srgbClr val="12312B"/>
-              </a:solidFill>
-              <a:latin typeface="Archivo Medium"/>
-              <a:ea typeface="Archivo Medium"/>
-              <a:cs typeface="Archivo Medium"/>
-              <a:sym typeface="Archivo Medium"/>
-            </a:endParaRPr>
-          </a:p>
           <a:p>
             <a:pPr marL="433260" lvl="1" indent="-216630" defTabSz="609630">
               <a:lnSpc>
@@ -22267,12 +21073,15 @@
                 <a:solidFill>
                   <a:srgbClr val="12312B"/>
                 </a:solidFill>
+                <a:highlight>
+                  <a:srgbClr val="FFFF00"/>
+                </a:highlight>
                 <a:latin typeface="Archivo Medium"/>
                 <a:ea typeface="Archivo Medium"/>
                 <a:cs typeface="Archivo Medium"/>
                 <a:sym typeface="Archivo Medium"/>
               </a:rPr>
-              <a:t>Day 1</a:t>
+              <a:t>Day 1 – Monday March 23</a:t>
             </a:r>
           </a:p>
           <a:p>
@@ -22289,9 +21098,12 @@
             </a:pPr>
             <a:r>
               <a:rPr lang="en-US" sz="1600" dirty="0">
+                <a:highlight>
+                  <a:srgbClr val="FFFF00"/>
+                </a:highlight>
                 <a:sym typeface="Archivo Medium"/>
               </a:rPr>
-              <a:t>Subpoint 1</a:t>
+              <a:t>9:00 – 9:30 Introductions, orientation, &amp; setup</a:t>
             </a:r>
           </a:p>
           <a:p>
@@ -22308,9 +21120,78 @@
             </a:pPr>
             <a:r>
               <a:rPr lang="en-US" sz="1600" dirty="0">
+                <a:highlight>
+                  <a:srgbClr val="FFFF00"/>
+                </a:highlight>
                 <a:sym typeface="Archivo Medium"/>
               </a:rPr>
-              <a:t>Subpoint 2</a:t>
+              <a:t>9:30 – 10:30 Exploring your data</a:t>
+            </a:r>
+          </a:p>
+          <a:p>
+            <a:pPr marL="866521" lvl="2" indent="-288840" defTabSz="609630">
+              <a:lnSpc>
+                <a:spcPct val="140013"/>
+              </a:lnSpc>
+              <a:buClr>
+                <a:srgbClr val="12312B"/>
+              </a:buClr>
+              <a:buSzPts val="3009"/>
+              <a:buFont typeface="Archivo Medium"/>
+              <a:buChar char="⚬"/>
+            </a:pPr>
+            <a:r>
+              <a:rPr lang="en-US" sz="1600" dirty="0">
+                <a:highlight>
+                  <a:srgbClr val="FFFF00"/>
+                </a:highlight>
+                <a:sym typeface="Archivo Medium"/>
+              </a:rPr>
+              <a:t>10:30 – 10:45 Break</a:t>
+            </a:r>
+          </a:p>
+          <a:p>
+            <a:pPr marL="866521" lvl="2" indent="-288840" defTabSz="609630">
+              <a:lnSpc>
+                <a:spcPct val="140013"/>
+              </a:lnSpc>
+              <a:buClr>
+                <a:srgbClr val="12312B"/>
+              </a:buClr>
+              <a:buSzPts val="3009"/>
+              <a:buFont typeface="Archivo Medium"/>
+              <a:buChar char="⚬"/>
+            </a:pPr>
+            <a:r>
+              <a:rPr lang="en-US" sz="1600" dirty="0">
+                <a:highlight>
+                  <a:srgbClr val="FFFF00"/>
+                </a:highlight>
+                <a:sym typeface="Archivo Medium"/>
+              </a:rPr>
+              <a:t>10:45 – 12:00  Wrangling your data </a:t>
+            </a:r>
+          </a:p>
+          <a:p>
+            <a:pPr marL="866521" lvl="2" indent="-288840" defTabSz="609630">
+              <a:lnSpc>
+                <a:spcPct val="140013"/>
+              </a:lnSpc>
+              <a:buClr>
+                <a:srgbClr val="12312B"/>
+              </a:buClr>
+              <a:buSzPts val="3009"/>
+              <a:buFont typeface="Archivo Medium"/>
+              <a:buChar char="⚬"/>
+            </a:pPr>
+            <a:r>
+              <a:rPr lang="en-US" sz="1600" dirty="0">
+                <a:highlight>
+                  <a:srgbClr val="FFFF00"/>
+                </a:highlight>
+                <a:sym typeface="Archivo Medium"/>
+              </a:rPr>
+              <a:t>12:00 – 12:30 (Optional) Additional exploration, Q&amp;A,…</a:t>
             </a:r>
           </a:p>
           <a:p>
@@ -22329,6 +21210,9 @@
               <a:solidFill>
                 <a:srgbClr val="12312B"/>
               </a:solidFill>
+              <a:highlight>
+                <a:srgbClr val="FFFF00"/>
+              </a:highlight>
               <a:latin typeface="Archivo Medium"/>
               <a:ea typeface="Archivo Medium"/>
               <a:cs typeface="Archivo Medium"/>
@@ -22352,12 +21236,15 @@
                 <a:solidFill>
                   <a:srgbClr val="12312B"/>
                 </a:solidFill>
+                <a:highlight>
+                  <a:srgbClr val="FFFF00"/>
+                </a:highlight>
                 <a:latin typeface="Archivo Medium"/>
                 <a:ea typeface="Archivo Medium"/>
                 <a:cs typeface="Archivo Medium"/>
                 <a:sym typeface="Archivo Medium"/>
               </a:rPr>
-              <a:t>Day 2</a:t>
+              <a:t>Day 2 – Wednesday March 25</a:t>
             </a:r>
           </a:p>
           <a:p>
@@ -22374,9 +21261,12 @@
             </a:pPr>
             <a:r>
               <a:rPr lang="en-US" sz="1600" dirty="0">
+                <a:highlight>
+                  <a:srgbClr val="FFFF00"/>
+                </a:highlight>
                 <a:sym typeface="Archivo Medium"/>
               </a:rPr>
-              <a:t>Subpoint 1</a:t>
+              <a:t>9:00 – 9:15 Introduction to Day 2</a:t>
             </a:r>
           </a:p>
           <a:p>
@@ -22393,13 +21283,31 @@
             </a:pPr>
             <a:r>
               <a:rPr lang="en-US" sz="1600" dirty="0">
+                <a:highlight>
+                  <a:srgbClr val="FFFF00"/>
+                </a:highlight>
                 <a:sym typeface="Archivo Medium"/>
               </a:rPr>
-              <a:t>Subpoint 2</a:t>
+              <a:t>9:15 – 10:30 Building a plot in </a:t>
             </a:r>
-          </a:p>
-          <a:p>
-            <a:pPr marL="433260" lvl="1" indent="-216630" defTabSz="609630">
+            <a:r>
+              <a:rPr lang="en-US" sz="1600" dirty="0" err="1">
+                <a:highlight>
+                  <a:srgbClr val="FFFF00"/>
+                </a:highlight>
+                <a:sym typeface="Archivo Medium"/>
+              </a:rPr>
+              <a:t>ggplot</a:t>
+            </a:r>
+            <a:endParaRPr lang="en-US" sz="1600" dirty="0">
+              <a:highlight>
+                <a:srgbClr val="FFFF00"/>
+              </a:highlight>
+              <a:sym typeface="Archivo Medium"/>
+            </a:endParaRPr>
+          </a:p>
+          <a:p>
+            <a:pPr marL="866521" lvl="2" indent="-288840" defTabSz="609630">
               <a:lnSpc>
                 <a:spcPct val="140013"/>
               </a:lnSpc>
@@ -22408,20 +21316,20 @@
               </a:buClr>
               <a:buSzPts val="3009"/>
               <a:buFont typeface="Archivo Medium"/>
-              <a:buChar char="•"/>
+              <a:buChar char="⚬"/>
             </a:pPr>
-            <a:endParaRPr lang="en-US" sz="2006" kern="0" dirty="0">
-              <a:solidFill>
-                <a:srgbClr val="12312B"/>
-              </a:solidFill>
-              <a:latin typeface="Archivo Medium"/>
-              <a:ea typeface="Archivo Medium"/>
-              <a:cs typeface="Archivo Medium"/>
-              <a:sym typeface="Archivo Medium"/>
-            </a:endParaRPr>
-          </a:p>
-          <a:p>
-            <a:pPr marL="433260" lvl="1" indent="-216630" defTabSz="609630">
+            <a:r>
+              <a:rPr lang="en-US" sz="1600" dirty="0">
+                <a:highlight>
+                  <a:srgbClr val="FFFF00"/>
+                </a:highlight>
+                <a:sym typeface="Archivo Medium"/>
+              </a:rPr>
+              <a:t>10:30 – 10:45 Break</a:t>
+            </a:r>
+          </a:p>
+          <a:p>
+            <a:pPr marL="866521" lvl="2" indent="-288840" defTabSz="609630">
               <a:lnSpc>
                 <a:spcPct val="140013"/>
               </a:lnSpc>
@@ -22430,7 +21338,51 @@
               </a:buClr>
               <a:buSzPts val="3009"/>
               <a:buFont typeface="Archivo Medium"/>
-              <a:buChar char="•"/>
+              <a:buChar char="⚬"/>
+            </a:pPr>
+            <a:r>
+              <a:rPr lang="en-US" sz="1600" dirty="0">
+                <a:highlight>
+                  <a:srgbClr val="FFFF00"/>
+                </a:highlight>
+                <a:sym typeface="Archivo Medium"/>
+              </a:rPr>
+              <a:t>10:45 – 12:00 Additional visualization options and saving visualizations</a:t>
+            </a:r>
+          </a:p>
+          <a:p>
+            <a:pPr marL="866521" lvl="2" indent="-288840" defTabSz="609630">
+              <a:lnSpc>
+                <a:spcPct val="140013"/>
+              </a:lnSpc>
+              <a:buClr>
+                <a:srgbClr val="12312B"/>
+              </a:buClr>
+              <a:buSzPts val="3009"/>
+              <a:buFont typeface="Archivo Medium"/>
+              <a:buChar char="⚬"/>
+            </a:pPr>
+            <a:r>
+              <a:rPr lang="en-US" sz="1600" dirty="0">
+                <a:highlight>
+                  <a:srgbClr val="FFFF00"/>
+                </a:highlight>
+                <a:sym typeface="Archivo Medium"/>
+              </a:rPr>
+              <a:t>12:00 – 12:30 (Optional) Additional exploration, Q&amp;A,…</a:t>
+            </a:r>
+          </a:p>
+          <a:p>
+            <a:pPr marL="866521" lvl="2" indent="-288840" defTabSz="609630">
+              <a:lnSpc>
+                <a:spcPct val="140013"/>
+              </a:lnSpc>
+              <a:buClr>
+                <a:srgbClr val="12312B"/>
+              </a:buClr>
+              <a:buSzPts val="3009"/>
+              <a:buFont typeface="Archivo Medium"/>
+              <a:buChar char="⚬"/>
             </a:pPr>
             <a:endParaRPr lang="en-US" sz="2006" kern="0" dirty="0">
               <a:solidFill>
@@ -22490,38 +21442,7 @@
                                         <p:tgtEl>
                                           <p:spTgt spid="142">
                                             <p:txEl>
-                                              <p:pRg st="5" end="5"/>
-                                            </p:txEl>
-                                          </p:spTgt>
-                                        </p:tgtEl>
-                                        <p:attrNameLst>
-                                          <p:attrName>style.visibility</p:attrName>
-                                        </p:attrNameLst>
-                                      </p:cBhvr>
-                                      <p:to>
-                                        <p:strVal val="visible"/>
-                                      </p:to>
-                                    </p:set>
-                                  </p:childTnLst>
-                                </p:cTn>
-                              </p:par>
-                              <p:par>
-                                <p:cTn id="7" presetID="1" presetClass="entr" presetSubtype="0" fill="hold" nodeType="withEffect">
-                                  <p:stCondLst>
-                                    <p:cond delay="0"/>
-                                  </p:stCondLst>
-                                  <p:childTnLst>
-                                    <p:set>
-                                      <p:cBhvr>
-                                        <p:cTn id="8" dur="1" fill="hold">
-                                          <p:stCondLst>
-                                            <p:cond delay="0"/>
-                                          </p:stCondLst>
-                                        </p:cTn>
-                                        <p:tgtEl>
-                                          <p:spTgt spid="142">
-                                            <p:txEl>
-                                              <p:pRg st="6" end="6"/>
+                                              <p:pRg st="7" end="7"/>
                                             </p:txEl>
                                           </p:spTgt>
                                         </p:tgtEl>
@@ -22575,373 +21496,6 @@
         <p:cNvPr id="1" name="Shape 139">
           <a:extLst>
             <a:ext uri="{FF2B5EF4-FFF2-40B4-BE49-F238E27FC236}">
-              <a16:creationId xmlns:a16="http://schemas.microsoft.com/office/drawing/2014/main" id="{492ED415-B6B2-270C-003F-176DCDAA9815}"/>
-            </a:ext>
-          </a:extLst>
-        </p:cNvPr>
-        <p:cNvGrpSpPr/>
-        <p:nvPr/>
-      </p:nvGrpSpPr>
-      <p:grpSpPr>
-        <a:xfrm>
-          <a:off x="0" y="0"/>
-          <a:ext cx="0" cy="0"/>
-          <a:chOff x="0" y="0"/>
-          <a:chExt cx="0" cy="0"/>
-        </a:xfrm>
-      </p:grpSpPr>
-      <p:sp>
-        <p:nvSpPr>
-          <p:cNvPr id="141" name="Google Shape;141;p26">
-            <a:extLst>
-              <a:ext uri="{FF2B5EF4-FFF2-40B4-BE49-F238E27FC236}">
-                <a16:creationId xmlns:a16="http://schemas.microsoft.com/office/drawing/2014/main" id="{5EDFCD96-892A-B449-4839-26398579B5A5}"/>
-              </a:ext>
-            </a:extLst>
-          </p:cNvPr>
-          <p:cNvSpPr txBox="1"/>
-          <p:nvPr/>
-        </p:nvSpPr>
-        <p:spPr>
-          <a:xfrm>
-            <a:off x="922201" y="1157695"/>
-            <a:ext cx="8284715" cy="742383"/>
-          </a:xfrm>
-          <a:prstGeom prst="rect">
-            <a:avLst/>
-          </a:prstGeom>
-          <a:noFill/>
-          <a:ln>
-            <a:noFill/>
-          </a:ln>
-        </p:spPr>
-        <p:txBody>
-          <a:bodyPr spcFirstLastPara="1" wrap="square" lIns="0" tIns="0" rIns="0" bIns="0" anchor="t" anchorCtr="0">
-            <a:spAutoFit/>
-          </a:bodyPr>
-          <a:lstStyle/>
-          <a:p>
-            <a:pPr defTabSz="609630">
-              <a:lnSpc>
-                <a:spcPct val="140007"/>
-              </a:lnSpc>
-              <a:buClr>
-                <a:srgbClr val="000000"/>
-              </a:buClr>
-            </a:pPr>
-            <a:r>
-              <a:rPr lang="en-US" sz="3446" kern="0" dirty="0">
-                <a:solidFill>
-                  <a:srgbClr val="00693D"/>
-                </a:solidFill>
-                <a:latin typeface="Anton"/>
-                <a:ea typeface="Anton"/>
-                <a:cs typeface="Anton"/>
-                <a:sym typeface="Anton"/>
-              </a:rPr>
-              <a:t>Reproducible Research workshop series</a:t>
-            </a:r>
-            <a:endParaRPr sz="933" kern="0" dirty="0">
-              <a:solidFill>
-                <a:srgbClr val="000000"/>
-              </a:solidFill>
-              <a:latin typeface="Anton"/>
-              <a:ea typeface="Anton"/>
-              <a:cs typeface="Anton"/>
-              <a:sym typeface="Anton"/>
-            </a:endParaRPr>
-          </a:p>
-        </p:txBody>
-      </p:sp>
-      <p:sp>
-        <p:nvSpPr>
-          <p:cNvPr id="142" name="Google Shape;142;p26">
-            <a:extLst>
-              <a:ext uri="{FF2B5EF4-FFF2-40B4-BE49-F238E27FC236}">
-                <a16:creationId xmlns:a16="http://schemas.microsoft.com/office/drawing/2014/main" id="{9B72596A-D557-1CA0-4098-0B9E3210C40F}"/>
-              </a:ext>
-            </a:extLst>
-          </p:cNvPr>
-          <p:cNvSpPr txBox="1"/>
-          <p:nvPr/>
-        </p:nvSpPr>
-        <p:spPr>
-          <a:xfrm>
-            <a:off x="922201" y="1983519"/>
-            <a:ext cx="9776400" cy="3834896"/>
-          </a:xfrm>
-          <a:prstGeom prst="rect">
-            <a:avLst/>
-          </a:prstGeom>
-          <a:noFill/>
-          <a:ln>
-            <a:noFill/>
-          </a:ln>
-        </p:spPr>
-        <p:txBody>
-          <a:bodyPr spcFirstLastPara="1" wrap="square" lIns="0" tIns="0" rIns="0" bIns="0" anchor="t" anchorCtr="0">
-            <a:spAutoFit/>
-          </a:bodyPr>
-          <a:lstStyle/>
-          <a:p>
-            <a:pPr marL="433260" lvl="1" indent="-216630" defTabSz="609630">
-              <a:lnSpc>
-                <a:spcPct val="140013"/>
-              </a:lnSpc>
-              <a:buClr>
-                <a:srgbClr val="12312B"/>
-              </a:buClr>
-              <a:buSzPts val="3009"/>
-              <a:buFont typeface="Archivo Medium"/>
-              <a:buChar char="•"/>
-            </a:pPr>
-            <a:r>
-              <a:rPr lang="en-US" dirty="0">
-                <a:solidFill>
-                  <a:srgbClr val="12312B"/>
-                </a:solidFill>
-                <a:latin typeface="Archivo Medium"/>
-                <a:cs typeface="Archivo Medium"/>
-                <a:sym typeface="Archivo Medium"/>
-              </a:rPr>
-              <a:t>T</a:t>
-            </a:r>
-            <a:r>
-              <a:rPr lang="en-US" dirty="0">
-                <a:solidFill>
-                  <a:srgbClr val="12312B"/>
-                </a:solidFill>
-                <a:latin typeface="Archivo Medium"/>
-                <a:ea typeface="Archivo Medium"/>
-                <a:cs typeface="Archivo Medium"/>
-                <a:sym typeface="Archivo Medium"/>
-              </a:rPr>
-              <a:t>he </a:t>
-            </a:r>
-            <a:r>
-              <a:rPr lang="en-US" b="1" dirty="0">
-                <a:solidFill>
-                  <a:srgbClr val="12312B"/>
-                </a:solidFill>
-                <a:latin typeface="Archivo Medium"/>
-                <a:ea typeface="Archivo"/>
-                <a:cs typeface="Archivo"/>
-                <a:sym typeface="Archivo"/>
-              </a:rPr>
-              <a:t>Reproducible Research Group</a:t>
-            </a:r>
-            <a:r>
-              <a:rPr lang="en-US" dirty="0">
-                <a:solidFill>
-                  <a:srgbClr val="12312B"/>
-                </a:solidFill>
-                <a:latin typeface="Archivo Medium"/>
-                <a:ea typeface="Archivo"/>
-                <a:cs typeface="Archivo"/>
-                <a:sym typeface="Archivo"/>
-              </a:rPr>
-              <a:t>—a</a:t>
-            </a:r>
-            <a:r>
-              <a:rPr lang="en-US" dirty="0">
-                <a:latin typeface="Archivo Medium"/>
-              </a:rPr>
-              <a:t> collaboration between Dartmouth Libraries and Research Computing / ITC—of</a:t>
-            </a:r>
-            <a:r>
-              <a:rPr lang="en-US" dirty="0">
-                <a:solidFill>
-                  <a:srgbClr val="12312B"/>
-                </a:solidFill>
-                <a:latin typeface="Archivo Medium"/>
-                <a:ea typeface="Archivo Medium"/>
-                <a:cs typeface="Archivo Medium"/>
-                <a:sym typeface="Archivo Medium"/>
-              </a:rPr>
-              <a:t>fers workshops on computational and reproducible research, data science, and related fields every term. </a:t>
-            </a:r>
-            <a:endParaRPr lang="en-US" dirty="0">
-              <a:latin typeface="Archivo Medium"/>
-            </a:endParaRPr>
-          </a:p>
-          <a:p>
-            <a:pPr marL="433260" lvl="1" indent="-216630" defTabSz="609630">
-              <a:lnSpc>
-                <a:spcPct val="140013"/>
-              </a:lnSpc>
-              <a:buClr>
-                <a:srgbClr val="12312B"/>
-              </a:buClr>
-              <a:buSzPts val="3009"/>
-              <a:buFont typeface="Archivo Medium"/>
-              <a:buChar char="•"/>
-            </a:pPr>
-            <a:endParaRPr lang="en-US" dirty="0">
-              <a:latin typeface="Archivo Medium"/>
-              <a:sym typeface="Archivo Medium"/>
-            </a:endParaRPr>
-          </a:p>
-          <a:p>
-            <a:pPr marL="433260" lvl="1" indent="-216630" defTabSz="609630">
-              <a:lnSpc>
-                <a:spcPct val="140013"/>
-              </a:lnSpc>
-              <a:buClr>
-                <a:srgbClr val="12312B"/>
-              </a:buClr>
-              <a:buSzPts val="3009"/>
-              <a:buFont typeface="Archivo Medium"/>
-              <a:buChar char="•"/>
-            </a:pPr>
-            <a:r>
-              <a:rPr lang="en-US" dirty="0">
-                <a:latin typeface="Archivo Medium"/>
-              </a:rPr>
-              <a:t>The full list of upcoming workshops is available at </a:t>
-            </a:r>
-            <a:r>
-              <a:rPr lang="en-US" dirty="0">
-                <a:latin typeface="Archivo Medium"/>
-                <a:hlinkClick r:id="rId3"/>
-              </a:rPr>
-              <a:t>dartgo.org/</a:t>
-            </a:r>
-            <a:r>
-              <a:rPr lang="en-US" dirty="0" err="1">
-                <a:latin typeface="Archivo Medium"/>
-                <a:hlinkClick r:id="rId3"/>
-              </a:rPr>
-              <a:t>RRADworkshops</a:t>
-            </a:r>
-            <a:r>
-              <a:rPr lang="en-US" dirty="0">
-                <a:latin typeface="Archivo Medium"/>
-                <a:hlinkClick r:id="rId3"/>
-              </a:rPr>
-              <a:t>  </a:t>
-            </a:r>
-            <a:endParaRPr lang="en-US" dirty="0">
-              <a:latin typeface="Archivo Medium"/>
-            </a:endParaRPr>
-          </a:p>
-          <a:p>
-            <a:pPr marL="866521" lvl="2" indent="-288840" defTabSz="609630">
-              <a:lnSpc>
-                <a:spcPct val="140013"/>
-              </a:lnSpc>
-              <a:buClr>
-                <a:srgbClr val="12312B"/>
-              </a:buClr>
-              <a:buSzPts val="3009"/>
-              <a:buFont typeface="Archivo Medium"/>
-              <a:buChar char="⚬"/>
-            </a:pPr>
-            <a:r>
-              <a:rPr lang="en-US" sz="1600" dirty="0">
-                <a:sym typeface="Archivo Medium"/>
-              </a:rPr>
-              <a:t>Most are online</a:t>
-            </a:r>
-          </a:p>
-          <a:p>
-            <a:pPr marL="866521" lvl="2" indent="-288840" defTabSz="609630">
-              <a:lnSpc>
-                <a:spcPct val="140013"/>
-              </a:lnSpc>
-              <a:buClr>
-                <a:srgbClr val="12312B"/>
-              </a:buClr>
-              <a:buSzPts val="3009"/>
-              <a:buFont typeface="Archivo Medium"/>
-              <a:buChar char="⚬"/>
-            </a:pPr>
-            <a:r>
-              <a:rPr lang="en-US" sz="1600" dirty="0">
-                <a:highlight>
-                  <a:srgbClr val="FFFF00"/>
-                </a:highlight>
-                <a:sym typeface="Archivo Medium"/>
-              </a:rPr>
-              <a:t>Upcoming workshops related to today’s are listed at the end of this presentation</a:t>
-            </a:r>
-            <a:r>
-              <a:rPr lang="en-US" sz="1600" dirty="0">
-                <a:sym typeface="Archivo Medium"/>
-              </a:rPr>
-              <a:t>.</a:t>
-            </a:r>
-            <a:endParaRPr sz="1600" dirty="0">
-              <a:sym typeface="Archivo Medium"/>
-            </a:endParaRPr>
-          </a:p>
-          <a:p>
-            <a:pPr marL="866521" lvl="2" indent="-288840" defTabSz="609630">
-              <a:lnSpc>
-                <a:spcPct val="140013"/>
-              </a:lnSpc>
-              <a:buClr>
-                <a:srgbClr val="12312B"/>
-              </a:buClr>
-              <a:buSzPts val="3009"/>
-              <a:buFont typeface="Archivo Medium"/>
-              <a:buChar char="⚬"/>
-            </a:pPr>
-            <a:endParaRPr lang="en-US" sz="1600" dirty="0">
-              <a:latin typeface="Archivo Medium"/>
-            </a:endParaRPr>
-          </a:p>
-          <a:p>
-            <a:pPr marL="433260" lvl="1" indent="-216630" defTabSz="609630">
-              <a:lnSpc>
-                <a:spcPct val="140013"/>
-              </a:lnSpc>
-              <a:buClr>
-                <a:srgbClr val="12312B"/>
-              </a:buClr>
-              <a:buSzPts val="3009"/>
-              <a:buFont typeface="Archivo Medium"/>
-              <a:buChar char="•"/>
-              <a:defRPr/>
-            </a:pPr>
-            <a:r>
-              <a:rPr lang="en-US" dirty="0">
-                <a:latin typeface="Archivo Medium"/>
-              </a:rPr>
-              <a:t>If you need help with something that isn’t the subject of a workshop or need it before we’re offering the relevant workshop, please reach out!</a:t>
-            </a:r>
-            <a:endParaRPr sz="2006" kern="0" dirty="0">
-              <a:solidFill>
-                <a:srgbClr val="12312B"/>
-              </a:solidFill>
-              <a:latin typeface="Archivo Medium"/>
-              <a:ea typeface="Arial"/>
-              <a:cs typeface="Arial"/>
-              <a:sym typeface="Arial"/>
-            </a:endParaRPr>
-          </a:p>
-        </p:txBody>
-      </p:sp>
-    </p:spTree>
-    <p:extLst>
-      <p:ext uri="{BB962C8B-B14F-4D97-AF65-F5344CB8AC3E}">
-        <p14:creationId xmlns:p14="http://schemas.microsoft.com/office/powerpoint/2010/main" val="1227487870"/>
-      </p:ext>
-    </p:extLst>
-  </p:cSld>
-  <p:clrMapOvr>
-    <a:masterClrMapping/>
-  </p:clrMapOvr>
-</p:sld>
-</file>
-
-<file path=ppt/slides/slide6.xml><?xml version="1.0" encoding="utf-8"?>
-<p:sld xmlns:a="http://schemas.openxmlformats.org/drawingml/2006/main" xmlns:r="http://schemas.openxmlformats.org/officeDocument/2006/relationships" xmlns:p="http://schemas.openxmlformats.org/presentationml/2006/main">
-  <p:cSld>
-    <p:spTree>
-      <p:nvGrpSpPr>
-        <p:cNvPr id="1" name="Shape 139">
-          <a:extLst>
-            <a:ext uri="{FF2B5EF4-FFF2-40B4-BE49-F238E27FC236}">
               <a16:creationId xmlns:a16="http://schemas.microsoft.com/office/drawing/2014/main" id="{00D7AC0D-CEC3-BEEE-CE0A-3674961D0C54}"/>
             </a:ext>
           </a:extLst>
@@ -23006,12 +21560,30 @@
                 <a:cs typeface="Anton"/>
                 <a:sym typeface="Anton"/>
               </a:rPr>
-              <a:t>Hi, I’m Katie! – slide for each of us?</a:t>
+              <a:t>Hi, I’m Katie! – </a:t>
+            </a:r>
+            <a:r>
+              <a:rPr lang="en-US" sz="3446" kern="0" dirty="0">
+                <a:solidFill>
+                  <a:srgbClr val="00693D"/>
+                </a:solidFill>
+                <a:highlight>
+                  <a:srgbClr val="FFFF00"/>
+                </a:highlight>
+                <a:latin typeface="Anton"/>
+                <a:ea typeface="Anton"/>
+                <a:cs typeface="Anton"/>
+                <a:sym typeface="Anton"/>
+              </a:rPr>
+              <a:t>slide for each of us?</a:t>
             </a:r>
             <a:endParaRPr sz="933" kern="0" dirty="0">
               <a:solidFill>
                 <a:srgbClr val="000000"/>
               </a:solidFill>
+              <a:highlight>
+                <a:srgbClr val="FFFF00"/>
+              </a:highlight>
               <a:latin typeface="Anton"/>
               <a:ea typeface="Anton"/>
               <a:cs typeface="Anton"/>
@@ -23308,7 +21880,7 @@
 </p:sld>
 </file>
 
-<file path=ppt/slides/slide7.xml><?xml version="1.0" encoding="utf-8"?>
+<file path=ppt/slides/slide6.xml><?xml version="1.0" encoding="utf-8"?>
 <p:sld xmlns:a="http://schemas.openxmlformats.org/drawingml/2006/main" xmlns:r="http://schemas.openxmlformats.org/officeDocument/2006/relationships" xmlns:p="http://schemas.openxmlformats.org/presentationml/2006/main">
   <p:cSld>
     <p:spTree>
@@ -24030,7 +22602,7 @@
 </p:sld>
 </file>
 
-<file path=ppt/slides/slide8.xml><?xml version="1.0" encoding="utf-8"?>
+<file path=ppt/slides/slide7.xml><?xml version="1.0" encoding="utf-8"?>
 <p:sld xmlns:a="http://schemas.openxmlformats.org/drawingml/2006/main" xmlns:r="http://schemas.openxmlformats.org/officeDocument/2006/relationships" xmlns:p="http://schemas.openxmlformats.org/presentationml/2006/main">
   <p:cSld>
     <p:spTree>
@@ -24334,37 +22906,7 @@
                 <a:cs typeface="Archivo Medium"/>
                 <a:sym typeface="Archivo Medium"/>
               </a:rPr>
-              <a:t>THIS </a:t>
-            </a:r>
-            <a:r>
-              <a:rPr lang="en-US" sz="2006" kern="0" dirty="0" err="1">
-                <a:solidFill>
-                  <a:srgbClr val="12312B"/>
-                </a:solidFill>
-                <a:highlight>
-                  <a:srgbClr val="FFFF00"/>
-                </a:highlight>
-                <a:latin typeface="Archivo Medium"/>
-                <a:ea typeface="Archivo Medium"/>
-                <a:cs typeface="Archivo Medium"/>
-                <a:sym typeface="Archivo Medium"/>
-              </a:rPr>
-              <a:t>LOCAtiON</a:t>
-            </a:r>
-            <a:r>
-              <a:rPr lang="en-US" sz="2006" kern="0" dirty="0">
-                <a:solidFill>
-                  <a:srgbClr val="12312B"/>
-                </a:solidFill>
-                <a:highlight>
-                  <a:srgbClr val="FFFF00"/>
-                </a:highlight>
-                <a:latin typeface="Archivo Medium"/>
-                <a:ea typeface="Archivo Medium"/>
-                <a:cs typeface="Archivo Medium"/>
-                <a:sym typeface="Archivo Medium"/>
-              </a:rPr>
-              <a:t> </a:t>
+              <a:t>THIS Location </a:t>
             </a:r>
             <a:r>
               <a:rPr lang="en-US" sz="2006" kern="0" dirty="0">
@@ -24495,7 +23037,7 @@
 </p:sld>
 </file>
 
-<file path=ppt/slides/slide9.xml><?xml version="1.0" encoding="utf-8"?>
+<file path=ppt/slides/slide8.xml><?xml version="1.0" encoding="utf-8"?>
 <p:sld xmlns:a="http://schemas.openxmlformats.org/drawingml/2006/main" xmlns:r="http://schemas.openxmlformats.org/officeDocument/2006/relationships" xmlns:p="http://schemas.openxmlformats.org/presentationml/2006/main">
   <p:cSld>
     <p:spTree>
@@ -24781,6 +23323,153 @@
     <p:extLst>
       <p:ext uri="{BB962C8B-B14F-4D97-AF65-F5344CB8AC3E}">
         <p14:creationId xmlns:p14="http://schemas.microsoft.com/office/powerpoint/2010/main" val="288270584"/>
+      </p:ext>
+    </p:extLst>
+  </p:cSld>
+  <p:clrMapOvr>
+    <a:masterClrMapping/>
+  </p:clrMapOvr>
+</p:sld>
+</file>
+
+<file path=ppt/slides/slide9.xml><?xml version="1.0" encoding="utf-8"?>
+<p:sld xmlns:a="http://schemas.openxmlformats.org/drawingml/2006/main" xmlns:r="http://schemas.openxmlformats.org/officeDocument/2006/relationships" xmlns:p="http://schemas.openxmlformats.org/presentationml/2006/main">
+  <p:cSld>
+    <p:spTree>
+      <p:nvGrpSpPr>
+        <p:cNvPr id="1" name="Shape 157">
+          <a:extLst>
+            <a:ext uri="{FF2B5EF4-FFF2-40B4-BE49-F238E27FC236}">
+              <a16:creationId xmlns:a16="http://schemas.microsoft.com/office/drawing/2014/main" id="{085F6405-7F4A-13C9-ADC6-785C80561D89}"/>
+            </a:ext>
+          </a:extLst>
+        </p:cNvPr>
+        <p:cNvGrpSpPr/>
+        <p:nvPr/>
+      </p:nvGrpSpPr>
+      <p:grpSpPr>
+        <a:xfrm>
+          <a:off x="0" y="0"/>
+          <a:ext cx="0" cy="0"/>
+          <a:chOff x="0" y="0"/>
+          <a:chExt cx="0" cy="0"/>
+        </a:xfrm>
+      </p:grpSpPr>
+      <p:sp>
+        <p:nvSpPr>
+          <p:cNvPr id="158" name="Google Shape;158;p19">
+            <a:extLst>
+              <a:ext uri="{FF2B5EF4-FFF2-40B4-BE49-F238E27FC236}">
+                <a16:creationId xmlns:a16="http://schemas.microsoft.com/office/drawing/2014/main" id="{F0B4E771-CF6F-C6B2-8CF5-60A162B78732}"/>
+              </a:ext>
+            </a:extLst>
+          </p:cNvPr>
+          <p:cNvSpPr txBox="1">
+            <a:spLocks noGrp="1"/>
+          </p:cNvSpPr>
+          <p:nvPr>
+            <p:ph type="title"/>
+          </p:nvPr>
+        </p:nvSpPr>
+        <p:spPr>
+          <a:xfrm>
+            <a:off x="2329800" y="1709750"/>
+            <a:ext cx="9017400" cy="2852700"/>
+          </a:xfrm>
+          <a:prstGeom prst="rect">
+            <a:avLst/>
+          </a:prstGeom>
+          <a:noFill/>
+          <a:ln>
+            <a:noFill/>
+          </a:ln>
+        </p:spPr>
+        <p:txBody>
+          <a:bodyPr spcFirstLastPara="1" wrap="square" lIns="91425" tIns="45700" rIns="91425" bIns="45700" anchor="b" anchorCtr="0">
+            <a:noAutofit/>
+          </a:bodyPr>
+          <a:lstStyle/>
+          <a:p>
+            <a:pPr marL="0" lvl="0" indent="0" algn="l" rtl="0">
+              <a:lnSpc>
+                <a:spcPct val="90000"/>
+              </a:lnSpc>
+              <a:spcBef>
+                <a:spcPts val="0"/>
+              </a:spcBef>
+              <a:spcAft>
+                <a:spcPts val="0"/>
+              </a:spcAft>
+              <a:buClr>
+                <a:schemeClr val="dk1"/>
+              </a:buClr>
+              <a:buSzPts val="6000"/>
+              <a:buFont typeface="Arial"/>
+              <a:buNone/>
+            </a:pPr>
+            <a:r>
+              <a:rPr lang="en-US" b="0" dirty="0"/>
+              <a:t>Let’s get started!</a:t>
+            </a:r>
+            <a:endParaRPr b="0" dirty="0"/>
+          </a:p>
+        </p:txBody>
+      </p:sp>
+      <p:sp>
+        <p:nvSpPr>
+          <p:cNvPr id="2" name="TextBox 1">
+            <a:extLst>
+              <a:ext uri="{FF2B5EF4-FFF2-40B4-BE49-F238E27FC236}">
+                <a16:creationId xmlns:a16="http://schemas.microsoft.com/office/drawing/2014/main" id="{C666E518-A04F-6DE0-C306-91FE81E92306}"/>
+              </a:ext>
+            </a:extLst>
+          </p:cNvPr>
+          <p:cNvSpPr txBox="1"/>
+          <p:nvPr/>
+        </p:nvSpPr>
+        <p:spPr>
+          <a:xfrm>
+            <a:off x="3315767" y="5078064"/>
+            <a:ext cx="4242987" cy="369332"/>
+          </a:xfrm>
+          <a:prstGeom prst="rect">
+            <a:avLst/>
+          </a:prstGeom>
+          <a:noFill/>
+        </p:spPr>
+        <p:txBody>
+          <a:bodyPr wrap="square" rtlCol="0">
+            <a:spAutoFit/>
+          </a:bodyPr>
+          <a:lstStyle/>
+          <a:p>
+            <a:r>
+              <a:rPr lang="en-US" dirty="0"/>
+              <a:t>Download the data from: </a:t>
+            </a:r>
+            <a:r>
+              <a:rPr lang="en-US" dirty="0" err="1">
+                <a:highlight>
+                  <a:srgbClr val="FFFF00"/>
+                </a:highlight>
+              </a:rPr>
+              <a:t>dartgo</a:t>
+            </a:r>
+            <a:r>
+              <a:rPr lang="en-US" dirty="0">
+                <a:highlight>
+                  <a:srgbClr val="FFFF00"/>
+                </a:highlight>
+              </a:rPr>
+              <a:t> link</a:t>
+            </a:r>
+          </a:p>
+        </p:txBody>
+      </p:sp>
+    </p:spTree>
+    <p:extLst>
+      <p:ext uri="{BB962C8B-B14F-4D97-AF65-F5344CB8AC3E}">
+        <p14:creationId xmlns:p14="http://schemas.microsoft.com/office/powerpoint/2010/main" val="3846199407"/>
       </p:ext>
     </p:extLst>
   </p:cSld>

</xml_diff>

<commit_message>
EDA updates and folder cleanup
</commit_message>
<xml_diff>
--- a/slides/R_Data_Wrangling_and_Visualization.pptx
+++ b/slides/R_Data_Wrangling_and_Visualization.pptx
@@ -140,7 +140,7 @@
 <file path=ppt/revisionInfo.xml><?xml version="1.0" encoding="utf-8"?>
 <p1510:revInfo xmlns:a="http://schemas.openxmlformats.org/drawingml/2006/main" xmlns:r="http://schemas.openxmlformats.org/officeDocument/2006/relationships" xmlns:p1510="http://schemas.microsoft.com/office/powerpoint/2015/10/main">
   <p1510:revLst>
-    <p1510:client id="{F35A9B08-6B64-4261-AD91-5F59BA8C75C2}" v="1387" dt="2026-03-17T18:35:30.164"/>
+    <p1510:client id="{F35A9B08-6B64-4261-AD91-5F59BA8C75C2}" v="1390" dt="2026-03-18T17:22:36.310"/>
   </p1510:revLst>
 </p1510:revInfo>
 </file>
@@ -150,7 +150,7 @@
   <pc:docChgLst>
     <pc:chgData name="Katie Owers Bonner" userId="031be739-2ca3-49bb-9134-32c5274b029d" providerId="ADAL" clId="{A2AFF3C0-B35D-4D35-896C-645D8DA4EEB0}"/>
     <pc:docChg chg="undo custSel addSld delSld modSld sldOrd">
-      <pc:chgData name="Katie Owers Bonner" userId="031be739-2ca3-49bb-9134-32c5274b029d" providerId="ADAL" clId="{A2AFF3C0-B35D-4D35-896C-645D8DA4EEB0}" dt="2026-03-17T18:35:30.164" v="2053" actId="313"/>
+      <pc:chgData name="Katie Owers Bonner" userId="031be739-2ca3-49bb-9134-32c5274b029d" providerId="ADAL" clId="{A2AFF3C0-B35D-4D35-896C-645D8DA4EEB0}" dt="2026-03-18T17:34:47.293" v="2088" actId="20577"/>
       <pc:docMkLst>
         <pc:docMk/>
       </pc:docMkLst>
@@ -192,7 +192,7 @@
         </pc:spChg>
       </pc:sldChg>
       <pc:sldChg chg="modSp mod ord">
-        <pc:chgData name="Katie Owers Bonner" userId="031be739-2ca3-49bb-9134-32c5274b029d" providerId="ADAL" clId="{A2AFF3C0-B35D-4D35-896C-645D8DA4EEB0}" dt="2026-03-17T18:17:04.777" v="1587"/>
+        <pc:chgData name="Katie Owers Bonner" userId="031be739-2ca3-49bb-9134-32c5274b029d" providerId="ADAL" clId="{A2AFF3C0-B35D-4D35-896C-645D8DA4EEB0}" dt="2026-03-18T17:34:47.293" v="2088" actId="20577"/>
         <pc:sldMkLst>
           <pc:docMk/>
           <pc:sldMk cId="4126705857" sldId="272"/>
@@ -206,7 +206,7 @@
           </ac:spMkLst>
         </pc:spChg>
         <pc:spChg chg="mod">
-          <ac:chgData name="Katie Owers Bonner" userId="031be739-2ca3-49bb-9134-32c5274b029d" providerId="ADAL" clId="{A2AFF3C0-B35D-4D35-896C-645D8DA4EEB0}" dt="2026-03-17T17:52:35.076" v="573" actId="13926"/>
+          <ac:chgData name="Katie Owers Bonner" userId="031be739-2ca3-49bb-9134-32c5274b029d" providerId="ADAL" clId="{A2AFF3C0-B35D-4D35-896C-645D8DA4EEB0}" dt="2026-03-18T17:34:47.293" v="2088" actId="20577"/>
           <ac:spMkLst>
             <pc:docMk/>
             <pc:sldMk cId="4126705857" sldId="272"/>
@@ -243,8 +243,8 @@
           <pc:sldMk cId="536404643" sldId="296"/>
         </pc:sldMkLst>
       </pc:sldChg>
-      <pc:sldChg chg="addSp delSp modSp mod">
-        <pc:chgData name="Katie Owers Bonner" userId="031be739-2ca3-49bb-9134-32c5274b029d" providerId="ADAL" clId="{A2AFF3C0-B35D-4D35-896C-645D8DA4EEB0}" dt="2026-03-17T18:16:18.611" v="1585" actId="403"/>
+      <pc:sldChg chg="addSp delSp modSp mod modNotesTx">
+        <pc:chgData name="Katie Owers Bonner" userId="031be739-2ca3-49bb-9134-32c5274b029d" providerId="ADAL" clId="{A2AFF3C0-B35D-4D35-896C-645D8DA4EEB0}" dt="2026-03-18T17:05:03.213" v="2054" actId="20577"/>
         <pc:sldMkLst>
           <pc:docMk/>
           <pc:sldMk cId="0" sldId="299"/>
@@ -290,13 +290,13 @@
         </pc:sldMkLst>
       </pc:sldChg>
       <pc:sldChg chg="addSp modSp mod modNotesTx">
-        <pc:chgData name="Katie Owers Bonner" userId="031be739-2ca3-49bb-9134-32c5274b029d" providerId="ADAL" clId="{A2AFF3C0-B35D-4D35-896C-645D8DA4EEB0}" dt="2026-03-17T18:12:46.612" v="1583" actId="20577"/>
+        <pc:chgData name="Katie Owers Bonner" userId="031be739-2ca3-49bb-9134-32c5274b029d" providerId="ADAL" clId="{A2AFF3C0-B35D-4D35-896C-645D8DA4EEB0}" dt="2026-03-18T17:15:49.961" v="2083" actId="1076"/>
         <pc:sldMkLst>
           <pc:docMk/>
           <pc:sldMk cId="3846199407" sldId="321"/>
         </pc:sldMkLst>
         <pc:spChg chg="add mod">
-          <ac:chgData name="Katie Owers Bonner" userId="031be739-2ca3-49bb-9134-32c5274b029d" providerId="ADAL" clId="{A2AFF3C0-B35D-4D35-896C-645D8DA4EEB0}" dt="2026-03-17T18:12:28.302" v="1582" actId="1076"/>
+          <ac:chgData name="Katie Owers Bonner" userId="031be739-2ca3-49bb-9134-32c5274b029d" providerId="ADAL" clId="{A2AFF3C0-B35D-4D35-896C-645D8DA4EEB0}" dt="2026-03-18T17:15:49.961" v="2083" actId="1076"/>
           <ac:spMkLst>
             <pc:docMk/>
             <pc:sldMk cId="3846199407" sldId="321"/>
@@ -317,6 +317,20 @@
         <pc:sldMkLst>
           <pc:docMk/>
           <pc:sldMk cId="2972185394" sldId="322"/>
+        </pc:sldMkLst>
+      </pc:sldChg>
+      <pc:sldChg chg="modNotesTx">
+        <pc:chgData name="Katie Owers Bonner" userId="031be739-2ca3-49bb-9134-32c5274b029d" providerId="ADAL" clId="{A2AFF3C0-B35D-4D35-896C-645D8DA4EEB0}" dt="2026-03-18T17:05:21.269" v="2056" actId="20577"/>
+        <pc:sldMkLst>
+          <pc:docMk/>
+          <pc:sldMk cId="1188028618" sldId="325"/>
+        </pc:sldMkLst>
+      </pc:sldChg>
+      <pc:sldChg chg="modNotesTx">
+        <pc:chgData name="Katie Owers Bonner" userId="031be739-2ca3-49bb-9134-32c5274b029d" providerId="ADAL" clId="{A2AFF3C0-B35D-4D35-896C-645D8DA4EEB0}" dt="2026-03-18T17:05:17.283" v="2055" actId="20577"/>
+        <pc:sldMkLst>
+          <pc:docMk/>
+          <pc:sldMk cId="3215979294" sldId="368"/>
         </pc:sldMkLst>
       </pc:sldChg>
       <pc:sldChg chg="modSp mod ord">
@@ -350,7 +364,7 @@
         </pc:spChg>
       </pc:sldChg>
       <pc:sldChg chg="modSp add mod ord modAnim">
-        <pc:chgData name="Katie Owers Bonner" userId="031be739-2ca3-49bb-9134-32c5274b029d" providerId="ADAL" clId="{A2AFF3C0-B35D-4D35-896C-645D8DA4EEB0}" dt="2026-03-17T18:35:02.394" v="2051" actId="6549"/>
+        <pc:chgData name="Katie Owers Bonner" userId="031be739-2ca3-49bb-9134-32c5274b029d" providerId="ADAL" clId="{A2AFF3C0-B35D-4D35-896C-645D8DA4EEB0}" dt="2026-03-18T17:22:36.310" v="2085" actId="6549"/>
         <pc:sldMkLst>
           <pc:docMk/>
           <pc:sldMk cId="2108451283" sldId="374"/>
@@ -364,7 +378,7 @@
           </ac:spMkLst>
         </pc:spChg>
         <pc:spChg chg="mod">
-          <ac:chgData name="Katie Owers Bonner" userId="031be739-2ca3-49bb-9134-32c5274b029d" providerId="ADAL" clId="{A2AFF3C0-B35D-4D35-896C-645D8DA4EEB0}" dt="2026-03-17T18:35:02.394" v="2051" actId="6549"/>
+          <ac:chgData name="Katie Owers Bonner" userId="031be739-2ca3-49bb-9134-32c5274b029d" providerId="ADAL" clId="{A2AFF3C0-B35D-4D35-896C-645D8DA4EEB0}" dt="2026-03-18T17:22:36.310" v="2085" actId="6549"/>
           <ac:spMkLst>
             <pc:docMk/>
             <pc:sldMk cId="2108451283" sldId="374"/>
@@ -565,7 +579,7 @@
           <a:p>
             <a:fld id="{F19BCB6A-05C9-45C4-8C56-4DA0982723A6}" type="datetimeFigureOut">
               <a:rPr lang="en-US" smtClean="0"/>
-              <a:t>3/17/2026</a:t>
+              <a:t>3/18/2026</a:t>
             </a:fld>
             <a:endParaRPr lang="en-US"/>
           </a:p>
@@ -874,37 +888,6 @@
           </a:bodyPr>
           <a:lstStyle/>
           <a:p>
-            <a:pPr marL="0" marR="0" lvl="0" indent="0" algn="l" defTabSz="914400" rtl="0" eaLnBrk="1" fontAlgn="auto" latinLnBrk="0" hangingPunct="1">
-              <a:lnSpc>
-                <a:spcPct val="100000"/>
-              </a:lnSpc>
-              <a:spcBef>
-                <a:spcPts val="0"/>
-              </a:spcBef>
-              <a:spcAft>
-                <a:spcPts val="0"/>
-              </a:spcAft>
-              <a:buClrTx/>
-              <a:buSzTx/>
-              <a:buFontTx/>
-              <a:buNone/>
-              <a:tabLst/>
-              <a:defRPr/>
-            </a:pPr>
-            <a:r>
-              <a:rPr lang="en-US" sz="1200" b="0" i="0" kern="1200" dirty="0">
-                <a:solidFill>
-                  <a:schemeClr val="tx1"/>
-                </a:solidFill>
-                <a:effectLst/>
-                <a:latin typeface="+mn-lt"/>
-                <a:ea typeface="+mn-ea"/>
-                <a:cs typeface="+mn-cs"/>
-              </a:rPr>
-              <a:t>While people are joining - put something you're looking forward to this month in the chat!</a:t>
-            </a:r>
-          </a:p>
-          <a:p>
             <a:pPr marL="0" lvl="0" indent="0" algn="l" rtl="0">
               <a:spcBef>
                 <a:spcPts val="0"/>
@@ -1642,10 +1625,6 @@
               </a:spcAft>
               <a:buNone/>
             </a:pPr>
-            <a:r>
-              <a:rPr lang="en-US" dirty="0"/>
-              <a:t>Note this flow is specific to the data aspects of a project and does not include critical steps like literature review and hypothesis formulation.</a:t>
-            </a:r>
             <a:endParaRPr dirty="0"/>
           </a:p>
         </p:txBody>
@@ -1775,7 +1754,7 @@
             </a:pPr>
             <a:r>
               <a:rPr lang="en-US" dirty="0"/>
-              <a:t>Note this flow is specific to the data aspects of a project and does not include critical steps like literature review and hypothesis formulation.</a:t>
+              <a:t>\</a:t>
             </a:r>
             <a:endParaRPr dirty="0"/>
           </a:p>
@@ -20838,7 +20817,7 @@
                   <a:srgbClr val="FFFF00"/>
                 </a:highlight>
               </a:rPr>
-              <a:t>create a variety of more sophisticated visualizations using </a:t>
+              <a:t>Create a variety of visualizations using </a:t>
             </a:r>
             <a:r>
               <a:rPr lang="en-US" sz="2000" dirty="0" err="1">
@@ -21041,7 +21020,7 @@
         <p:spPr>
           <a:xfrm>
             <a:off x="922202" y="1736904"/>
-            <a:ext cx="9776400" cy="5175776"/>
+            <a:ext cx="9776400" cy="4743606"/>
           </a:xfrm>
           <a:prstGeom prst="rect">
             <a:avLst/>
@@ -21073,9 +21052,6 @@
                 <a:solidFill>
                   <a:srgbClr val="12312B"/>
                 </a:solidFill>
-                <a:highlight>
-                  <a:srgbClr val="FFFF00"/>
-                </a:highlight>
                 <a:latin typeface="Archivo Medium"/>
                 <a:ea typeface="Archivo Medium"/>
                 <a:cs typeface="Archivo Medium"/>
@@ -21098,9 +21074,6 @@
             </a:pPr>
             <a:r>
               <a:rPr lang="en-US" sz="1600" dirty="0">
-                <a:highlight>
-                  <a:srgbClr val="FFFF00"/>
-                </a:highlight>
                 <a:sym typeface="Archivo Medium"/>
               </a:rPr>
               <a:t>9:00 – 9:30 Introductions, orientation, &amp; setup</a:t>
@@ -21120,9 +21093,6 @@
             </a:pPr>
             <a:r>
               <a:rPr lang="en-US" sz="1600" dirty="0">
-                <a:highlight>
-                  <a:srgbClr val="FFFF00"/>
-                </a:highlight>
                 <a:sym typeface="Archivo Medium"/>
               </a:rPr>
               <a:t>9:30 – 10:30 Exploring your data</a:t>
@@ -21142,9 +21112,6 @@
             </a:pPr>
             <a:r>
               <a:rPr lang="en-US" sz="1600" dirty="0">
-                <a:highlight>
-                  <a:srgbClr val="FFFF00"/>
-                </a:highlight>
                 <a:sym typeface="Archivo Medium"/>
               </a:rPr>
               <a:t>10:30 – 10:45 Break</a:t>
@@ -21164,9 +21131,6 @@
             </a:pPr>
             <a:r>
               <a:rPr lang="en-US" sz="1600" dirty="0">
-                <a:highlight>
-                  <a:srgbClr val="FFFF00"/>
-                </a:highlight>
                 <a:sym typeface="Archivo Medium"/>
               </a:rPr>
               <a:t>10:45 – 12:00  Wrangling your data </a:t>
@@ -21186,9 +21150,6 @@
             </a:pPr>
             <a:r>
               <a:rPr lang="en-US" sz="1600" dirty="0">
-                <a:highlight>
-                  <a:srgbClr val="FFFF00"/>
-                </a:highlight>
                 <a:sym typeface="Archivo Medium"/>
               </a:rPr>
               <a:t>12:00 – 12:30 (Optional) Additional exploration, Q&amp;A,…</a:t>
@@ -21210,9 +21171,6 @@
               <a:solidFill>
                 <a:srgbClr val="12312B"/>
               </a:solidFill>
-              <a:highlight>
-                <a:srgbClr val="FFFF00"/>
-              </a:highlight>
               <a:latin typeface="Archivo Medium"/>
               <a:ea typeface="Archivo Medium"/>
               <a:cs typeface="Archivo Medium"/>
@@ -21236,9 +21194,6 @@
                 <a:solidFill>
                   <a:srgbClr val="12312B"/>
                 </a:solidFill>
-                <a:highlight>
-                  <a:srgbClr val="FFFF00"/>
-                </a:highlight>
                 <a:latin typeface="Archivo Medium"/>
                 <a:ea typeface="Archivo Medium"/>
                 <a:cs typeface="Archivo Medium"/>
@@ -21261,9 +21216,6 @@
             </a:pPr>
             <a:r>
               <a:rPr lang="en-US" sz="1600" dirty="0">
-                <a:highlight>
-                  <a:srgbClr val="FFFF00"/>
-                </a:highlight>
                 <a:sym typeface="Archivo Medium"/>
               </a:rPr>
               <a:t>9:00 – 9:15 Introduction to Day 2</a:t>
@@ -21283,26 +21235,17 @@
             </a:pPr>
             <a:r>
               <a:rPr lang="en-US" sz="1600" dirty="0">
-                <a:highlight>
-                  <a:srgbClr val="FFFF00"/>
-                </a:highlight>
                 <a:sym typeface="Archivo Medium"/>
               </a:rPr>
               <a:t>9:15 – 10:30 Building a plot in </a:t>
             </a:r>
             <a:r>
               <a:rPr lang="en-US" sz="1600" dirty="0" err="1">
-                <a:highlight>
-                  <a:srgbClr val="FFFF00"/>
-                </a:highlight>
                 <a:sym typeface="Archivo Medium"/>
               </a:rPr>
               <a:t>ggplot</a:t>
             </a:r>
             <a:endParaRPr lang="en-US" sz="1600" dirty="0">
-              <a:highlight>
-                <a:srgbClr val="FFFF00"/>
-              </a:highlight>
               <a:sym typeface="Archivo Medium"/>
             </a:endParaRPr>
           </a:p>
@@ -21320,9 +21263,6 @@
             </a:pPr>
             <a:r>
               <a:rPr lang="en-US" sz="1600" dirty="0">
-                <a:highlight>
-                  <a:srgbClr val="FFFF00"/>
-                </a:highlight>
                 <a:sym typeface="Archivo Medium"/>
               </a:rPr>
               <a:t>10:30 – 10:45 Break</a:t>
@@ -21342,9 +21282,6 @@
             </a:pPr>
             <a:r>
               <a:rPr lang="en-US" sz="1600" dirty="0">
-                <a:highlight>
-                  <a:srgbClr val="FFFF00"/>
-                </a:highlight>
                 <a:sym typeface="Archivo Medium"/>
               </a:rPr>
               <a:t>10:45 – 12:00 Additional visualization options and saving visualizations</a:t>
@@ -21364,26 +21301,10 @@
             </a:pPr>
             <a:r>
               <a:rPr lang="en-US" sz="1600" dirty="0">
-                <a:highlight>
-                  <a:srgbClr val="FFFF00"/>
-                </a:highlight>
                 <a:sym typeface="Archivo Medium"/>
               </a:rPr>
               <a:t>12:00 – 12:30 (Optional) Additional exploration, Q&amp;A,…</a:t>
             </a:r>
-          </a:p>
-          <a:p>
-            <a:pPr marL="866521" lvl="2" indent="-288840" defTabSz="609630">
-              <a:lnSpc>
-                <a:spcPct val="140013"/>
-              </a:lnSpc>
-              <a:buClr>
-                <a:srgbClr val="12312B"/>
-              </a:buClr>
-              <a:buSzPts val="3009"/>
-              <a:buFont typeface="Archivo Medium"/>
-              <a:buChar char="⚬"/>
-            </a:pPr>
             <a:endParaRPr lang="en-US" sz="2006" kern="0" dirty="0">
               <a:solidFill>
                 <a:srgbClr val="12312B"/>
@@ -23429,8 +23350,8 @@
         </p:nvSpPr>
         <p:spPr>
           <a:xfrm>
-            <a:off x="3315767" y="5078064"/>
-            <a:ext cx="4242987" cy="369332"/>
+            <a:off x="2329800" y="5031062"/>
+            <a:ext cx="6016240" cy="369332"/>
           </a:xfrm>
           <a:prstGeom prst="rect">
             <a:avLst/>
@@ -23448,21 +23369,12 @@
               <a:t>Download the data from: </a:t>
             </a:r>
             <a:r>
-              <a:rPr lang="en-US" dirty="0" err="1">
-                <a:highlight>
-                  <a:srgbClr val="FFFF00"/>
-                </a:highlight>
+              <a:rPr lang="en-US" dirty="0">
+                <a:hlinkClick r:id="rId3"/>
               </a:rPr>
-              <a:t>dartgo</a:t>
+              <a:t>dartgo.org/sp26_r-workshop</a:t>
             </a:r>
-            <a:r>
-              <a:rPr lang="en-US" dirty="0">
-                <a:highlight>
-                  <a:srgbClr val="FFFF00"/>
-                </a:highlight>
-              </a:rPr>
-              <a:t> link</a:t>
-            </a:r>
+            <a:endParaRPr lang="en-US" dirty="0"/>
           </a:p>
         </p:txBody>
       </p:sp>

</xml_diff>